<commit_message>
added more concepts to draw.io files
</commit_message>
<xml_diff>
--- a/deep_on_inference.pptx
+++ b/deep_on_inference.pptx
@@ -5,7 +5,7 @@
     <p:sldMasterId id="2147483648" r:id="rId1"/>
   </p:sldMasterIdLst>
   <p:notesMasterIdLst>
-    <p:notesMasterId r:id="rId11"/>
+    <p:notesMasterId r:id="rId15"/>
   </p:notesMasterIdLst>
   <p:sldIdLst>
     <p:sldId id="256" r:id="rId2"/>
@@ -17,6 +17,10 @@
     <p:sldId id="261" r:id="rId8"/>
     <p:sldId id="262" r:id="rId9"/>
     <p:sldId id="263" r:id="rId10"/>
+    <p:sldId id="265" r:id="rId11"/>
+    <p:sldId id="266" r:id="rId12"/>
+    <p:sldId id="267" r:id="rId13"/>
+    <p:sldId id="268" r:id="rId14"/>
   </p:sldIdLst>
   <p:sldSz cx="12192000" cy="6858000"/>
   <p:notesSz cx="6858000" cy="9144000"/>
@@ -552,6 +556,222 @@
 </p:notes>
 </file>
 
+<file path=ppt/notesSlides/notesSlide10.xml><?xml version="1.0" encoding="utf-8"?>
+<p:notes xmlns:a="http://schemas.openxmlformats.org/drawingml/2006/main" xmlns:r="http://schemas.openxmlformats.org/officeDocument/2006/relationships" xmlns:p="http://schemas.openxmlformats.org/presentationml/2006/main">
+  <p:cSld>
+    <p:spTree>
+      <p:nvGrpSpPr>
+        <p:cNvPr id="1" name="">
+          <a:extLst>
+            <a:ext uri="{FF2B5EF4-FFF2-40B4-BE49-F238E27FC236}">
+              <a16:creationId xmlns:a16="http://schemas.microsoft.com/office/drawing/2014/main" id="{EA1E683F-D896-230F-9884-00E8CB4690F1}"/>
+            </a:ext>
+          </a:extLst>
+        </p:cNvPr>
+        <p:cNvGrpSpPr/>
+        <p:nvPr/>
+      </p:nvGrpSpPr>
+      <p:grpSpPr>
+        <a:xfrm>
+          <a:off x="0" y="0"/>
+          <a:ext cx="0" cy="0"/>
+          <a:chOff x="0" y="0"/>
+          <a:chExt cx="0" cy="0"/>
+        </a:xfrm>
+      </p:grpSpPr>
+      <p:sp>
+        <p:nvSpPr>
+          <p:cNvPr id="2" name="Slide Image Placeholder 1">
+            <a:extLst>
+              <a:ext uri="{FF2B5EF4-FFF2-40B4-BE49-F238E27FC236}">
+                <a16:creationId xmlns:a16="http://schemas.microsoft.com/office/drawing/2014/main" id="{02691DFD-A6FF-4539-0599-A427283C2539}"/>
+              </a:ext>
+            </a:extLst>
+          </p:cNvPr>
+          <p:cNvSpPr>
+            <a:spLocks noGrp="1" noRot="1" noChangeAspect="1"/>
+          </p:cNvSpPr>
+          <p:nvPr>
+            <p:ph type="sldImg"/>
+          </p:nvPr>
+        </p:nvSpPr>
+        <p:spPr/>
+      </p:sp>
+      <p:sp>
+        <p:nvSpPr>
+          <p:cNvPr id="3" name="Notes Placeholder 2">
+            <a:extLst>
+              <a:ext uri="{FF2B5EF4-FFF2-40B4-BE49-F238E27FC236}">
+                <a16:creationId xmlns:a16="http://schemas.microsoft.com/office/drawing/2014/main" id="{A64E8A66-F401-F05D-8011-89C5467F9158}"/>
+              </a:ext>
+            </a:extLst>
+          </p:cNvPr>
+          <p:cNvSpPr>
+            <a:spLocks noGrp="1"/>
+          </p:cNvSpPr>
+          <p:nvPr>
+            <p:ph type="body" idx="1"/>
+          </p:nvPr>
+        </p:nvSpPr>
+        <p:spPr/>
+        <p:txBody>
+          <a:bodyPr/>
+          <a:lstStyle/>
+          <a:p>
+            <a:endParaRPr lang="en-US" dirty="0"/>
+          </a:p>
+        </p:txBody>
+      </p:sp>
+      <p:sp>
+        <p:nvSpPr>
+          <p:cNvPr id="4" name="Slide Number Placeholder 3">
+            <a:extLst>
+              <a:ext uri="{FF2B5EF4-FFF2-40B4-BE49-F238E27FC236}">
+                <a16:creationId xmlns:a16="http://schemas.microsoft.com/office/drawing/2014/main" id="{C39A53DB-91F3-19EF-6FAC-8197DA48D23E}"/>
+              </a:ext>
+            </a:extLst>
+          </p:cNvPr>
+          <p:cNvSpPr>
+            <a:spLocks noGrp="1"/>
+          </p:cNvSpPr>
+          <p:nvPr>
+            <p:ph type="sldNum" sz="quarter" idx="5"/>
+          </p:nvPr>
+        </p:nvSpPr>
+        <p:spPr/>
+        <p:txBody>
+          <a:bodyPr/>
+          <a:lstStyle/>
+          <a:p>
+            <a:fld id="{EC94FF2E-E923-D04D-A47F-B6EB8146CC33}" type="slidenum">
+              <a:rPr lang="en-US" smtClean="0"/>
+              <a:t>12</a:t>
+            </a:fld>
+            <a:endParaRPr lang="en-US"/>
+          </a:p>
+        </p:txBody>
+      </p:sp>
+    </p:spTree>
+    <p:extLst>
+      <p:ext uri="{BB962C8B-B14F-4D97-AF65-F5344CB8AC3E}">
+        <p14:creationId xmlns:p14="http://schemas.microsoft.com/office/powerpoint/2010/main" val="3663337534"/>
+      </p:ext>
+    </p:extLst>
+  </p:cSld>
+  <p:clrMapOvr>
+    <a:masterClrMapping/>
+  </p:clrMapOvr>
+</p:notes>
+</file>
+
+<file path=ppt/notesSlides/notesSlide11.xml><?xml version="1.0" encoding="utf-8"?>
+<p:notes xmlns:a="http://schemas.openxmlformats.org/drawingml/2006/main" xmlns:r="http://schemas.openxmlformats.org/officeDocument/2006/relationships" xmlns:p="http://schemas.openxmlformats.org/presentationml/2006/main">
+  <p:cSld>
+    <p:spTree>
+      <p:nvGrpSpPr>
+        <p:cNvPr id="1" name="">
+          <a:extLst>
+            <a:ext uri="{FF2B5EF4-FFF2-40B4-BE49-F238E27FC236}">
+              <a16:creationId xmlns:a16="http://schemas.microsoft.com/office/drawing/2014/main" id="{94378374-19AD-A049-21A9-B7A72EE5CBAC}"/>
+            </a:ext>
+          </a:extLst>
+        </p:cNvPr>
+        <p:cNvGrpSpPr/>
+        <p:nvPr/>
+      </p:nvGrpSpPr>
+      <p:grpSpPr>
+        <a:xfrm>
+          <a:off x="0" y="0"/>
+          <a:ext cx="0" cy="0"/>
+          <a:chOff x="0" y="0"/>
+          <a:chExt cx="0" cy="0"/>
+        </a:xfrm>
+      </p:grpSpPr>
+      <p:sp>
+        <p:nvSpPr>
+          <p:cNvPr id="2" name="Slide Image Placeholder 1">
+            <a:extLst>
+              <a:ext uri="{FF2B5EF4-FFF2-40B4-BE49-F238E27FC236}">
+                <a16:creationId xmlns:a16="http://schemas.microsoft.com/office/drawing/2014/main" id="{BBD4E75D-5E92-B783-8AA8-67AC8EFD2CE9}"/>
+              </a:ext>
+            </a:extLst>
+          </p:cNvPr>
+          <p:cNvSpPr>
+            <a:spLocks noGrp="1" noRot="1" noChangeAspect="1"/>
+          </p:cNvSpPr>
+          <p:nvPr>
+            <p:ph type="sldImg"/>
+          </p:nvPr>
+        </p:nvSpPr>
+        <p:spPr/>
+      </p:sp>
+      <p:sp>
+        <p:nvSpPr>
+          <p:cNvPr id="3" name="Notes Placeholder 2">
+            <a:extLst>
+              <a:ext uri="{FF2B5EF4-FFF2-40B4-BE49-F238E27FC236}">
+                <a16:creationId xmlns:a16="http://schemas.microsoft.com/office/drawing/2014/main" id="{038D340C-9066-6336-09B5-194E37B70491}"/>
+              </a:ext>
+            </a:extLst>
+          </p:cNvPr>
+          <p:cNvSpPr>
+            <a:spLocks noGrp="1"/>
+          </p:cNvSpPr>
+          <p:nvPr>
+            <p:ph type="body" idx="1"/>
+          </p:nvPr>
+        </p:nvSpPr>
+        <p:spPr/>
+        <p:txBody>
+          <a:bodyPr/>
+          <a:lstStyle/>
+          <a:p>
+            <a:endParaRPr lang="en-US" dirty="0"/>
+          </a:p>
+        </p:txBody>
+      </p:sp>
+      <p:sp>
+        <p:nvSpPr>
+          <p:cNvPr id="4" name="Slide Number Placeholder 3">
+            <a:extLst>
+              <a:ext uri="{FF2B5EF4-FFF2-40B4-BE49-F238E27FC236}">
+                <a16:creationId xmlns:a16="http://schemas.microsoft.com/office/drawing/2014/main" id="{DD66F22E-B861-4BBF-6A46-11F924806C0D}"/>
+              </a:ext>
+            </a:extLst>
+          </p:cNvPr>
+          <p:cNvSpPr>
+            <a:spLocks noGrp="1"/>
+          </p:cNvSpPr>
+          <p:nvPr>
+            <p:ph type="sldNum" sz="quarter" idx="5"/>
+          </p:nvPr>
+        </p:nvSpPr>
+        <p:spPr/>
+        <p:txBody>
+          <a:bodyPr/>
+          <a:lstStyle/>
+          <a:p>
+            <a:fld id="{EC94FF2E-E923-D04D-A47F-B6EB8146CC33}" type="slidenum">
+              <a:rPr lang="en-US" smtClean="0"/>
+              <a:t>13</a:t>
+            </a:fld>
+            <a:endParaRPr lang="en-US"/>
+          </a:p>
+        </p:txBody>
+      </p:sp>
+    </p:spTree>
+    <p:extLst>
+      <p:ext uri="{BB962C8B-B14F-4D97-AF65-F5344CB8AC3E}">
+        <p14:creationId xmlns:p14="http://schemas.microsoft.com/office/powerpoint/2010/main" val="3075487479"/>
+      </p:ext>
+    </p:extLst>
+  </p:cSld>
+  <p:clrMapOvr>
+    <a:masterClrMapping/>
+  </p:clrMapOvr>
+</p:notes>
+</file>
+
 <file path=ppt/notesSlides/notesSlide2.xml><?xml version="1.0" encoding="utf-8"?>
 <p:notes xmlns:a="http://schemas.openxmlformats.org/drawingml/2006/main" xmlns:r="http://schemas.openxmlformats.org/officeDocument/2006/relationships" xmlns:p="http://schemas.openxmlformats.org/presentationml/2006/main">
   <p:cSld>
@@ -1630,6 +1850,222 @@
     <p:extLst>
       <p:ext uri="{BB962C8B-B14F-4D97-AF65-F5344CB8AC3E}">
         <p14:creationId xmlns:p14="http://schemas.microsoft.com/office/powerpoint/2010/main" val="4110271203"/>
+      </p:ext>
+    </p:extLst>
+  </p:cSld>
+  <p:clrMapOvr>
+    <a:masterClrMapping/>
+  </p:clrMapOvr>
+</p:notes>
+</file>
+
+<file path=ppt/notesSlides/notesSlide8.xml><?xml version="1.0" encoding="utf-8"?>
+<p:notes xmlns:a="http://schemas.openxmlformats.org/drawingml/2006/main" xmlns:r="http://schemas.openxmlformats.org/officeDocument/2006/relationships" xmlns:p="http://schemas.openxmlformats.org/presentationml/2006/main">
+  <p:cSld>
+    <p:spTree>
+      <p:nvGrpSpPr>
+        <p:cNvPr id="1" name="">
+          <a:extLst>
+            <a:ext uri="{FF2B5EF4-FFF2-40B4-BE49-F238E27FC236}">
+              <a16:creationId xmlns:a16="http://schemas.microsoft.com/office/drawing/2014/main" id="{DEA5F2A7-FA39-A2EE-64A2-8994C3613350}"/>
+            </a:ext>
+          </a:extLst>
+        </p:cNvPr>
+        <p:cNvGrpSpPr/>
+        <p:nvPr/>
+      </p:nvGrpSpPr>
+      <p:grpSpPr>
+        <a:xfrm>
+          <a:off x="0" y="0"/>
+          <a:ext cx="0" cy="0"/>
+          <a:chOff x="0" y="0"/>
+          <a:chExt cx="0" cy="0"/>
+        </a:xfrm>
+      </p:grpSpPr>
+      <p:sp>
+        <p:nvSpPr>
+          <p:cNvPr id="2" name="Slide Image Placeholder 1">
+            <a:extLst>
+              <a:ext uri="{FF2B5EF4-FFF2-40B4-BE49-F238E27FC236}">
+                <a16:creationId xmlns:a16="http://schemas.microsoft.com/office/drawing/2014/main" id="{1FECA1FF-607D-2FBE-9DB1-B639BBC116F3}"/>
+              </a:ext>
+            </a:extLst>
+          </p:cNvPr>
+          <p:cNvSpPr>
+            <a:spLocks noGrp="1" noRot="1" noChangeAspect="1"/>
+          </p:cNvSpPr>
+          <p:nvPr>
+            <p:ph type="sldImg"/>
+          </p:nvPr>
+        </p:nvSpPr>
+        <p:spPr/>
+      </p:sp>
+      <p:sp>
+        <p:nvSpPr>
+          <p:cNvPr id="3" name="Notes Placeholder 2">
+            <a:extLst>
+              <a:ext uri="{FF2B5EF4-FFF2-40B4-BE49-F238E27FC236}">
+                <a16:creationId xmlns:a16="http://schemas.microsoft.com/office/drawing/2014/main" id="{40EB21AA-CBA2-4F99-56AB-8373444051E8}"/>
+              </a:ext>
+            </a:extLst>
+          </p:cNvPr>
+          <p:cNvSpPr>
+            <a:spLocks noGrp="1"/>
+          </p:cNvSpPr>
+          <p:nvPr>
+            <p:ph type="body" idx="1"/>
+          </p:nvPr>
+        </p:nvSpPr>
+        <p:spPr/>
+        <p:txBody>
+          <a:bodyPr/>
+          <a:lstStyle/>
+          <a:p>
+            <a:endParaRPr lang="en-US" dirty="0"/>
+          </a:p>
+        </p:txBody>
+      </p:sp>
+      <p:sp>
+        <p:nvSpPr>
+          <p:cNvPr id="4" name="Slide Number Placeholder 3">
+            <a:extLst>
+              <a:ext uri="{FF2B5EF4-FFF2-40B4-BE49-F238E27FC236}">
+                <a16:creationId xmlns:a16="http://schemas.microsoft.com/office/drawing/2014/main" id="{2429BBD5-8594-F3DA-24A9-2B458BF599A5}"/>
+              </a:ext>
+            </a:extLst>
+          </p:cNvPr>
+          <p:cNvSpPr>
+            <a:spLocks noGrp="1"/>
+          </p:cNvSpPr>
+          <p:nvPr>
+            <p:ph type="sldNum" sz="quarter" idx="5"/>
+          </p:nvPr>
+        </p:nvSpPr>
+        <p:spPr/>
+        <p:txBody>
+          <a:bodyPr/>
+          <a:lstStyle/>
+          <a:p>
+            <a:fld id="{EC94FF2E-E923-D04D-A47F-B6EB8146CC33}" type="slidenum">
+              <a:rPr lang="en-US" smtClean="0"/>
+              <a:t>10</a:t>
+            </a:fld>
+            <a:endParaRPr lang="en-US"/>
+          </a:p>
+        </p:txBody>
+      </p:sp>
+    </p:spTree>
+    <p:extLst>
+      <p:ext uri="{BB962C8B-B14F-4D97-AF65-F5344CB8AC3E}">
+        <p14:creationId xmlns:p14="http://schemas.microsoft.com/office/powerpoint/2010/main" val="4141130966"/>
+      </p:ext>
+    </p:extLst>
+  </p:cSld>
+  <p:clrMapOvr>
+    <a:masterClrMapping/>
+  </p:clrMapOvr>
+</p:notes>
+</file>
+
+<file path=ppt/notesSlides/notesSlide9.xml><?xml version="1.0" encoding="utf-8"?>
+<p:notes xmlns:a="http://schemas.openxmlformats.org/drawingml/2006/main" xmlns:r="http://schemas.openxmlformats.org/officeDocument/2006/relationships" xmlns:p="http://schemas.openxmlformats.org/presentationml/2006/main">
+  <p:cSld>
+    <p:spTree>
+      <p:nvGrpSpPr>
+        <p:cNvPr id="1" name="">
+          <a:extLst>
+            <a:ext uri="{FF2B5EF4-FFF2-40B4-BE49-F238E27FC236}">
+              <a16:creationId xmlns:a16="http://schemas.microsoft.com/office/drawing/2014/main" id="{A07997E1-B605-D680-FBC3-72925C124349}"/>
+            </a:ext>
+          </a:extLst>
+        </p:cNvPr>
+        <p:cNvGrpSpPr/>
+        <p:nvPr/>
+      </p:nvGrpSpPr>
+      <p:grpSpPr>
+        <a:xfrm>
+          <a:off x="0" y="0"/>
+          <a:ext cx="0" cy="0"/>
+          <a:chOff x="0" y="0"/>
+          <a:chExt cx="0" cy="0"/>
+        </a:xfrm>
+      </p:grpSpPr>
+      <p:sp>
+        <p:nvSpPr>
+          <p:cNvPr id="2" name="Slide Image Placeholder 1">
+            <a:extLst>
+              <a:ext uri="{FF2B5EF4-FFF2-40B4-BE49-F238E27FC236}">
+                <a16:creationId xmlns:a16="http://schemas.microsoft.com/office/drawing/2014/main" id="{E09EB0C2-344D-220D-F639-EB8F99BCAAB3}"/>
+              </a:ext>
+            </a:extLst>
+          </p:cNvPr>
+          <p:cNvSpPr>
+            <a:spLocks noGrp="1" noRot="1" noChangeAspect="1"/>
+          </p:cNvSpPr>
+          <p:nvPr>
+            <p:ph type="sldImg"/>
+          </p:nvPr>
+        </p:nvSpPr>
+        <p:spPr/>
+      </p:sp>
+      <p:sp>
+        <p:nvSpPr>
+          <p:cNvPr id="3" name="Notes Placeholder 2">
+            <a:extLst>
+              <a:ext uri="{FF2B5EF4-FFF2-40B4-BE49-F238E27FC236}">
+                <a16:creationId xmlns:a16="http://schemas.microsoft.com/office/drawing/2014/main" id="{93C8D4FB-0A99-96FB-BE3A-F410971E6EE1}"/>
+              </a:ext>
+            </a:extLst>
+          </p:cNvPr>
+          <p:cNvSpPr>
+            <a:spLocks noGrp="1"/>
+          </p:cNvSpPr>
+          <p:nvPr>
+            <p:ph type="body" idx="1"/>
+          </p:nvPr>
+        </p:nvSpPr>
+        <p:spPr/>
+        <p:txBody>
+          <a:bodyPr/>
+          <a:lstStyle/>
+          <a:p>
+            <a:endParaRPr lang="en-US" dirty="0"/>
+          </a:p>
+        </p:txBody>
+      </p:sp>
+      <p:sp>
+        <p:nvSpPr>
+          <p:cNvPr id="4" name="Slide Number Placeholder 3">
+            <a:extLst>
+              <a:ext uri="{FF2B5EF4-FFF2-40B4-BE49-F238E27FC236}">
+                <a16:creationId xmlns:a16="http://schemas.microsoft.com/office/drawing/2014/main" id="{0C2222DE-6DDB-F2F0-C624-9ED28706A6D0}"/>
+              </a:ext>
+            </a:extLst>
+          </p:cNvPr>
+          <p:cNvSpPr>
+            <a:spLocks noGrp="1"/>
+          </p:cNvSpPr>
+          <p:nvPr>
+            <p:ph type="sldNum" sz="quarter" idx="5"/>
+          </p:nvPr>
+        </p:nvSpPr>
+        <p:spPr/>
+        <p:txBody>
+          <a:bodyPr/>
+          <a:lstStyle/>
+          <a:p>
+            <a:fld id="{EC94FF2E-E923-D04D-A47F-B6EB8146CC33}" type="slidenum">
+              <a:rPr lang="en-US" smtClean="0"/>
+              <a:t>11</a:t>
+            </a:fld>
+            <a:endParaRPr lang="en-US"/>
+          </a:p>
+        </p:txBody>
+      </p:sp>
+    </p:spTree>
+    <p:extLst>
+      <p:ext uri="{BB962C8B-B14F-4D97-AF65-F5344CB8AC3E}">
+        <p14:creationId xmlns:p14="http://schemas.microsoft.com/office/powerpoint/2010/main" val="1930417939"/>
       </p:ext>
     </p:extLst>
   </p:cSld>
@@ -4943,6 +5379,2275 @@
 </p:sld>
 </file>
 
+<file path=ppt/slides/slide10.xml><?xml version="1.0" encoding="utf-8"?>
+<p:sld xmlns:a="http://schemas.openxmlformats.org/drawingml/2006/main" xmlns:r="http://schemas.openxmlformats.org/officeDocument/2006/relationships" xmlns:p="http://schemas.openxmlformats.org/presentationml/2006/main">
+  <p:cSld>
+    <p:bg>
+      <p:bgPr>
+        <a:solidFill>
+          <a:schemeClr val="bg1"/>
+        </a:solidFill>
+        <a:effectLst/>
+      </p:bgPr>
+    </p:bg>
+    <p:spTree>
+      <p:nvGrpSpPr>
+        <p:cNvPr id="1" name="">
+          <a:extLst>
+            <a:ext uri="{FF2B5EF4-FFF2-40B4-BE49-F238E27FC236}">
+              <a16:creationId xmlns:a16="http://schemas.microsoft.com/office/drawing/2014/main" id="{346F6256-E725-F4F9-952F-9B7FF8928D5B}"/>
+            </a:ext>
+          </a:extLst>
+        </p:cNvPr>
+        <p:cNvGrpSpPr/>
+        <p:nvPr/>
+      </p:nvGrpSpPr>
+      <p:grpSpPr>
+        <a:xfrm>
+          <a:off x="0" y="0"/>
+          <a:ext cx="0" cy="0"/>
+          <a:chOff x="0" y="0"/>
+          <a:chExt cx="0" cy="0"/>
+        </a:xfrm>
+      </p:grpSpPr>
+      <p:sp useBgFill="1">
+        <p:nvSpPr>
+          <p:cNvPr id="66" name="Rectangle 65">
+            <a:extLst>
+              <a:ext uri="{FF2B5EF4-FFF2-40B4-BE49-F238E27FC236}">
+                <a16:creationId xmlns:a16="http://schemas.microsoft.com/office/drawing/2014/main" id="{BCED4D40-4B67-4331-AC48-79B82B4A47D8}"/>
+              </a:ext>
+              <a:ext uri="{C183D7F6-B498-43B3-948B-1728B52AA6E4}">
+                <adec:decorative xmlns:adec="http://schemas.microsoft.com/office/drawing/2017/decorative" val="1"/>
+              </a:ext>
+            </a:extLst>
+          </p:cNvPr>
+          <p:cNvSpPr>
+            <a:spLocks noGrp="1" noRot="1" noChangeAspect="1" noMove="1" noResize="1" noEditPoints="1" noAdjustHandles="1" noChangeArrowheads="1" noChangeShapeType="1" noTextEdit="1"/>
+          </p:cNvSpPr>
+          <p:nvPr>
+            <p:extLst>
+              <p:ext uri="{386F3935-93C4-4BCD-93E2-E3B085C9AB24}">
+                <p16:designElem xmlns:p16="http://schemas.microsoft.com/office/powerpoint/2015/main" val="1"/>
+              </p:ext>
+            </p:extLst>
+          </p:nvPr>
+        </p:nvSpPr>
+        <p:spPr>
+          <a:xfrm>
+            <a:off x="0" y="0"/>
+            <a:ext cx="12192000" cy="6858000"/>
+          </a:xfrm>
+          <a:prstGeom prst="rect">
+            <a:avLst/>
+          </a:prstGeom>
+          <a:ln>
+            <a:noFill/>
+          </a:ln>
+        </p:spPr>
+        <p:style>
+          <a:lnRef idx="2">
+            <a:schemeClr val="accent1">
+              <a:shade val="50000"/>
+            </a:schemeClr>
+          </a:lnRef>
+          <a:fillRef idx="1">
+            <a:schemeClr val="accent1"/>
+          </a:fillRef>
+          <a:effectRef idx="0">
+            <a:schemeClr val="accent1"/>
+          </a:effectRef>
+          <a:fontRef idx="minor">
+            <a:schemeClr val="lt1"/>
+          </a:fontRef>
+        </p:style>
+        <p:txBody>
+          <a:bodyPr rtlCol="0" anchor="ctr"/>
+          <a:lstStyle/>
+          <a:p>
+            <a:pPr algn="ctr"/>
+            <a:endParaRPr lang="en-US"/>
+          </a:p>
+        </p:txBody>
+      </p:sp>
+      <p:sp>
+        <p:nvSpPr>
+          <p:cNvPr id="2" name="Title 1">
+            <a:extLst>
+              <a:ext uri="{FF2B5EF4-FFF2-40B4-BE49-F238E27FC236}">
+                <a16:creationId xmlns:a16="http://schemas.microsoft.com/office/drawing/2014/main" id="{66EF003C-A9FC-1466-8EA0-AB95F29DF3FC}"/>
+              </a:ext>
+            </a:extLst>
+          </p:cNvPr>
+          <p:cNvSpPr>
+            <a:spLocks noGrp="1"/>
+          </p:cNvSpPr>
+          <p:nvPr>
+            <p:ph type="title"/>
+          </p:nvPr>
+        </p:nvSpPr>
+        <p:spPr>
+          <a:xfrm>
+            <a:off x="638881" y="417576"/>
+            <a:ext cx="10909640" cy="1249394"/>
+          </a:xfrm>
+        </p:spPr>
+        <p:txBody>
+          <a:bodyPr vert="horz" lIns="91440" tIns="45720" rIns="91440" bIns="45720" rtlCol="0" anchor="ctr">
+            <a:normAutofit/>
+          </a:bodyPr>
+          <a:lstStyle/>
+          <a:p>
+            <a:pPr algn="ctr"/>
+            <a:r>
+              <a:rPr lang="en-US" sz="4100" b="1" kern="1200">
+                <a:solidFill>
+                  <a:schemeClr val="tx1"/>
+                </a:solidFill>
+                <a:latin typeface="+mj-lt"/>
+                <a:ea typeface="+mj-ea"/>
+                <a:cs typeface="+mj-cs"/>
+              </a:rPr>
+              <a:t>PagedAttention: Prompts, Tokenization &amp; Block Allocation</a:t>
+            </a:r>
+          </a:p>
+        </p:txBody>
+      </p:sp>
+      <p:sp>
+        <p:nvSpPr>
+          <p:cNvPr id="68" name="sketch line">
+            <a:extLst>
+              <a:ext uri="{FF2B5EF4-FFF2-40B4-BE49-F238E27FC236}">
+                <a16:creationId xmlns:a16="http://schemas.microsoft.com/office/drawing/2014/main" id="{670CEDEF-4F34-412E-84EE-329C1E936AF5}"/>
+              </a:ext>
+              <a:ext uri="{C183D7F6-B498-43B3-948B-1728B52AA6E4}">
+                <adec:decorative xmlns:adec="http://schemas.microsoft.com/office/drawing/2017/decorative" val="1"/>
+              </a:ext>
+            </a:extLst>
+          </p:cNvPr>
+          <p:cNvSpPr>
+            <a:spLocks noGrp="1" noRot="1" noChangeAspect="1" noMove="1" noResize="1" noEditPoints="1" noAdjustHandles="1" noChangeArrowheads="1" noChangeShapeType="1" noTextEdit="1"/>
+          </p:cNvSpPr>
+          <p:nvPr>
+            <p:extLst>
+              <p:ext uri="{386F3935-93C4-4BCD-93E2-E3B085C9AB24}">
+                <p16:designElem xmlns:p16="http://schemas.microsoft.com/office/powerpoint/2015/main" val="1"/>
+              </p:ext>
+            </p:extLst>
+          </p:nvPr>
+        </p:nvSpPr>
+        <p:spPr>
+          <a:xfrm>
+            <a:off x="3807702" y="1733454"/>
+            <a:ext cx="4572000" cy="18288"/>
+          </a:xfrm>
+          <a:custGeom>
+            <a:avLst/>
+            <a:gdLst>
+              <a:gd name="csX0" fmla="*/ 0 w 4572000"/>
+              <a:gd name="csY0" fmla="*/ 0 h 18288"/>
+              <a:gd name="csX1" fmla="*/ 515983 w 4572000"/>
+              <a:gd name="csY1" fmla="*/ 0 h 18288"/>
+              <a:gd name="csX2" fmla="*/ 1031966 w 4572000"/>
+              <a:gd name="csY2" fmla="*/ 0 h 18288"/>
+              <a:gd name="csX3" fmla="*/ 1639389 w 4572000"/>
+              <a:gd name="csY3" fmla="*/ 0 h 18288"/>
+              <a:gd name="csX4" fmla="*/ 2383971 w 4572000"/>
+              <a:gd name="csY4" fmla="*/ 0 h 18288"/>
+              <a:gd name="csX5" fmla="*/ 2945674 w 4572000"/>
+              <a:gd name="csY5" fmla="*/ 0 h 18288"/>
+              <a:gd name="csX6" fmla="*/ 3507377 w 4572000"/>
+              <a:gd name="csY6" fmla="*/ 0 h 18288"/>
+              <a:gd name="csX7" fmla="*/ 4572000 w 4572000"/>
+              <a:gd name="csY7" fmla="*/ 0 h 18288"/>
+              <a:gd name="csX8" fmla="*/ 4572000 w 4572000"/>
+              <a:gd name="csY8" fmla="*/ 18288 h 18288"/>
+              <a:gd name="csX9" fmla="*/ 3873137 w 4572000"/>
+              <a:gd name="csY9" fmla="*/ 18288 h 18288"/>
+              <a:gd name="csX10" fmla="*/ 3311434 w 4572000"/>
+              <a:gd name="csY10" fmla="*/ 18288 h 18288"/>
+              <a:gd name="csX11" fmla="*/ 2749731 w 4572000"/>
+              <a:gd name="csY11" fmla="*/ 18288 h 18288"/>
+              <a:gd name="csX12" fmla="*/ 2050869 w 4572000"/>
+              <a:gd name="csY12" fmla="*/ 18288 h 18288"/>
+              <a:gd name="csX13" fmla="*/ 1306286 w 4572000"/>
+              <a:gd name="csY13" fmla="*/ 18288 h 18288"/>
+              <a:gd name="csX14" fmla="*/ 790303 w 4572000"/>
+              <a:gd name="csY14" fmla="*/ 18288 h 18288"/>
+              <a:gd name="csX15" fmla="*/ 0 w 4572000"/>
+              <a:gd name="csY15" fmla="*/ 18288 h 18288"/>
+              <a:gd name="csX16" fmla="*/ 0 w 4572000"/>
+              <a:gd name="csY16" fmla="*/ 0 h 18288"/>
+            </a:gdLst>
+            <a:ahLst/>
+            <a:cxnLst>
+              <a:cxn ang="0">
+                <a:pos x="csX0" y="csY0"/>
+              </a:cxn>
+              <a:cxn ang="0">
+                <a:pos x="csX1" y="csY1"/>
+              </a:cxn>
+              <a:cxn ang="0">
+                <a:pos x="csX2" y="csY2"/>
+              </a:cxn>
+              <a:cxn ang="0">
+                <a:pos x="csX3" y="csY3"/>
+              </a:cxn>
+              <a:cxn ang="0">
+                <a:pos x="csX4" y="csY4"/>
+              </a:cxn>
+              <a:cxn ang="0">
+                <a:pos x="csX5" y="csY5"/>
+              </a:cxn>
+              <a:cxn ang="0">
+                <a:pos x="csX6" y="csY6"/>
+              </a:cxn>
+              <a:cxn ang="0">
+                <a:pos x="csX7" y="csY7"/>
+              </a:cxn>
+              <a:cxn ang="0">
+                <a:pos x="csX8" y="csY8"/>
+              </a:cxn>
+              <a:cxn ang="0">
+                <a:pos x="csX9" y="csY9"/>
+              </a:cxn>
+              <a:cxn ang="0">
+                <a:pos x="csX10" y="csY10"/>
+              </a:cxn>
+              <a:cxn ang="0">
+                <a:pos x="csX11" y="csY11"/>
+              </a:cxn>
+              <a:cxn ang="0">
+                <a:pos x="csX12" y="csY12"/>
+              </a:cxn>
+              <a:cxn ang="0">
+                <a:pos x="csX13" y="csY13"/>
+              </a:cxn>
+              <a:cxn ang="0">
+                <a:pos x="csX14" y="csY14"/>
+              </a:cxn>
+              <a:cxn ang="0">
+                <a:pos x="csX15" y="csY15"/>
+              </a:cxn>
+              <a:cxn ang="0">
+                <a:pos x="csX16" y="csY16"/>
+              </a:cxn>
+            </a:cxnLst>
+            <a:rect l="l" t="t" r="r" b="b"/>
+            <a:pathLst>
+              <a:path w="4572000" h="18288" fill="none" extrusionOk="0">
+                <a:moveTo>
+                  <a:pt x="0" y="0"/>
+                </a:moveTo>
+                <a:cubicBezTo>
+                  <a:pt x="105156" y="-20963"/>
+                  <a:pt x="340432" y="822"/>
+                  <a:pt x="515983" y="0"/>
+                </a:cubicBezTo>
+                <a:cubicBezTo>
+                  <a:pt x="691534" y="-822"/>
+                  <a:pt x="850679" y="16479"/>
+                  <a:pt x="1031966" y="0"/>
+                </a:cubicBezTo>
+                <a:cubicBezTo>
+                  <a:pt x="1213253" y="-16479"/>
+                  <a:pt x="1443646" y="-18730"/>
+                  <a:pt x="1639389" y="0"/>
+                </a:cubicBezTo>
+                <a:cubicBezTo>
+                  <a:pt x="1835132" y="18730"/>
+                  <a:pt x="2159975" y="18531"/>
+                  <a:pt x="2383971" y="0"/>
+                </a:cubicBezTo>
+                <a:cubicBezTo>
+                  <a:pt x="2607967" y="-18531"/>
+                  <a:pt x="2719096" y="-12030"/>
+                  <a:pt x="2945674" y="0"/>
+                </a:cubicBezTo>
+                <a:cubicBezTo>
+                  <a:pt x="3172252" y="12030"/>
+                  <a:pt x="3269167" y="27666"/>
+                  <a:pt x="3507377" y="0"/>
+                </a:cubicBezTo>
+                <a:cubicBezTo>
+                  <a:pt x="3745587" y="-27666"/>
+                  <a:pt x="4116741" y="18705"/>
+                  <a:pt x="4572000" y="0"/>
+                </a:cubicBezTo>
+                <a:cubicBezTo>
+                  <a:pt x="4572895" y="8974"/>
+                  <a:pt x="4571454" y="9359"/>
+                  <a:pt x="4572000" y="18288"/>
+                </a:cubicBezTo>
+                <a:cubicBezTo>
+                  <a:pt x="4374698" y="3942"/>
+                  <a:pt x="4098874" y="-11042"/>
+                  <a:pt x="3873137" y="18288"/>
+                </a:cubicBezTo>
+                <a:cubicBezTo>
+                  <a:pt x="3647400" y="47618"/>
+                  <a:pt x="3517055" y="5421"/>
+                  <a:pt x="3311434" y="18288"/>
+                </a:cubicBezTo>
+                <a:cubicBezTo>
+                  <a:pt x="3105813" y="31155"/>
+                  <a:pt x="3025168" y="17856"/>
+                  <a:pt x="2749731" y="18288"/>
+                </a:cubicBezTo>
+                <a:cubicBezTo>
+                  <a:pt x="2474294" y="18720"/>
+                  <a:pt x="2291766" y="-14168"/>
+                  <a:pt x="2050869" y="18288"/>
+                </a:cubicBezTo>
+                <a:cubicBezTo>
+                  <a:pt x="1809972" y="50744"/>
+                  <a:pt x="1540276" y="46798"/>
+                  <a:pt x="1306286" y="18288"/>
+                </a:cubicBezTo>
+                <a:cubicBezTo>
+                  <a:pt x="1072296" y="-10222"/>
+                  <a:pt x="972445" y="19645"/>
+                  <a:pt x="790303" y="18288"/>
+                </a:cubicBezTo>
+                <a:cubicBezTo>
+                  <a:pt x="608161" y="16931"/>
+                  <a:pt x="200981" y="8241"/>
+                  <a:pt x="0" y="18288"/>
+                </a:cubicBezTo>
+                <a:cubicBezTo>
+                  <a:pt x="-229" y="14222"/>
+                  <a:pt x="509" y="5816"/>
+                  <a:pt x="0" y="0"/>
+                </a:cubicBezTo>
+                <a:close/>
+              </a:path>
+              <a:path w="4572000" h="18288" stroke="0" extrusionOk="0">
+                <a:moveTo>
+                  <a:pt x="0" y="0"/>
+                </a:moveTo>
+                <a:cubicBezTo>
+                  <a:pt x="143285" y="-9565"/>
+                  <a:pt x="327959" y="-11498"/>
+                  <a:pt x="561703" y="0"/>
+                </a:cubicBezTo>
+                <a:cubicBezTo>
+                  <a:pt x="795447" y="11498"/>
+                  <a:pt x="838260" y="18255"/>
+                  <a:pt x="1077686" y="0"/>
+                </a:cubicBezTo>
+                <a:cubicBezTo>
+                  <a:pt x="1317112" y="-18255"/>
+                  <a:pt x="1437472" y="23514"/>
+                  <a:pt x="1639389" y="0"/>
+                </a:cubicBezTo>
+                <a:cubicBezTo>
+                  <a:pt x="1841306" y="-23514"/>
+                  <a:pt x="2037142" y="-12551"/>
+                  <a:pt x="2292531" y="0"/>
+                </a:cubicBezTo>
+                <a:cubicBezTo>
+                  <a:pt x="2547920" y="12551"/>
+                  <a:pt x="2810436" y="-20352"/>
+                  <a:pt x="2991394" y="0"/>
+                </a:cubicBezTo>
+                <a:cubicBezTo>
+                  <a:pt x="3172352" y="20352"/>
+                  <a:pt x="3530025" y="-13347"/>
+                  <a:pt x="3735977" y="0"/>
+                </a:cubicBezTo>
+                <a:cubicBezTo>
+                  <a:pt x="3941929" y="13347"/>
+                  <a:pt x="4161497" y="34086"/>
+                  <a:pt x="4572000" y="0"/>
+                </a:cubicBezTo>
+                <a:cubicBezTo>
+                  <a:pt x="4571545" y="6162"/>
+                  <a:pt x="4571903" y="11775"/>
+                  <a:pt x="4572000" y="18288"/>
+                </a:cubicBezTo>
+                <a:cubicBezTo>
+                  <a:pt x="4228040" y="36490"/>
+                  <a:pt x="4199736" y="42557"/>
+                  <a:pt x="3873137" y="18288"/>
+                </a:cubicBezTo>
+                <a:cubicBezTo>
+                  <a:pt x="3546538" y="-5981"/>
+                  <a:pt x="3472124" y="16809"/>
+                  <a:pt x="3128554" y="18288"/>
+                </a:cubicBezTo>
+                <a:cubicBezTo>
+                  <a:pt x="2784984" y="19767"/>
+                  <a:pt x="2735896" y="-17781"/>
+                  <a:pt x="2383971" y="18288"/>
+                </a:cubicBezTo>
+                <a:cubicBezTo>
+                  <a:pt x="2032046" y="54357"/>
+                  <a:pt x="2019324" y="2920"/>
+                  <a:pt x="1867989" y="18288"/>
+                </a:cubicBezTo>
+                <a:cubicBezTo>
+                  <a:pt x="1716654" y="33656"/>
+                  <a:pt x="1418675" y="32575"/>
+                  <a:pt x="1169126" y="18288"/>
+                </a:cubicBezTo>
+                <a:cubicBezTo>
+                  <a:pt x="919577" y="4001"/>
+                  <a:pt x="798537" y="16165"/>
+                  <a:pt x="561703" y="18288"/>
+                </a:cubicBezTo>
+                <a:cubicBezTo>
+                  <a:pt x="324869" y="20411"/>
+                  <a:pt x="221395" y="-912"/>
+                  <a:pt x="0" y="18288"/>
+                </a:cubicBezTo>
+                <a:cubicBezTo>
+                  <a:pt x="766" y="10800"/>
+                  <a:pt x="-457" y="8180"/>
+                  <a:pt x="0" y="0"/>
+                </a:cubicBezTo>
+                <a:close/>
+              </a:path>
+            </a:pathLst>
+          </a:custGeom>
+          <a:solidFill>
+            <a:schemeClr val="accent2"/>
+          </a:solidFill>
+          <a:ln w="41275" cap="rnd">
+            <a:solidFill>
+              <a:schemeClr val="accent2"/>
+            </a:solidFill>
+            <a:round/>
+            <a:extLst>
+              <a:ext uri="{C807C97D-BFC1-408E-A445-0C87EB9F89A2}">
+                <ask:lineSketchStyleProps xmlns:ask="http://schemas.microsoft.com/office/drawing/2018/sketchyshapes" sd="2727557108">
+                  <a:prstGeom prst="rect">
+                    <a:avLst/>
+                  </a:prstGeom>
+                  <ask:type>
+                    <ask:lineSketchFreehand/>
+                  </ask:type>
+                </ask:lineSketchStyleProps>
+              </a:ext>
+            </a:extLst>
+          </a:ln>
+        </p:spPr>
+        <p:style>
+          <a:lnRef idx="2">
+            <a:schemeClr val="accent1">
+              <a:shade val="50000"/>
+            </a:schemeClr>
+          </a:lnRef>
+          <a:fillRef idx="1">
+            <a:schemeClr val="accent1"/>
+          </a:fillRef>
+          <a:effectRef idx="0">
+            <a:schemeClr val="accent1"/>
+          </a:effectRef>
+          <a:fontRef idx="minor">
+            <a:schemeClr val="lt1"/>
+          </a:fontRef>
+        </p:style>
+        <p:txBody>
+          <a:bodyPr rtlCol="0" anchor="ctr"/>
+          <a:lstStyle/>
+          <a:p>
+            <a:pPr algn="ctr"/>
+            <a:endParaRPr lang="en-US"/>
+          </a:p>
+        </p:txBody>
+      </p:sp>
+      <p:pic>
+        <p:nvPicPr>
+          <p:cNvPr id="3" name="Picture 2">
+            <a:extLst>
+              <a:ext uri="{FF2B5EF4-FFF2-40B4-BE49-F238E27FC236}">
+                <a16:creationId xmlns:a16="http://schemas.microsoft.com/office/drawing/2014/main" id="{828CB561-43E4-E505-D83C-D40356F5D250}"/>
+              </a:ext>
+            </a:extLst>
+          </p:cNvPr>
+          <p:cNvPicPr>
+            <a:picLocks noChangeAspect="1"/>
+          </p:cNvPicPr>
+          <p:nvPr/>
+        </p:nvPicPr>
+        <p:blipFill>
+          <a:blip r:embed="rId3"/>
+          <a:stretch>
+            <a:fillRect/>
+          </a:stretch>
+        </p:blipFill>
+        <p:spPr>
+          <a:xfrm>
+            <a:off x="320040" y="2983039"/>
+            <a:ext cx="11548872" cy="2887219"/>
+          </a:xfrm>
+          <a:prstGeom prst="rect">
+            <a:avLst/>
+          </a:prstGeom>
+        </p:spPr>
+      </p:pic>
+    </p:spTree>
+    <p:extLst>
+      <p:ext uri="{BB962C8B-B14F-4D97-AF65-F5344CB8AC3E}">
+        <p14:creationId xmlns:p14="http://schemas.microsoft.com/office/powerpoint/2010/main" val="1426268313"/>
+      </p:ext>
+    </p:extLst>
+  </p:cSld>
+  <p:clrMapOvr>
+    <a:masterClrMapping/>
+  </p:clrMapOvr>
+</p:sld>
+</file>
+
+<file path=ppt/slides/slide11.xml><?xml version="1.0" encoding="utf-8"?>
+<p:sld xmlns:a="http://schemas.openxmlformats.org/drawingml/2006/main" xmlns:r="http://schemas.openxmlformats.org/officeDocument/2006/relationships" xmlns:p="http://schemas.openxmlformats.org/presentationml/2006/main">
+  <p:cSld>
+    <p:bg>
+      <p:bgPr>
+        <a:solidFill>
+          <a:schemeClr val="bg1"/>
+        </a:solidFill>
+        <a:effectLst/>
+      </p:bgPr>
+    </p:bg>
+    <p:spTree>
+      <p:nvGrpSpPr>
+        <p:cNvPr id="1" name="">
+          <a:extLst>
+            <a:ext uri="{FF2B5EF4-FFF2-40B4-BE49-F238E27FC236}">
+              <a16:creationId xmlns:a16="http://schemas.microsoft.com/office/drawing/2014/main" id="{E8B6EE3E-3B36-F86B-463A-2565C9C1831E}"/>
+            </a:ext>
+          </a:extLst>
+        </p:cNvPr>
+        <p:cNvGrpSpPr/>
+        <p:nvPr/>
+      </p:nvGrpSpPr>
+      <p:grpSpPr>
+        <a:xfrm>
+          <a:off x="0" y="0"/>
+          <a:ext cx="0" cy="0"/>
+          <a:chOff x="0" y="0"/>
+          <a:chExt cx="0" cy="0"/>
+        </a:xfrm>
+      </p:grpSpPr>
+      <p:sp useBgFill="1">
+        <p:nvSpPr>
+          <p:cNvPr id="73" name="Rectangle 72">
+            <a:extLst>
+              <a:ext uri="{FF2B5EF4-FFF2-40B4-BE49-F238E27FC236}">
+                <a16:creationId xmlns:a16="http://schemas.microsoft.com/office/drawing/2014/main" id="{2B97F24A-32CE-4C1C-A50D-3016B394DCFB}"/>
+              </a:ext>
+              <a:ext uri="{C183D7F6-B498-43B3-948B-1728B52AA6E4}">
+                <adec:decorative xmlns:adec="http://schemas.microsoft.com/office/drawing/2017/decorative" val="1"/>
+              </a:ext>
+            </a:extLst>
+          </p:cNvPr>
+          <p:cNvSpPr>
+            <a:spLocks noGrp="1" noRot="1" noChangeAspect="1" noMove="1" noResize="1" noEditPoints="1" noAdjustHandles="1" noChangeArrowheads="1" noChangeShapeType="1" noTextEdit="1"/>
+          </p:cNvSpPr>
+          <p:nvPr>
+            <p:extLst>
+              <p:ext uri="{386F3935-93C4-4BCD-93E2-E3B085C9AB24}">
+                <p16:designElem xmlns:p16="http://schemas.microsoft.com/office/powerpoint/2015/main" val="1"/>
+              </p:ext>
+            </p:extLst>
+          </p:nvPr>
+        </p:nvSpPr>
+        <p:spPr>
+          <a:xfrm>
+            <a:off x="0" y="0"/>
+            <a:ext cx="12192000" cy="6858000"/>
+          </a:xfrm>
+          <a:prstGeom prst="rect">
+            <a:avLst/>
+          </a:prstGeom>
+          <a:ln>
+            <a:noFill/>
+          </a:ln>
+        </p:spPr>
+        <p:style>
+          <a:lnRef idx="2">
+            <a:schemeClr val="accent1">
+              <a:shade val="50000"/>
+            </a:schemeClr>
+          </a:lnRef>
+          <a:fillRef idx="1">
+            <a:schemeClr val="accent1"/>
+          </a:fillRef>
+          <a:effectRef idx="0">
+            <a:schemeClr val="accent1"/>
+          </a:effectRef>
+          <a:fontRef idx="minor">
+            <a:schemeClr val="lt1"/>
+          </a:fontRef>
+        </p:style>
+        <p:txBody>
+          <a:bodyPr rtlCol="0" anchor="ctr"/>
+          <a:lstStyle/>
+          <a:p>
+            <a:pPr algn="ctr"/>
+            <a:endParaRPr lang="en-US"/>
+          </a:p>
+        </p:txBody>
+      </p:sp>
+      <p:sp>
+        <p:nvSpPr>
+          <p:cNvPr id="2" name="Title 1">
+            <a:extLst>
+              <a:ext uri="{FF2B5EF4-FFF2-40B4-BE49-F238E27FC236}">
+                <a16:creationId xmlns:a16="http://schemas.microsoft.com/office/drawing/2014/main" id="{5570279A-0567-9DEA-6111-4A4A32A394E2}"/>
+              </a:ext>
+            </a:extLst>
+          </p:cNvPr>
+          <p:cNvSpPr>
+            <a:spLocks noGrp="1"/>
+          </p:cNvSpPr>
+          <p:nvPr>
+            <p:ph type="title"/>
+          </p:nvPr>
+        </p:nvSpPr>
+        <p:spPr>
+          <a:xfrm>
+            <a:off x="630936" y="639520"/>
+            <a:ext cx="3429000" cy="1719072"/>
+          </a:xfrm>
+        </p:spPr>
+        <p:txBody>
+          <a:bodyPr vert="horz" lIns="91440" tIns="45720" rIns="91440" bIns="45720" rtlCol="0" anchor="b">
+            <a:normAutofit/>
+          </a:bodyPr>
+          <a:lstStyle/>
+          <a:p>
+            <a:r>
+              <a:rPr lang="en-US" sz="5000" b="1" kern="1200">
+                <a:solidFill>
+                  <a:schemeClr val="tx1"/>
+                </a:solidFill>
+                <a:latin typeface="+mj-lt"/>
+                <a:ea typeface="+mj-ea"/>
+                <a:cs typeface="+mj-cs"/>
+              </a:rPr>
+              <a:t>Continuous Batching</a:t>
+            </a:r>
+          </a:p>
+        </p:txBody>
+      </p:sp>
+      <p:sp>
+        <p:nvSpPr>
+          <p:cNvPr id="75" name="sketch line">
+            <a:extLst>
+              <a:ext uri="{FF2B5EF4-FFF2-40B4-BE49-F238E27FC236}">
+                <a16:creationId xmlns:a16="http://schemas.microsoft.com/office/drawing/2014/main" id="{CD8B4F24-440B-49E9-B85D-733523DC064B}"/>
+              </a:ext>
+              <a:ext uri="{C183D7F6-B498-43B3-948B-1728B52AA6E4}">
+                <adec:decorative xmlns:adec="http://schemas.microsoft.com/office/drawing/2017/decorative" val="1"/>
+              </a:ext>
+            </a:extLst>
+          </p:cNvPr>
+          <p:cNvSpPr>
+            <a:spLocks noGrp="1" noRot="1" noChangeAspect="1" noMove="1" noResize="1" noEditPoints="1" noAdjustHandles="1" noChangeArrowheads="1" noChangeShapeType="1" noTextEdit="1"/>
+          </p:cNvSpPr>
+          <p:nvPr>
+            <p:extLst>
+              <p:ext uri="{386F3935-93C4-4BCD-93E2-E3B085C9AB24}">
+                <p16:designElem xmlns:p16="http://schemas.microsoft.com/office/powerpoint/2015/main" val="1"/>
+              </p:ext>
+            </p:extLst>
+          </p:nvPr>
+        </p:nvSpPr>
+        <p:spPr>
+          <a:xfrm>
+            <a:off x="643278" y="2573756"/>
+            <a:ext cx="3255095" cy="18288"/>
+          </a:xfrm>
+          <a:custGeom>
+            <a:avLst/>
+            <a:gdLst>
+              <a:gd name="csX0" fmla="*/ 0 w 3255095"/>
+              <a:gd name="csY0" fmla="*/ 0 h 18288"/>
+              <a:gd name="csX1" fmla="*/ 618468 w 3255095"/>
+              <a:gd name="csY1" fmla="*/ 0 h 18288"/>
+              <a:gd name="csX2" fmla="*/ 1269487 w 3255095"/>
+              <a:gd name="csY2" fmla="*/ 0 h 18288"/>
+              <a:gd name="csX3" fmla="*/ 1953057 w 3255095"/>
+              <a:gd name="csY3" fmla="*/ 0 h 18288"/>
+              <a:gd name="csX4" fmla="*/ 2636627 w 3255095"/>
+              <a:gd name="csY4" fmla="*/ 0 h 18288"/>
+              <a:gd name="csX5" fmla="*/ 3255095 w 3255095"/>
+              <a:gd name="csY5" fmla="*/ 0 h 18288"/>
+              <a:gd name="csX6" fmla="*/ 3255095 w 3255095"/>
+              <a:gd name="csY6" fmla="*/ 18288 h 18288"/>
+              <a:gd name="csX7" fmla="*/ 2538974 w 3255095"/>
+              <a:gd name="csY7" fmla="*/ 18288 h 18288"/>
+              <a:gd name="csX8" fmla="*/ 1822853 w 3255095"/>
+              <a:gd name="csY8" fmla="*/ 18288 h 18288"/>
+              <a:gd name="csX9" fmla="*/ 1171834 w 3255095"/>
+              <a:gd name="csY9" fmla="*/ 18288 h 18288"/>
+              <a:gd name="csX10" fmla="*/ 0 w 3255095"/>
+              <a:gd name="csY10" fmla="*/ 18288 h 18288"/>
+              <a:gd name="csX11" fmla="*/ 0 w 3255095"/>
+              <a:gd name="csY11" fmla="*/ 0 h 18288"/>
+            </a:gdLst>
+            <a:ahLst/>
+            <a:cxnLst>
+              <a:cxn ang="0">
+                <a:pos x="csX0" y="csY0"/>
+              </a:cxn>
+              <a:cxn ang="0">
+                <a:pos x="csX1" y="csY1"/>
+              </a:cxn>
+              <a:cxn ang="0">
+                <a:pos x="csX2" y="csY2"/>
+              </a:cxn>
+              <a:cxn ang="0">
+                <a:pos x="csX3" y="csY3"/>
+              </a:cxn>
+              <a:cxn ang="0">
+                <a:pos x="csX4" y="csY4"/>
+              </a:cxn>
+              <a:cxn ang="0">
+                <a:pos x="csX5" y="csY5"/>
+              </a:cxn>
+              <a:cxn ang="0">
+                <a:pos x="csX6" y="csY6"/>
+              </a:cxn>
+              <a:cxn ang="0">
+                <a:pos x="csX7" y="csY7"/>
+              </a:cxn>
+              <a:cxn ang="0">
+                <a:pos x="csX8" y="csY8"/>
+              </a:cxn>
+              <a:cxn ang="0">
+                <a:pos x="csX9" y="csY9"/>
+              </a:cxn>
+              <a:cxn ang="0">
+                <a:pos x="csX10" y="csY10"/>
+              </a:cxn>
+              <a:cxn ang="0">
+                <a:pos x="csX11" y="csY11"/>
+              </a:cxn>
+            </a:cxnLst>
+            <a:rect l="l" t="t" r="r" b="b"/>
+            <a:pathLst>
+              <a:path w="3255095" h="18288" fill="none" extrusionOk="0">
+                <a:moveTo>
+                  <a:pt x="0" y="0"/>
+                </a:moveTo>
+                <a:cubicBezTo>
+                  <a:pt x="240201" y="-22123"/>
+                  <a:pt x="462021" y="-19623"/>
+                  <a:pt x="618468" y="0"/>
+                </a:cubicBezTo>
+                <a:cubicBezTo>
+                  <a:pt x="774915" y="19623"/>
+                  <a:pt x="974734" y="2035"/>
+                  <a:pt x="1269487" y="0"/>
+                </a:cubicBezTo>
+                <a:cubicBezTo>
+                  <a:pt x="1564240" y="-2035"/>
+                  <a:pt x="1733579" y="10639"/>
+                  <a:pt x="1953057" y="0"/>
+                </a:cubicBezTo>
+                <a:cubicBezTo>
+                  <a:pt x="2172535" y="-10639"/>
+                  <a:pt x="2453962" y="14018"/>
+                  <a:pt x="2636627" y="0"/>
+                </a:cubicBezTo>
+                <a:cubicBezTo>
+                  <a:pt x="2819292" y="-14018"/>
+                  <a:pt x="3121375" y="5399"/>
+                  <a:pt x="3255095" y="0"/>
+                </a:cubicBezTo>
+                <a:cubicBezTo>
+                  <a:pt x="3254386" y="8157"/>
+                  <a:pt x="3254682" y="12125"/>
+                  <a:pt x="3255095" y="18288"/>
+                </a:cubicBezTo>
+                <a:cubicBezTo>
+                  <a:pt x="3088545" y="23203"/>
+                  <a:pt x="2687475" y="7419"/>
+                  <a:pt x="2538974" y="18288"/>
+                </a:cubicBezTo>
+                <a:cubicBezTo>
+                  <a:pt x="2390473" y="29157"/>
+                  <a:pt x="2137381" y="-8959"/>
+                  <a:pt x="1822853" y="18288"/>
+                </a:cubicBezTo>
+                <a:cubicBezTo>
+                  <a:pt x="1508325" y="45535"/>
+                  <a:pt x="1466437" y="20385"/>
+                  <a:pt x="1171834" y="18288"/>
+                </a:cubicBezTo>
+                <a:cubicBezTo>
+                  <a:pt x="877231" y="16191"/>
+                  <a:pt x="561097" y="37643"/>
+                  <a:pt x="0" y="18288"/>
+                </a:cubicBezTo>
+                <a:cubicBezTo>
+                  <a:pt x="-46" y="12483"/>
+                  <a:pt x="-203" y="6491"/>
+                  <a:pt x="0" y="0"/>
+                </a:cubicBezTo>
+                <a:close/>
+              </a:path>
+              <a:path w="3255095" h="18288" stroke="0" extrusionOk="0">
+                <a:moveTo>
+                  <a:pt x="0" y="0"/>
+                </a:moveTo>
+                <a:cubicBezTo>
+                  <a:pt x="291965" y="19429"/>
+                  <a:pt x="363155" y="8568"/>
+                  <a:pt x="618468" y="0"/>
+                </a:cubicBezTo>
+                <a:cubicBezTo>
+                  <a:pt x="873781" y="-8568"/>
+                  <a:pt x="904459" y="-19505"/>
+                  <a:pt x="1171834" y="0"/>
+                </a:cubicBezTo>
+                <a:cubicBezTo>
+                  <a:pt x="1439209" y="19505"/>
+                  <a:pt x="1744369" y="9790"/>
+                  <a:pt x="1887955" y="0"/>
+                </a:cubicBezTo>
+                <a:cubicBezTo>
+                  <a:pt x="2031541" y="-9790"/>
+                  <a:pt x="2346378" y="21240"/>
+                  <a:pt x="2506423" y="0"/>
+                </a:cubicBezTo>
+                <a:cubicBezTo>
+                  <a:pt x="2666468" y="-21240"/>
+                  <a:pt x="2990257" y="30414"/>
+                  <a:pt x="3255095" y="0"/>
+                </a:cubicBezTo>
+                <a:cubicBezTo>
+                  <a:pt x="3254831" y="4493"/>
+                  <a:pt x="3255479" y="9472"/>
+                  <a:pt x="3255095" y="18288"/>
+                </a:cubicBezTo>
+                <a:cubicBezTo>
+                  <a:pt x="3120743" y="16690"/>
+                  <a:pt x="2759628" y="42462"/>
+                  <a:pt x="2604076" y="18288"/>
+                </a:cubicBezTo>
+                <a:cubicBezTo>
+                  <a:pt x="2448524" y="-5886"/>
+                  <a:pt x="2184336" y="19599"/>
+                  <a:pt x="1887955" y="18288"/>
+                </a:cubicBezTo>
+                <a:cubicBezTo>
+                  <a:pt x="1591574" y="16977"/>
+                  <a:pt x="1548845" y="6870"/>
+                  <a:pt x="1334589" y="18288"/>
+                </a:cubicBezTo>
+                <a:cubicBezTo>
+                  <a:pt x="1120333" y="29706"/>
+                  <a:pt x="996014" y="9662"/>
+                  <a:pt x="683570" y="18288"/>
+                </a:cubicBezTo>
+                <a:cubicBezTo>
+                  <a:pt x="371126" y="26914"/>
+                  <a:pt x="198687" y="16167"/>
+                  <a:pt x="0" y="18288"/>
+                </a:cubicBezTo>
+                <a:cubicBezTo>
+                  <a:pt x="843" y="9577"/>
+                  <a:pt x="371" y="6900"/>
+                  <a:pt x="0" y="0"/>
+                </a:cubicBezTo>
+                <a:close/>
+              </a:path>
+            </a:pathLst>
+          </a:custGeom>
+          <a:solidFill>
+            <a:schemeClr val="accent2"/>
+          </a:solidFill>
+          <a:ln w="38100" cap="rnd">
+            <a:solidFill>
+              <a:schemeClr val="accent2"/>
+            </a:solidFill>
+            <a:round/>
+            <a:extLst>
+              <a:ext uri="{C807C97D-BFC1-408E-A445-0C87EB9F89A2}">
+                <ask:lineSketchStyleProps xmlns:ask="http://schemas.microsoft.com/office/drawing/2018/sketchyshapes" sd="1219033472">
+                  <a:prstGeom prst="rect">
+                    <a:avLst/>
+                  </a:prstGeom>
+                  <ask:type>
+                    <ask:lineSketchFreehand/>
+                  </ask:type>
+                </ask:lineSketchStyleProps>
+              </a:ext>
+            </a:extLst>
+          </a:ln>
+        </p:spPr>
+        <p:style>
+          <a:lnRef idx="2">
+            <a:schemeClr val="accent1">
+              <a:shade val="50000"/>
+            </a:schemeClr>
+          </a:lnRef>
+          <a:fillRef idx="1">
+            <a:schemeClr val="accent1"/>
+          </a:fillRef>
+          <a:effectRef idx="0">
+            <a:schemeClr val="accent1"/>
+          </a:effectRef>
+          <a:fontRef idx="minor">
+            <a:schemeClr val="lt1"/>
+          </a:fontRef>
+        </p:style>
+        <p:txBody>
+          <a:bodyPr rtlCol="0" anchor="ctr"/>
+          <a:lstStyle/>
+          <a:p>
+            <a:pPr algn="ctr"/>
+            <a:endParaRPr lang="en-US"/>
+          </a:p>
+        </p:txBody>
+      </p:sp>
+      <p:sp>
+        <p:nvSpPr>
+          <p:cNvPr id="5" name="TextBox 4">
+            <a:extLst>
+              <a:ext uri="{FF2B5EF4-FFF2-40B4-BE49-F238E27FC236}">
+                <a16:creationId xmlns:a16="http://schemas.microsoft.com/office/drawing/2014/main" id="{974F3E77-AB24-140C-0382-5B7829BB80D1}"/>
+              </a:ext>
+            </a:extLst>
+          </p:cNvPr>
+          <p:cNvSpPr txBox="1"/>
+          <p:nvPr/>
+        </p:nvSpPr>
+        <p:spPr>
+          <a:xfrm>
+            <a:off x="630936" y="2807208"/>
+            <a:ext cx="3429000" cy="3410712"/>
+          </a:xfrm>
+          <a:prstGeom prst="rect">
+            <a:avLst/>
+          </a:prstGeom>
+        </p:spPr>
+        <p:txBody>
+          <a:bodyPr vert="horz" lIns="91440" tIns="45720" rIns="91440" bIns="45720" rtlCol="0" anchor="t">
+            <a:normAutofit/>
+          </a:bodyPr>
+          <a:lstStyle/>
+          <a:p>
+            <a:pPr>
+              <a:lnSpc>
+                <a:spcPct val="90000"/>
+              </a:lnSpc>
+              <a:spcAft>
+                <a:spcPts val="938"/>
+              </a:spcAft>
+            </a:pPr>
+            <a:r>
+              <a:rPr lang="en-US" sz="1500" b="0" i="0" dirty="0">
+                <a:effectLst/>
+              </a:rPr>
+              <a:t>If Paged Attention improves memory efficiency, </a:t>
+            </a:r>
+            <a:r>
+              <a:rPr lang="en-US" sz="1500" b="1" i="0" dirty="0">
+                <a:effectLst/>
+              </a:rPr>
+              <a:t>Continuous Batching</a:t>
+            </a:r>
+            <a:r>
+              <a:rPr lang="en-US" sz="1500" b="0" i="0" dirty="0">
+                <a:effectLst/>
+              </a:rPr>
+              <a:t> maximizes GPU computation efficiency.</a:t>
+            </a:r>
+          </a:p>
+          <a:p>
+            <a:pPr indent="-228600">
+              <a:lnSpc>
+                <a:spcPct val="90000"/>
+              </a:lnSpc>
+              <a:spcAft>
+                <a:spcPts val="938"/>
+              </a:spcAft>
+              <a:buFont typeface="Arial" panose="020B0604020202020204" pitchFamily="34" charset="0"/>
+              <a:buChar char="•"/>
+            </a:pPr>
+            <a:r>
+              <a:rPr lang="en-US" sz="1500" b="0" i="0" dirty="0">
+                <a:effectLst/>
+              </a:rPr>
+              <a:t>Traditional batch inference:</a:t>
+            </a:r>
+          </a:p>
+          <a:p>
+            <a:pPr indent="-228600">
+              <a:lnSpc>
+                <a:spcPct val="90000"/>
+              </a:lnSpc>
+              <a:spcAft>
+                <a:spcPts val="938"/>
+              </a:spcAft>
+              <a:buFont typeface="Arial" panose="020B0604020202020204" pitchFamily="34" charset="0"/>
+              <a:buChar char="•"/>
+            </a:pPr>
+            <a:r>
+              <a:rPr lang="en-US" sz="1500" b="0" i="0" dirty="0">
+                <a:effectLst/>
+              </a:rPr>
+              <a:t>Collect requests → form a batch → process the entire batch → then move to the next batch But LLM requests differ in completion time (due to different output lengths). Thus, while a slow request continues, faster requests </a:t>
+            </a:r>
+            <a:r>
+              <a:rPr lang="en-US" sz="1500" b="1" i="0" dirty="0">
+                <a:effectLst/>
+              </a:rPr>
+              <a:t>remain stuck waiting</a:t>
+            </a:r>
+            <a:r>
+              <a:rPr lang="en-US" sz="1500" b="0" i="0" dirty="0">
+                <a:effectLst/>
+              </a:rPr>
+              <a:t>, wasting GPU compute capacity.</a:t>
+            </a:r>
+          </a:p>
+        </p:txBody>
+      </p:sp>
+      <p:pic>
+        <p:nvPicPr>
+          <p:cNvPr id="6" name="Picture 5">
+            <a:extLst>
+              <a:ext uri="{FF2B5EF4-FFF2-40B4-BE49-F238E27FC236}">
+                <a16:creationId xmlns:a16="http://schemas.microsoft.com/office/drawing/2014/main" id="{03002B1A-8649-3968-9123-7D1FED715BA4}"/>
+              </a:ext>
+            </a:extLst>
+          </p:cNvPr>
+          <p:cNvPicPr>
+            <a:picLocks noChangeAspect="1"/>
+          </p:cNvPicPr>
+          <p:nvPr/>
+        </p:nvPicPr>
+        <p:blipFill>
+          <a:blip r:embed="rId3"/>
+          <a:stretch>
+            <a:fillRect/>
+          </a:stretch>
+        </p:blipFill>
+        <p:spPr>
+          <a:xfrm>
+            <a:off x="4654296" y="1944700"/>
+            <a:ext cx="6903720" cy="2968600"/>
+          </a:xfrm>
+          <a:prstGeom prst="rect">
+            <a:avLst/>
+          </a:prstGeom>
+        </p:spPr>
+      </p:pic>
+    </p:spTree>
+    <p:extLst>
+      <p:ext uri="{BB962C8B-B14F-4D97-AF65-F5344CB8AC3E}">
+        <p14:creationId xmlns:p14="http://schemas.microsoft.com/office/powerpoint/2010/main" val="3911955687"/>
+      </p:ext>
+    </p:extLst>
+  </p:cSld>
+  <p:clrMapOvr>
+    <a:masterClrMapping/>
+  </p:clrMapOvr>
+</p:sld>
+</file>
+
+<file path=ppt/slides/slide12.xml><?xml version="1.0" encoding="utf-8"?>
+<p:sld xmlns:a="http://schemas.openxmlformats.org/drawingml/2006/main" xmlns:r="http://schemas.openxmlformats.org/officeDocument/2006/relationships" xmlns:p="http://schemas.openxmlformats.org/presentationml/2006/main">
+  <p:cSld>
+    <p:bg>
+      <p:bgPr>
+        <a:solidFill>
+          <a:schemeClr val="bg1"/>
+        </a:solidFill>
+        <a:effectLst/>
+      </p:bgPr>
+    </p:bg>
+    <p:spTree>
+      <p:nvGrpSpPr>
+        <p:cNvPr id="1" name="">
+          <a:extLst>
+            <a:ext uri="{FF2B5EF4-FFF2-40B4-BE49-F238E27FC236}">
+              <a16:creationId xmlns:a16="http://schemas.microsoft.com/office/drawing/2014/main" id="{B51BA401-DB5F-9955-0BB0-A83AE286F97E}"/>
+            </a:ext>
+          </a:extLst>
+        </p:cNvPr>
+        <p:cNvGrpSpPr/>
+        <p:nvPr/>
+      </p:nvGrpSpPr>
+      <p:grpSpPr>
+        <a:xfrm>
+          <a:off x="0" y="0"/>
+          <a:ext cx="0" cy="0"/>
+          <a:chOff x="0" y="0"/>
+          <a:chExt cx="0" cy="0"/>
+        </a:xfrm>
+      </p:grpSpPr>
+      <p:sp useBgFill="1">
+        <p:nvSpPr>
+          <p:cNvPr id="91" name="Rectangle 90">
+            <a:extLst>
+              <a:ext uri="{FF2B5EF4-FFF2-40B4-BE49-F238E27FC236}">
+                <a16:creationId xmlns:a16="http://schemas.microsoft.com/office/drawing/2014/main" id="{2B97F24A-32CE-4C1C-A50D-3016B394DCFB}"/>
+              </a:ext>
+              <a:ext uri="{C183D7F6-B498-43B3-948B-1728B52AA6E4}">
+                <adec:decorative xmlns:adec="http://schemas.microsoft.com/office/drawing/2017/decorative" val="1"/>
+              </a:ext>
+            </a:extLst>
+          </p:cNvPr>
+          <p:cNvSpPr>
+            <a:spLocks noGrp="1" noRot="1" noChangeAspect="1" noMove="1" noResize="1" noEditPoints="1" noAdjustHandles="1" noChangeArrowheads="1" noChangeShapeType="1" noTextEdit="1"/>
+          </p:cNvSpPr>
+          <p:nvPr>
+            <p:extLst>
+              <p:ext uri="{386F3935-93C4-4BCD-93E2-E3B085C9AB24}">
+                <p16:designElem xmlns:p16="http://schemas.microsoft.com/office/powerpoint/2015/main" val="1"/>
+              </p:ext>
+            </p:extLst>
+          </p:nvPr>
+        </p:nvSpPr>
+        <p:spPr>
+          <a:xfrm>
+            <a:off x="0" y="0"/>
+            <a:ext cx="12192000" cy="6858000"/>
+          </a:xfrm>
+          <a:prstGeom prst="rect">
+            <a:avLst/>
+          </a:prstGeom>
+          <a:ln>
+            <a:noFill/>
+          </a:ln>
+        </p:spPr>
+        <p:style>
+          <a:lnRef idx="2">
+            <a:schemeClr val="accent1">
+              <a:shade val="50000"/>
+            </a:schemeClr>
+          </a:lnRef>
+          <a:fillRef idx="1">
+            <a:schemeClr val="accent1"/>
+          </a:fillRef>
+          <a:effectRef idx="0">
+            <a:schemeClr val="accent1"/>
+          </a:effectRef>
+          <a:fontRef idx="minor">
+            <a:schemeClr val="lt1"/>
+          </a:fontRef>
+        </p:style>
+        <p:txBody>
+          <a:bodyPr rtlCol="0" anchor="ctr"/>
+          <a:lstStyle/>
+          <a:p>
+            <a:pPr algn="ctr"/>
+            <a:endParaRPr lang="en-US"/>
+          </a:p>
+        </p:txBody>
+      </p:sp>
+      <p:sp>
+        <p:nvSpPr>
+          <p:cNvPr id="2" name="Title 1">
+            <a:extLst>
+              <a:ext uri="{FF2B5EF4-FFF2-40B4-BE49-F238E27FC236}">
+                <a16:creationId xmlns:a16="http://schemas.microsoft.com/office/drawing/2014/main" id="{A1CA99BA-DC6D-6483-485B-185D3D2C88B9}"/>
+              </a:ext>
+            </a:extLst>
+          </p:cNvPr>
+          <p:cNvSpPr>
+            <a:spLocks noGrp="1"/>
+          </p:cNvSpPr>
+          <p:nvPr>
+            <p:ph type="title"/>
+          </p:nvPr>
+        </p:nvSpPr>
+        <p:spPr>
+          <a:xfrm>
+            <a:off x="630936" y="639520"/>
+            <a:ext cx="3429000" cy="1719072"/>
+          </a:xfrm>
+        </p:spPr>
+        <p:txBody>
+          <a:bodyPr vert="horz" lIns="91440" tIns="45720" rIns="91440" bIns="45720" rtlCol="0" anchor="b">
+            <a:normAutofit/>
+          </a:bodyPr>
+          <a:lstStyle/>
+          <a:p>
+            <a:r>
+              <a:rPr lang="en-US" sz="5000" b="1" kern="1200">
+                <a:solidFill>
+                  <a:schemeClr val="tx1"/>
+                </a:solidFill>
+                <a:latin typeface="+mj-lt"/>
+                <a:ea typeface="+mj-ea"/>
+                <a:cs typeface="+mj-cs"/>
+              </a:rPr>
+              <a:t>Continuous Batching</a:t>
+            </a:r>
+          </a:p>
+        </p:txBody>
+      </p:sp>
+      <p:sp>
+        <p:nvSpPr>
+          <p:cNvPr id="92" name="sketch line">
+            <a:extLst>
+              <a:ext uri="{FF2B5EF4-FFF2-40B4-BE49-F238E27FC236}">
+                <a16:creationId xmlns:a16="http://schemas.microsoft.com/office/drawing/2014/main" id="{CD8B4F24-440B-49E9-B85D-733523DC064B}"/>
+              </a:ext>
+              <a:ext uri="{C183D7F6-B498-43B3-948B-1728B52AA6E4}">
+                <adec:decorative xmlns:adec="http://schemas.microsoft.com/office/drawing/2017/decorative" val="1"/>
+              </a:ext>
+            </a:extLst>
+          </p:cNvPr>
+          <p:cNvSpPr>
+            <a:spLocks noGrp="1" noRot="1" noChangeAspect="1" noMove="1" noResize="1" noEditPoints="1" noAdjustHandles="1" noChangeArrowheads="1" noChangeShapeType="1" noTextEdit="1"/>
+          </p:cNvSpPr>
+          <p:nvPr>
+            <p:extLst>
+              <p:ext uri="{386F3935-93C4-4BCD-93E2-E3B085C9AB24}">
+                <p16:designElem xmlns:p16="http://schemas.microsoft.com/office/powerpoint/2015/main" val="1"/>
+              </p:ext>
+            </p:extLst>
+          </p:nvPr>
+        </p:nvSpPr>
+        <p:spPr>
+          <a:xfrm>
+            <a:off x="643278" y="2573756"/>
+            <a:ext cx="3255095" cy="18288"/>
+          </a:xfrm>
+          <a:custGeom>
+            <a:avLst/>
+            <a:gdLst>
+              <a:gd name="csX0" fmla="*/ 0 w 3255095"/>
+              <a:gd name="csY0" fmla="*/ 0 h 18288"/>
+              <a:gd name="csX1" fmla="*/ 618468 w 3255095"/>
+              <a:gd name="csY1" fmla="*/ 0 h 18288"/>
+              <a:gd name="csX2" fmla="*/ 1269487 w 3255095"/>
+              <a:gd name="csY2" fmla="*/ 0 h 18288"/>
+              <a:gd name="csX3" fmla="*/ 1953057 w 3255095"/>
+              <a:gd name="csY3" fmla="*/ 0 h 18288"/>
+              <a:gd name="csX4" fmla="*/ 2636627 w 3255095"/>
+              <a:gd name="csY4" fmla="*/ 0 h 18288"/>
+              <a:gd name="csX5" fmla="*/ 3255095 w 3255095"/>
+              <a:gd name="csY5" fmla="*/ 0 h 18288"/>
+              <a:gd name="csX6" fmla="*/ 3255095 w 3255095"/>
+              <a:gd name="csY6" fmla="*/ 18288 h 18288"/>
+              <a:gd name="csX7" fmla="*/ 2538974 w 3255095"/>
+              <a:gd name="csY7" fmla="*/ 18288 h 18288"/>
+              <a:gd name="csX8" fmla="*/ 1822853 w 3255095"/>
+              <a:gd name="csY8" fmla="*/ 18288 h 18288"/>
+              <a:gd name="csX9" fmla="*/ 1171834 w 3255095"/>
+              <a:gd name="csY9" fmla="*/ 18288 h 18288"/>
+              <a:gd name="csX10" fmla="*/ 0 w 3255095"/>
+              <a:gd name="csY10" fmla="*/ 18288 h 18288"/>
+              <a:gd name="csX11" fmla="*/ 0 w 3255095"/>
+              <a:gd name="csY11" fmla="*/ 0 h 18288"/>
+            </a:gdLst>
+            <a:ahLst/>
+            <a:cxnLst>
+              <a:cxn ang="0">
+                <a:pos x="csX0" y="csY0"/>
+              </a:cxn>
+              <a:cxn ang="0">
+                <a:pos x="csX1" y="csY1"/>
+              </a:cxn>
+              <a:cxn ang="0">
+                <a:pos x="csX2" y="csY2"/>
+              </a:cxn>
+              <a:cxn ang="0">
+                <a:pos x="csX3" y="csY3"/>
+              </a:cxn>
+              <a:cxn ang="0">
+                <a:pos x="csX4" y="csY4"/>
+              </a:cxn>
+              <a:cxn ang="0">
+                <a:pos x="csX5" y="csY5"/>
+              </a:cxn>
+              <a:cxn ang="0">
+                <a:pos x="csX6" y="csY6"/>
+              </a:cxn>
+              <a:cxn ang="0">
+                <a:pos x="csX7" y="csY7"/>
+              </a:cxn>
+              <a:cxn ang="0">
+                <a:pos x="csX8" y="csY8"/>
+              </a:cxn>
+              <a:cxn ang="0">
+                <a:pos x="csX9" y="csY9"/>
+              </a:cxn>
+              <a:cxn ang="0">
+                <a:pos x="csX10" y="csY10"/>
+              </a:cxn>
+              <a:cxn ang="0">
+                <a:pos x="csX11" y="csY11"/>
+              </a:cxn>
+            </a:cxnLst>
+            <a:rect l="l" t="t" r="r" b="b"/>
+            <a:pathLst>
+              <a:path w="3255095" h="18288" fill="none" extrusionOk="0">
+                <a:moveTo>
+                  <a:pt x="0" y="0"/>
+                </a:moveTo>
+                <a:cubicBezTo>
+                  <a:pt x="240201" y="-22123"/>
+                  <a:pt x="462021" y="-19623"/>
+                  <a:pt x="618468" y="0"/>
+                </a:cubicBezTo>
+                <a:cubicBezTo>
+                  <a:pt x="774915" y="19623"/>
+                  <a:pt x="974734" y="2035"/>
+                  <a:pt x="1269487" y="0"/>
+                </a:cubicBezTo>
+                <a:cubicBezTo>
+                  <a:pt x="1564240" y="-2035"/>
+                  <a:pt x="1733579" y="10639"/>
+                  <a:pt x="1953057" y="0"/>
+                </a:cubicBezTo>
+                <a:cubicBezTo>
+                  <a:pt x="2172535" y="-10639"/>
+                  <a:pt x="2453962" y="14018"/>
+                  <a:pt x="2636627" y="0"/>
+                </a:cubicBezTo>
+                <a:cubicBezTo>
+                  <a:pt x="2819292" y="-14018"/>
+                  <a:pt x="3121375" y="5399"/>
+                  <a:pt x="3255095" y="0"/>
+                </a:cubicBezTo>
+                <a:cubicBezTo>
+                  <a:pt x="3254386" y="8157"/>
+                  <a:pt x="3254682" y="12125"/>
+                  <a:pt x="3255095" y="18288"/>
+                </a:cubicBezTo>
+                <a:cubicBezTo>
+                  <a:pt x="3088545" y="23203"/>
+                  <a:pt x="2687475" y="7419"/>
+                  <a:pt x="2538974" y="18288"/>
+                </a:cubicBezTo>
+                <a:cubicBezTo>
+                  <a:pt x="2390473" y="29157"/>
+                  <a:pt x="2137381" y="-8959"/>
+                  <a:pt x="1822853" y="18288"/>
+                </a:cubicBezTo>
+                <a:cubicBezTo>
+                  <a:pt x="1508325" y="45535"/>
+                  <a:pt x="1466437" y="20385"/>
+                  <a:pt x="1171834" y="18288"/>
+                </a:cubicBezTo>
+                <a:cubicBezTo>
+                  <a:pt x="877231" y="16191"/>
+                  <a:pt x="561097" y="37643"/>
+                  <a:pt x="0" y="18288"/>
+                </a:cubicBezTo>
+                <a:cubicBezTo>
+                  <a:pt x="-46" y="12483"/>
+                  <a:pt x="-203" y="6491"/>
+                  <a:pt x="0" y="0"/>
+                </a:cubicBezTo>
+                <a:close/>
+              </a:path>
+              <a:path w="3255095" h="18288" stroke="0" extrusionOk="0">
+                <a:moveTo>
+                  <a:pt x="0" y="0"/>
+                </a:moveTo>
+                <a:cubicBezTo>
+                  <a:pt x="291965" y="19429"/>
+                  <a:pt x="363155" y="8568"/>
+                  <a:pt x="618468" y="0"/>
+                </a:cubicBezTo>
+                <a:cubicBezTo>
+                  <a:pt x="873781" y="-8568"/>
+                  <a:pt x="904459" y="-19505"/>
+                  <a:pt x="1171834" y="0"/>
+                </a:cubicBezTo>
+                <a:cubicBezTo>
+                  <a:pt x="1439209" y="19505"/>
+                  <a:pt x="1744369" y="9790"/>
+                  <a:pt x="1887955" y="0"/>
+                </a:cubicBezTo>
+                <a:cubicBezTo>
+                  <a:pt x="2031541" y="-9790"/>
+                  <a:pt x="2346378" y="21240"/>
+                  <a:pt x="2506423" y="0"/>
+                </a:cubicBezTo>
+                <a:cubicBezTo>
+                  <a:pt x="2666468" y="-21240"/>
+                  <a:pt x="2990257" y="30414"/>
+                  <a:pt x="3255095" y="0"/>
+                </a:cubicBezTo>
+                <a:cubicBezTo>
+                  <a:pt x="3254831" y="4493"/>
+                  <a:pt x="3255479" y="9472"/>
+                  <a:pt x="3255095" y="18288"/>
+                </a:cubicBezTo>
+                <a:cubicBezTo>
+                  <a:pt x="3120743" y="16690"/>
+                  <a:pt x="2759628" y="42462"/>
+                  <a:pt x="2604076" y="18288"/>
+                </a:cubicBezTo>
+                <a:cubicBezTo>
+                  <a:pt x="2448524" y="-5886"/>
+                  <a:pt x="2184336" y="19599"/>
+                  <a:pt x="1887955" y="18288"/>
+                </a:cubicBezTo>
+                <a:cubicBezTo>
+                  <a:pt x="1591574" y="16977"/>
+                  <a:pt x="1548845" y="6870"/>
+                  <a:pt x="1334589" y="18288"/>
+                </a:cubicBezTo>
+                <a:cubicBezTo>
+                  <a:pt x="1120333" y="29706"/>
+                  <a:pt x="996014" y="9662"/>
+                  <a:pt x="683570" y="18288"/>
+                </a:cubicBezTo>
+                <a:cubicBezTo>
+                  <a:pt x="371126" y="26914"/>
+                  <a:pt x="198687" y="16167"/>
+                  <a:pt x="0" y="18288"/>
+                </a:cubicBezTo>
+                <a:cubicBezTo>
+                  <a:pt x="843" y="9577"/>
+                  <a:pt x="371" y="6900"/>
+                  <a:pt x="0" y="0"/>
+                </a:cubicBezTo>
+                <a:close/>
+              </a:path>
+            </a:pathLst>
+          </a:custGeom>
+          <a:solidFill>
+            <a:schemeClr val="accent2"/>
+          </a:solidFill>
+          <a:ln w="38100" cap="rnd">
+            <a:solidFill>
+              <a:schemeClr val="accent2"/>
+            </a:solidFill>
+            <a:round/>
+            <a:extLst>
+              <a:ext uri="{C807C97D-BFC1-408E-A445-0C87EB9F89A2}">
+                <ask:lineSketchStyleProps xmlns:ask="http://schemas.microsoft.com/office/drawing/2018/sketchyshapes" sd="1219033472">
+                  <a:prstGeom prst="rect">
+                    <a:avLst/>
+                  </a:prstGeom>
+                  <ask:type>
+                    <ask:lineSketchFreehand/>
+                  </ask:type>
+                </ask:lineSketchStyleProps>
+              </a:ext>
+            </a:extLst>
+          </a:ln>
+        </p:spPr>
+        <p:style>
+          <a:lnRef idx="2">
+            <a:schemeClr val="accent1">
+              <a:shade val="50000"/>
+            </a:schemeClr>
+          </a:lnRef>
+          <a:fillRef idx="1">
+            <a:schemeClr val="accent1"/>
+          </a:fillRef>
+          <a:effectRef idx="0">
+            <a:schemeClr val="accent1"/>
+          </a:effectRef>
+          <a:fontRef idx="minor">
+            <a:schemeClr val="lt1"/>
+          </a:fontRef>
+        </p:style>
+        <p:txBody>
+          <a:bodyPr rtlCol="0" anchor="ctr"/>
+          <a:lstStyle/>
+          <a:p>
+            <a:pPr algn="ctr"/>
+            <a:endParaRPr lang="en-US"/>
+          </a:p>
+        </p:txBody>
+      </p:sp>
+      <p:sp>
+        <p:nvSpPr>
+          <p:cNvPr id="5" name="TextBox 4">
+            <a:extLst>
+              <a:ext uri="{FF2B5EF4-FFF2-40B4-BE49-F238E27FC236}">
+                <a16:creationId xmlns:a16="http://schemas.microsoft.com/office/drawing/2014/main" id="{3E969908-12E1-30A8-6339-406D2D3F55FB}"/>
+              </a:ext>
+            </a:extLst>
+          </p:cNvPr>
+          <p:cNvSpPr txBox="1"/>
+          <p:nvPr/>
+        </p:nvSpPr>
+        <p:spPr>
+          <a:xfrm>
+            <a:off x="630936" y="2807208"/>
+            <a:ext cx="4931664" cy="3411272"/>
+          </a:xfrm>
+          <a:prstGeom prst="rect">
+            <a:avLst/>
+          </a:prstGeom>
+        </p:spPr>
+        <p:txBody>
+          <a:bodyPr vert="horz" lIns="91440" tIns="45720" rIns="91440" bIns="45720" rtlCol="0" anchor="t">
+            <a:noAutofit/>
+          </a:bodyPr>
+          <a:lstStyle/>
+          <a:p>
+            <a:pPr indent="-228600">
+              <a:lnSpc>
+                <a:spcPct val="90000"/>
+              </a:lnSpc>
+              <a:spcAft>
+                <a:spcPts val="600"/>
+              </a:spcAft>
+              <a:buFont typeface="Arial" panose="020B0604020202020204" pitchFamily="34" charset="0"/>
+              <a:buChar char="•"/>
+            </a:pPr>
+            <a:r>
+              <a:rPr lang="en-US" sz="1200" dirty="0"/>
+              <a:t>Continuous Batching breaks the process into </a:t>
+            </a:r>
+            <a:r>
+              <a:rPr lang="en-US" sz="1200" b="1" dirty="0"/>
+              <a:t>token-generation iterations</a:t>
+            </a:r>
+            <a:r>
+              <a:rPr lang="en-US" sz="1200" dirty="0"/>
+              <a:t>. After each iteration:</a:t>
+            </a:r>
+          </a:p>
+          <a:p>
+            <a:pPr indent="-228600">
+              <a:lnSpc>
+                <a:spcPct val="90000"/>
+              </a:lnSpc>
+              <a:spcAft>
+                <a:spcPts val="600"/>
+              </a:spcAft>
+              <a:buFont typeface="Arial" panose="020B0604020202020204" pitchFamily="34" charset="0"/>
+              <a:buChar char="•"/>
+            </a:pPr>
+            <a:r>
+              <a:rPr lang="en-US" sz="1200" dirty="0"/>
+              <a:t>Finished requests exit the batch immediately</a:t>
+            </a:r>
+          </a:p>
+          <a:p>
+            <a:pPr indent="-228600">
+              <a:lnSpc>
+                <a:spcPct val="90000"/>
+              </a:lnSpc>
+              <a:spcAft>
+                <a:spcPts val="600"/>
+              </a:spcAft>
+              <a:buFont typeface="Arial" panose="020B0604020202020204" pitchFamily="34" charset="0"/>
+              <a:buChar char="•"/>
+            </a:pPr>
+            <a:r>
+              <a:rPr lang="en-US" sz="1200" dirty="0"/>
+              <a:t>Newly arrived requests join the batch instantly</a:t>
+            </a:r>
+          </a:p>
+          <a:p>
+            <a:pPr indent="-228600">
+              <a:lnSpc>
+                <a:spcPct val="90000"/>
+              </a:lnSpc>
+              <a:spcAft>
+                <a:spcPts val="600"/>
+              </a:spcAft>
+              <a:buFont typeface="Arial" panose="020B0604020202020204" pitchFamily="34" charset="0"/>
+              <a:buChar char="•"/>
+            </a:pPr>
+            <a:r>
+              <a:rPr lang="en-US" sz="1200" dirty="0"/>
+              <a:t>This makes the batch a </a:t>
+            </a:r>
+            <a:r>
+              <a:rPr lang="en-US" sz="1200" b="1" dirty="0"/>
+              <a:t>continuously updating structure</a:t>
+            </a:r>
+            <a:r>
+              <a:rPr lang="en-US" sz="1200" dirty="0"/>
+              <a:t> rather than a fixed one.</a:t>
+            </a:r>
+          </a:p>
+          <a:p>
+            <a:pPr indent="-228600">
+              <a:lnSpc>
+                <a:spcPct val="90000"/>
+              </a:lnSpc>
+              <a:spcAft>
+                <a:spcPts val="600"/>
+              </a:spcAft>
+              <a:buFont typeface="Arial" panose="020B0604020202020204" pitchFamily="34" charset="0"/>
+              <a:buChar char="•"/>
+            </a:pPr>
+            <a:endParaRPr lang="en-US" sz="1200" dirty="0"/>
+          </a:p>
+          <a:p>
+            <a:pPr indent="-228600">
+              <a:lnSpc>
+                <a:spcPct val="90000"/>
+              </a:lnSpc>
+              <a:spcAft>
+                <a:spcPts val="600"/>
+              </a:spcAft>
+              <a:buFont typeface="Arial" panose="020B0604020202020204" pitchFamily="34" charset="0"/>
+              <a:buChar char="•"/>
+            </a:pPr>
+            <a:r>
+              <a:rPr lang="en-US" sz="1200" dirty="0"/>
+              <a:t>This reduces GPU idle time and allows </a:t>
+            </a:r>
+            <a:r>
+              <a:rPr lang="en-US" sz="1200" b="1" dirty="0"/>
+              <a:t>far more requests</a:t>
+            </a:r>
+            <a:r>
+              <a:rPr lang="en-US" sz="1200" dirty="0"/>
+              <a:t> to be processed within the same timeframe. In particular, for environments with many short requests mixed with long ones, user-perceived latency improves dramatically.</a:t>
+            </a:r>
+          </a:p>
+          <a:p>
+            <a:pPr indent="-228600">
+              <a:lnSpc>
+                <a:spcPct val="90000"/>
+              </a:lnSpc>
+              <a:spcAft>
+                <a:spcPts val="600"/>
+              </a:spcAft>
+              <a:buFont typeface="Arial" panose="020B0604020202020204" pitchFamily="34" charset="0"/>
+              <a:buChar char="•"/>
+            </a:pPr>
+            <a:r>
+              <a:rPr lang="en-US" sz="1200" dirty="0"/>
+              <a:t>With:</a:t>
+            </a:r>
+          </a:p>
+          <a:p>
+            <a:pPr indent="-228600">
+              <a:lnSpc>
+                <a:spcPct val="90000"/>
+              </a:lnSpc>
+              <a:spcAft>
+                <a:spcPts val="600"/>
+              </a:spcAft>
+              <a:buFont typeface="Arial" panose="020B0604020202020204" pitchFamily="34" charset="0"/>
+              <a:buChar char="•"/>
+            </a:pPr>
+            <a:endParaRPr lang="en-US" sz="1200" dirty="0"/>
+          </a:p>
+          <a:p>
+            <a:pPr indent="-228600">
+              <a:lnSpc>
+                <a:spcPct val="90000"/>
+              </a:lnSpc>
+              <a:spcAft>
+                <a:spcPts val="600"/>
+              </a:spcAft>
+              <a:buFont typeface="Arial" panose="020B0604020202020204" pitchFamily="34" charset="0"/>
+              <a:buChar char="•"/>
+            </a:pPr>
+            <a:r>
+              <a:rPr lang="en-US" sz="1200" b="1" dirty="0"/>
+              <a:t>Paged Attention → efficient memory use</a:t>
+            </a:r>
+            <a:r>
+              <a:rPr lang="en-US" sz="1200" dirty="0"/>
+              <a:t>, and</a:t>
+            </a:r>
+          </a:p>
+          <a:p>
+            <a:pPr indent="-228600">
+              <a:lnSpc>
+                <a:spcPct val="90000"/>
+              </a:lnSpc>
+              <a:spcAft>
+                <a:spcPts val="600"/>
+              </a:spcAft>
+              <a:buFont typeface="Arial" panose="020B0604020202020204" pitchFamily="34" charset="0"/>
+              <a:buChar char="•"/>
+            </a:pPr>
+            <a:r>
+              <a:rPr lang="en-US" sz="1200" b="1" dirty="0"/>
+              <a:t>Continuous Batching → maximal compute utilization</a:t>
+            </a:r>
+            <a:r>
+              <a:rPr lang="en-US" sz="1200" dirty="0"/>
+              <a:t>,</a:t>
+            </a:r>
+          </a:p>
+          <a:p>
+            <a:pPr indent="-228600">
+              <a:lnSpc>
+                <a:spcPct val="90000"/>
+              </a:lnSpc>
+              <a:spcAft>
+                <a:spcPts val="600"/>
+              </a:spcAft>
+              <a:buFont typeface="Arial" panose="020B0604020202020204" pitchFamily="34" charset="0"/>
+              <a:buChar char="•"/>
+            </a:pPr>
+            <a:endParaRPr lang="en-US" sz="1200" dirty="0"/>
+          </a:p>
+        </p:txBody>
+      </p:sp>
+      <p:pic>
+        <p:nvPicPr>
+          <p:cNvPr id="3" name="Picture 2">
+            <a:extLst>
+              <a:ext uri="{FF2B5EF4-FFF2-40B4-BE49-F238E27FC236}">
+                <a16:creationId xmlns:a16="http://schemas.microsoft.com/office/drawing/2014/main" id="{D835F546-05D8-A20B-0A29-61705D45A394}"/>
+              </a:ext>
+            </a:extLst>
+          </p:cNvPr>
+          <p:cNvPicPr>
+            <a:picLocks noChangeAspect="1"/>
+          </p:cNvPicPr>
+          <p:nvPr/>
+        </p:nvPicPr>
+        <p:blipFill>
+          <a:blip r:embed="rId3"/>
+          <a:stretch>
+            <a:fillRect/>
+          </a:stretch>
+        </p:blipFill>
+        <p:spPr>
+          <a:xfrm>
+            <a:off x="5816600" y="1953330"/>
+            <a:ext cx="5741416" cy="2454456"/>
+          </a:xfrm>
+          <a:prstGeom prst="rect">
+            <a:avLst/>
+          </a:prstGeom>
+        </p:spPr>
+      </p:pic>
+    </p:spTree>
+    <p:extLst>
+      <p:ext uri="{BB962C8B-B14F-4D97-AF65-F5344CB8AC3E}">
+        <p14:creationId xmlns:p14="http://schemas.microsoft.com/office/powerpoint/2010/main" val="2421950582"/>
+      </p:ext>
+    </p:extLst>
+  </p:cSld>
+  <p:clrMapOvr>
+    <a:masterClrMapping/>
+  </p:clrMapOvr>
+</p:sld>
+</file>
+
+<file path=ppt/slides/slide13.xml><?xml version="1.0" encoding="utf-8"?>
+<p:sld xmlns:a="http://schemas.openxmlformats.org/drawingml/2006/main" xmlns:r="http://schemas.openxmlformats.org/officeDocument/2006/relationships" xmlns:p="http://schemas.openxmlformats.org/presentationml/2006/main">
+  <p:cSld>
+    <p:bg>
+      <p:bgPr>
+        <a:solidFill>
+          <a:schemeClr val="bg1"/>
+        </a:solidFill>
+        <a:effectLst/>
+      </p:bgPr>
+    </p:bg>
+    <p:spTree>
+      <p:nvGrpSpPr>
+        <p:cNvPr id="1" name="">
+          <a:extLst>
+            <a:ext uri="{FF2B5EF4-FFF2-40B4-BE49-F238E27FC236}">
+              <a16:creationId xmlns:a16="http://schemas.microsoft.com/office/drawing/2014/main" id="{D8140342-81B1-8651-BE9F-4BEAAACB35A8}"/>
+            </a:ext>
+          </a:extLst>
+        </p:cNvPr>
+        <p:cNvGrpSpPr/>
+        <p:nvPr/>
+      </p:nvGrpSpPr>
+      <p:grpSpPr>
+        <a:xfrm>
+          <a:off x="0" y="0"/>
+          <a:ext cx="0" cy="0"/>
+          <a:chOff x="0" y="0"/>
+          <a:chExt cx="0" cy="0"/>
+        </a:xfrm>
+      </p:grpSpPr>
+      <p:sp useBgFill="1">
+        <p:nvSpPr>
+          <p:cNvPr id="101" name="Rectangle 100">
+            <a:extLst>
+              <a:ext uri="{FF2B5EF4-FFF2-40B4-BE49-F238E27FC236}">
+                <a16:creationId xmlns:a16="http://schemas.microsoft.com/office/drawing/2014/main" id="{BCED4D40-4B67-4331-AC48-79B82B4A47D8}"/>
+              </a:ext>
+              <a:ext uri="{C183D7F6-B498-43B3-948B-1728B52AA6E4}">
+                <adec:decorative xmlns:adec="http://schemas.microsoft.com/office/drawing/2017/decorative" val="1"/>
+              </a:ext>
+            </a:extLst>
+          </p:cNvPr>
+          <p:cNvSpPr>
+            <a:spLocks noGrp="1" noRot="1" noChangeAspect="1" noMove="1" noResize="1" noEditPoints="1" noAdjustHandles="1" noChangeArrowheads="1" noChangeShapeType="1" noTextEdit="1"/>
+          </p:cNvSpPr>
+          <p:nvPr>
+            <p:extLst>
+              <p:ext uri="{386F3935-93C4-4BCD-93E2-E3B085C9AB24}">
+                <p16:designElem xmlns:p16="http://schemas.microsoft.com/office/powerpoint/2015/main" val="1"/>
+              </p:ext>
+            </p:extLst>
+          </p:nvPr>
+        </p:nvSpPr>
+        <p:spPr>
+          <a:xfrm>
+            <a:off x="0" y="0"/>
+            <a:ext cx="12192000" cy="6858000"/>
+          </a:xfrm>
+          <a:prstGeom prst="rect">
+            <a:avLst/>
+          </a:prstGeom>
+          <a:ln>
+            <a:noFill/>
+          </a:ln>
+        </p:spPr>
+        <p:style>
+          <a:lnRef idx="2">
+            <a:schemeClr val="accent1">
+              <a:shade val="50000"/>
+            </a:schemeClr>
+          </a:lnRef>
+          <a:fillRef idx="1">
+            <a:schemeClr val="accent1"/>
+          </a:fillRef>
+          <a:effectRef idx="0">
+            <a:schemeClr val="accent1"/>
+          </a:effectRef>
+          <a:fontRef idx="minor">
+            <a:schemeClr val="lt1"/>
+          </a:fontRef>
+        </p:style>
+        <p:txBody>
+          <a:bodyPr rtlCol="0" anchor="ctr"/>
+          <a:lstStyle/>
+          <a:p>
+            <a:pPr algn="ctr"/>
+            <a:endParaRPr lang="en-US"/>
+          </a:p>
+        </p:txBody>
+      </p:sp>
+      <p:sp>
+        <p:nvSpPr>
+          <p:cNvPr id="2" name="Title 1">
+            <a:extLst>
+              <a:ext uri="{FF2B5EF4-FFF2-40B4-BE49-F238E27FC236}">
+                <a16:creationId xmlns:a16="http://schemas.microsoft.com/office/drawing/2014/main" id="{DE1CBF9E-9FC5-134B-9AAE-546D0131AF9F}"/>
+              </a:ext>
+            </a:extLst>
+          </p:cNvPr>
+          <p:cNvSpPr>
+            <a:spLocks noGrp="1"/>
+          </p:cNvSpPr>
+          <p:nvPr>
+            <p:ph type="title"/>
+          </p:nvPr>
+        </p:nvSpPr>
+        <p:spPr>
+          <a:xfrm>
+            <a:off x="638881" y="417576"/>
+            <a:ext cx="10909640" cy="1249394"/>
+          </a:xfrm>
+        </p:spPr>
+        <p:txBody>
+          <a:bodyPr vert="horz" lIns="91440" tIns="45720" rIns="91440" bIns="45720" rtlCol="0" anchor="ctr">
+            <a:normAutofit/>
+          </a:bodyPr>
+          <a:lstStyle/>
+          <a:p>
+            <a:pPr algn="ctr"/>
+            <a:r>
+              <a:rPr lang="en-US" sz="6600" b="1" kern="1200">
+                <a:solidFill>
+                  <a:schemeClr val="tx1"/>
+                </a:solidFill>
+                <a:latin typeface="+mj-lt"/>
+                <a:ea typeface="+mj-ea"/>
+                <a:cs typeface="+mj-cs"/>
+              </a:rPr>
+              <a:t>Continuous Batching</a:t>
+            </a:r>
+          </a:p>
+        </p:txBody>
+      </p:sp>
+      <p:sp>
+        <p:nvSpPr>
+          <p:cNvPr id="102" name="sketch line">
+            <a:extLst>
+              <a:ext uri="{FF2B5EF4-FFF2-40B4-BE49-F238E27FC236}">
+                <a16:creationId xmlns:a16="http://schemas.microsoft.com/office/drawing/2014/main" id="{670CEDEF-4F34-412E-84EE-329C1E936AF5}"/>
+              </a:ext>
+              <a:ext uri="{C183D7F6-B498-43B3-948B-1728B52AA6E4}">
+                <adec:decorative xmlns:adec="http://schemas.microsoft.com/office/drawing/2017/decorative" val="1"/>
+              </a:ext>
+            </a:extLst>
+          </p:cNvPr>
+          <p:cNvSpPr>
+            <a:spLocks noGrp="1" noRot="1" noChangeAspect="1" noMove="1" noResize="1" noEditPoints="1" noAdjustHandles="1" noChangeArrowheads="1" noChangeShapeType="1" noTextEdit="1"/>
+          </p:cNvSpPr>
+          <p:nvPr>
+            <p:extLst>
+              <p:ext uri="{386F3935-93C4-4BCD-93E2-E3B085C9AB24}">
+                <p16:designElem xmlns:p16="http://schemas.microsoft.com/office/powerpoint/2015/main" val="1"/>
+              </p:ext>
+            </p:extLst>
+          </p:nvPr>
+        </p:nvSpPr>
+        <p:spPr>
+          <a:xfrm>
+            <a:off x="3807702" y="1733454"/>
+            <a:ext cx="4572000" cy="18288"/>
+          </a:xfrm>
+          <a:custGeom>
+            <a:avLst/>
+            <a:gdLst>
+              <a:gd name="csX0" fmla="*/ 0 w 4572000"/>
+              <a:gd name="csY0" fmla="*/ 0 h 18288"/>
+              <a:gd name="csX1" fmla="*/ 515983 w 4572000"/>
+              <a:gd name="csY1" fmla="*/ 0 h 18288"/>
+              <a:gd name="csX2" fmla="*/ 1031966 w 4572000"/>
+              <a:gd name="csY2" fmla="*/ 0 h 18288"/>
+              <a:gd name="csX3" fmla="*/ 1639389 w 4572000"/>
+              <a:gd name="csY3" fmla="*/ 0 h 18288"/>
+              <a:gd name="csX4" fmla="*/ 2383971 w 4572000"/>
+              <a:gd name="csY4" fmla="*/ 0 h 18288"/>
+              <a:gd name="csX5" fmla="*/ 2945674 w 4572000"/>
+              <a:gd name="csY5" fmla="*/ 0 h 18288"/>
+              <a:gd name="csX6" fmla="*/ 3507377 w 4572000"/>
+              <a:gd name="csY6" fmla="*/ 0 h 18288"/>
+              <a:gd name="csX7" fmla="*/ 4572000 w 4572000"/>
+              <a:gd name="csY7" fmla="*/ 0 h 18288"/>
+              <a:gd name="csX8" fmla="*/ 4572000 w 4572000"/>
+              <a:gd name="csY8" fmla="*/ 18288 h 18288"/>
+              <a:gd name="csX9" fmla="*/ 3873137 w 4572000"/>
+              <a:gd name="csY9" fmla="*/ 18288 h 18288"/>
+              <a:gd name="csX10" fmla="*/ 3311434 w 4572000"/>
+              <a:gd name="csY10" fmla="*/ 18288 h 18288"/>
+              <a:gd name="csX11" fmla="*/ 2749731 w 4572000"/>
+              <a:gd name="csY11" fmla="*/ 18288 h 18288"/>
+              <a:gd name="csX12" fmla="*/ 2050869 w 4572000"/>
+              <a:gd name="csY12" fmla="*/ 18288 h 18288"/>
+              <a:gd name="csX13" fmla="*/ 1306286 w 4572000"/>
+              <a:gd name="csY13" fmla="*/ 18288 h 18288"/>
+              <a:gd name="csX14" fmla="*/ 790303 w 4572000"/>
+              <a:gd name="csY14" fmla="*/ 18288 h 18288"/>
+              <a:gd name="csX15" fmla="*/ 0 w 4572000"/>
+              <a:gd name="csY15" fmla="*/ 18288 h 18288"/>
+              <a:gd name="csX16" fmla="*/ 0 w 4572000"/>
+              <a:gd name="csY16" fmla="*/ 0 h 18288"/>
+            </a:gdLst>
+            <a:ahLst/>
+            <a:cxnLst>
+              <a:cxn ang="0">
+                <a:pos x="csX0" y="csY0"/>
+              </a:cxn>
+              <a:cxn ang="0">
+                <a:pos x="csX1" y="csY1"/>
+              </a:cxn>
+              <a:cxn ang="0">
+                <a:pos x="csX2" y="csY2"/>
+              </a:cxn>
+              <a:cxn ang="0">
+                <a:pos x="csX3" y="csY3"/>
+              </a:cxn>
+              <a:cxn ang="0">
+                <a:pos x="csX4" y="csY4"/>
+              </a:cxn>
+              <a:cxn ang="0">
+                <a:pos x="csX5" y="csY5"/>
+              </a:cxn>
+              <a:cxn ang="0">
+                <a:pos x="csX6" y="csY6"/>
+              </a:cxn>
+              <a:cxn ang="0">
+                <a:pos x="csX7" y="csY7"/>
+              </a:cxn>
+              <a:cxn ang="0">
+                <a:pos x="csX8" y="csY8"/>
+              </a:cxn>
+              <a:cxn ang="0">
+                <a:pos x="csX9" y="csY9"/>
+              </a:cxn>
+              <a:cxn ang="0">
+                <a:pos x="csX10" y="csY10"/>
+              </a:cxn>
+              <a:cxn ang="0">
+                <a:pos x="csX11" y="csY11"/>
+              </a:cxn>
+              <a:cxn ang="0">
+                <a:pos x="csX12" y="csY12"/>
+              </a:cxn>
+              <a:cxn ang="0">
+                <a:pos x="csX13" y="csY13"/>
+              </a:cxn>
+              <a:cxn ang="0">
+                <a:pos x="csX14" y="csY14"/>
+              </a:cxn>
+              <a:cxn ang="0">
+                <a:pos x="csX15" y="csY15"/>
+              </a:cxn>
+              <a:cxn ang="0">
+                <a:pos x="csX16" y="csY16"/>
+              </a:cxn>
+            </a:cxnLst>
+            <a:rect l="l" t="t" r="r" b="b"/>
+            <a:pathLst>
+              <a:path w="4572000" h="18288" fill="none" extrusionOk="0">
+                <a:moveTo>
+                  <a:pt x="0" y="0"/>
+                </a:moveTo>
+                <a:cubicBezTo>
+                  <a:pt x="105156" y="-20963"/>
+                  <a:pt x="340432" y="822"/>
+                  <a:pt x="515983" y="0"/>
+                </a:cubicBezTo>
+                <a:cubicBezTo>
+                  <a:pt x="691534" y="-822"/>
+                  <a:pt x="850679" y="16479"/>
+                  <a:pt x="1031966" y="0"/>
+                </a:cubicBezTo>
+                <a:cubicBezTo>
+                  <a:pt x="1213253" y="-16479"/>
+                  <a:pt x="1443646" y="-18730"/>
+                  <a:pt x="1639389" y="0"/>
+                </a:cubicBezTo>
+                <a:cubicBezTo>
+                  <a:pt x="1835132" y="18730"/>
+                  <a:pt x="2159975" y="18531"/>
+                  <a:pt x="2383971" y="0"/>
+                </a:cubicBezTo>
+                <a:cubicBezTo>
+                  <a:pt x="2607967" y="-18531"/>
+                  <a:pt x="2719096" y="-12030"/>
+                  <a:pt x="2945674" y="0"/>
+                </a:cubicBezTo>
+                <a:cubicBezTo>
+                  <a:pt x="3172252" y="12030"/>
+                  <a:pt x="3269167" y="27666"/>
+                  <a:pt x="3507377" y="0"/>
+                </a:cubicBezTo>
+                <a:cubicBezTo>
+                  <a:pt x="3745587" y="-27666"/>
+                  <a:pt x="4116741" y="18705"/>
+                  <a:pt x="4572000" y="0"/>
+                </a:cubicBezTo>
+                <a:cubicBezTo>
+                  <a:pt x="4572895" y="8974"/>
+                  <a:pt x="4571454" y="9359"/>
+                  <a:pt x="4572000" y="18288"/>
+                </a:cubicBezTo>
+                <a:cubicBezTo>
+                  <a:pt x="4374698" y="3942"/>
+                  <a:pt x="4098874" y="-11042"/>
+                  <a:pt x="3873137" y="18288"/>
+                </a:cubicBezTo>
+                <a:cubicBezTo>
+                  <a:pt x="3647400" y="47618"/>
+                  <a:pt x="3517055" y="5421"/>
+                  <a:pt x="3311434" y="18288"/>
+                </a:cubicBezTo>
+                <a:cubicBezTo>
+                  <a:pt x="3105813" y="31155"/>
+                  <a:pt x="3025168" y="17856"/>
+                  <a:pt x="2749731" y="18288"/>
+                </a:cubicBezTo>
+                <a:cubicBezTo>
+                  <a:pt x="2474294" y="18720"/>
+                  <a:pt x="2291766" y="-14168"/>
+                  <a:pt x="2050869" y="18288"/>
+                </a:cubicBezTo>
+                <a:cubicBezTo>
+                  <a:pt x="1809972" y="50744"/>
+                  <a:pt x="1540276" y="46798"/>
+                  <a:pt x="1306286" y="18288"/>
+                </a:cubicBezTo>
+                <a:cubicBezTo>
+                  <a:pt x="1072296" y="-10222"/>
+                  <a:pt x="972445" y="19645"/>
+                  <a:pt x="790303" y="18288"/>
+                </a:cubicBezTo>
+                <a:cubicBezTo>
+                  <a:pt x="608161" y="16931"/>
+                  <a:pt x="200981" y="8241"/>
+                  <a:pt x="0" y="18288"/>
+                </a:cubicBezTo>
+                <a:cubicBezTo>
+                  <a:pt x="-229" y="14222"/>
+                  <a:pt x="509" y="5816"/>
+                  <a:pt x="0" y="0"/>
+                </a:cubicBezTo>
+                <a:close/>
+              </a:path>
+              <a:path w="4572000" h="18288" stroke="0" extrusionOk="0">
+                <a:moveTo>
+                  <a:pt x="0" y="0"/>
+                </a:moveTo>
+                <a:cubicBezTo>
+                  <a:pt x="143285" y="-9565"/>
+                  <a:pt x="327959" y="-11498"/>
+                  <a:pt x="561703" y="0"/>
+                </a:cubicBezTo>
+                <a:cubicBezTo>
+                  <a:pt x="795447" y="11498"/>
+                  <a:pt x="838260" y="18255"/>
+                  <a:pt x="1077686" y="0"/>
+                </a:cubicBezTo>
+                <a:cubicBezTo>
+                  <a:pt x="1317112" y="-18255"/>
+                  <a:pt x="1437472" y="23514"/>
+                  <a:pt x="1639389" y="0"/>
+                </a:cubicBezTo>
+                <a:cubicBezTo>
+                  <a:pt x="1841306" y="-23514"/>
+                  <a:pt x="2037142" y="-12551"/>
+                  <a:pt x="2292531" y="0"/>
+                </a:cubicBezTo>
+                <a:cubicBezTo>
+                  <a:pt x="2547920" y="12551"/>
+                  <a:pt x="2810436" y="-20352"/>
+                  <a:pt x="2991394" y="0"/>
+                </a:cubicBezTo>
+                <a:cubicBezTo>
+                  <a:pt x="3172352" y="20352"/>
+                  <a:pt x="3530025" y="-13347"/>
+                  <a:pt x="3735977" y="0"/>
+                </a:cubicBezTo>
+                <a:cubicBezTo>
+                  <a:pt x="3941929" y="13347"/>
+                  <a:pt x="4161497" y="34086"/>
+                  <a:pt x="4572000" y="0"/>
+                </a:cubicBezTo>
+                <a:cubicBezTo>
+                  <a:pt x="4571545" y="6162"/>
+                  <a:pt x="4571903" y="11775"/>
+                  <a:pt x="4572000" y="18288"/>
+                </a:cubicBezTo>
+                <a:cubicBezTo>
+                  <a:pt x="4228040" y="36490"/>
+                  <a:pt x="4199736" y="42557"/>
+                  <a:pt x="3873137" y="18288"/>
+                </a:cubicBezTo>
+                <a:cubicBezTo>
+                  <a:pt x="3546538" y="-5981"/>
+                  <a:pt x="3472124" y="16809"/>
+                  <a:pt x="3128554" y="18288"/>
+                </a:cubicBezTo>
+                <a:cubicBezTo>
+                  <a:pt x="2784984" y="19767"/>
+                  <a:pt x="2735896" y="-17781"/>
+                  <a:pt x="2383971" y="18288"/>
+                </a:cubicBezTo>
+                <a:cubicBezTo>
+                  <a:pt x="2032046" y="54357"/>
+                  <a:pt x="2019324" y="2920"/>
+                  <a:pt x="1867989" y="18288"/>
+                </a:cubicBezTo>
+                <a:cubicBezTo>
+                  <a:pt x="1716654" y="33656"/>
+                  <a:pt x="1418675" y="32575"/>
+                  <a:pt x="1169126" y="18288"/>
+                </a:cubicBezTo>
+                <a:cubicBezTo>
+                  <a:pt x="919577" y="4001"/>
+                  <a:pt x="798537" y="16165"/>
+                  <a:pt x="561703" y="18288"/>
+                </a:cubicBezTo>
+                <a:cubicBezTo>
+                  <a:pt x="324869" y="20411"/>
+                  <a:pt x="221395" y="-912"/>
+                  <a:pt x="0" y="18288"/>
+                </a:cubicBezTo>
+                <a:cubicBezTo>
+                  <a:pt x="766" y="10800"/>
+                  <a:pt x="-457" y="8180"/>
+                  <a:pt x="0" y="0"/>
+                </a:cubicBezTo>
+                <a:close/>
+              </a:path>
+            </a:pathLst>
+          </a:custGeom>
+          <a:solidFill>
+            <a:schemeClr val="accent2"/>
+          </a:solidFill>
+          <a:ln w="41275" cap="rnd">
+            <a:solidFill>
+              <a:schemeClr val="accent2"/>
+            </a:solidFill>
+            <a:round/>
+            <a:extLst>
+              <a:ext uri="{C807C97D-BFC1-408E-A445-0C87EB9F89A2}">
+                <ask:lineSketchStyleProps xmlns:ask="http://schemas.microsoft.com/office/drawing/2018/sketchyshapes" sd="2727557108">
+                  <a:prstGeom prst="rect">
+                    <a:avLst/>
+                  </a:prstGeom>
+                  <ask:type>
+                    <ask:lineSketchFreehand/>
+                  </ask:type>
+                </ask:lineSketchStyleProps>
+              </a:ext>
+            </a:extLst>
+          </a:ln>
+        </p:spPr>
+        <p:style>
+          <a:lnRef idx="2">
+            <a:schemeClr val="accent1">
+              <a:shade val="50000"/>
+            </a:schemeClr>
+          </a:lnRef>
+          <a:fillRef idx="1">
+            <a:schemeClr val="accent1"/>
+          </a:fillRef>
+          <a:effectRef idx="0">
+            <a:schemeClr val="accent1"/>
+          </a:effectRef>
+          <a:fontRef idx="minor">
+            <a:schemeClr val="lt1"/>
+          </a:fontRef>
+        </p:style>
+        <p:txBody>
+          <a:bodyPr rtlCol="0" anchor="ctr"/>
+          <a:lstStyle/>
+          <a:p>
+            <a:pPr algn="ctr"/>
+            <a:endParaRPr lang="en-US"/>
+          </a:p>
+        </p:txBody>
+      </p:sp>
+      <p:pic>
+        <p:nvPicPr>
+          <p:cNvPr id="4" name="Picture 3">
+            <a:extLst>
+              <a:ext uri="{FF2B5EF4-FFF2-40B4-BE49-F238E27FC236}">
+                <a16:creationId xmlns:a16="http://schemas.microsoft.com/office/drawing/2014/main" id="{E2ACFC46-604D-AE15-3BD3-44429860C148}"/>
+              </a:ext>
+            </a:extLst>
+          </p:cNvPr>
+          <p:cNvPicPr>
+            <a:picLocks noChangeAspect="1"/>
+          </p:cNvPicPr>
+          <p:nvPr/>
+        </p:nvPicPr>
+        <p:blipFill>
+          <a:blip r:embed="rId3"/>
+          <a:stretch>
+            <a:fillRect/>
+          </a:stretch>
+        </p:blipFill>
+        <p:spPr>
+          <a:xfrm>
+            <a:off x="385406" y="1818226"/>
+            <a:ext cx="11421187" cy="4482814"/>
+          </a:xfrm>
+          <a:prstGeom prst="rect">
+            <a:avLst/>
+          </a:prstGeom>
+        </p:spPr>
+      </p:pic>
+    </p:spTree>
+    <p:extLst>
+      <p:ext uri="{BB962C8B-B14F-4D97-AF65-F5344CB8AC3E}">
+        <p14:creationId xmlns:p14="http://schemas.microsoft.com/office/powerpoint/2010/main" val="611591770"/>
+      </p:ext>
+    </p:extLst>
+  </p:cSld>
+  <p:clrMapOvr>
+    <a:masterClrMapping/>
+  </p:clrMapOvr>
+</p:sld>
+</file>
+
 <file path=ppt/slides/slide2.xml><?xml version="1.0" encoding="utf-8"?>
 <p:sld xmlns:a="http://schemas.openxmlformats.org/drawingml/2006/main" xmlns:r="http://schemas.openxmlformats.org/officeDocument/2006/relationships" xmlns:p="http://schemas.openxmlformats.org/presentationml/2006/main">
   <p:cSld>
@@ -7572,7 +10277,7 @@
           <a:lstStyle/>
           <a:p>
             <a:r>
-              <a:rPr lang="en-IN" sz="1400"/>
+              <a:rPr lang="en-IN" sz="1400" dirty="0"/>
               <a:t>For each token in a sequence, at each Transformer layer, the model computes:</a:t>
             </a:r>
           </a:p>
@@ -7583,11 +10288,11 @@
               </a:spcBef>
             </a:pPr>
             <a:r>
-              <a:rPr lang="en-IN" sz="1400" b="1"/>
+              <a:rPr lang="en-IN" sz="1400" b="1" dirty="0"/>
               <a:t>K</a:t>
             </a:r>
             <a:r>
-              <a:rPr lang="en-IN" sz="1400"/>
+              <a:rPr lang="en-IN" sz="1400" dirty="0"/>
               <a:t> (Key vector) — what this token "offers"</a:t>
             </a:r>
           </a:p>
@@ -7598,11 +10303,11 @@
               </a:spcBef>
             </a:pPr>
             <a:r>
-              <a:rPr lang="en-IN" sz="1400" b="1"/>
+              <a:rPr lang="en-IN" sz="1400" b="1" dirty="0"/>
               <a:t>V</a:t>
             </a:r>
             <a:r>
-              <a:rPr lang="en-IN" sz="1400"/>
+              <a:rPr lang="en-IN" sz="1400" dirty="0"/>
               <a:t> (Value vector) — what information this token holds</a:t>
             </a:r>
           </a:p>
@@ -7613,7 +10318,7 @@
               </a:spcBef>
             </a:pPr>
             <a:r>
-              <a:rPr lang="en-IN" sz="1400"/>
+              <a:rPr lang="en-IN" sz="1400" dirty="0"/>
               <a:t>These are stored in GPU memory so they don't need to be recomputed.</a:t>
             </a:r>
           </a:p>
@@ -7624,16 +10329,16 @@
               </a:spcBef>
             </a:pPr>
             <a:r>
-              <a:rPr lang="en-IN" sz="1400"/>
+              <a:rPr lang="en-IN" sz="1400" dirty="0"/>
               <a:t>Sentence: "today we are going to learn"</a:t>
             </a:r>
           </a:p>
           <a:p>
-            <a:endParaRPr lang="en-IN" sz="1400"/>
-          </a:p>
-          <a:p>
-            <a:r>
-              <a:rPr lang="en-IN" sz="1400"/>
+            <a:endParaRPr lang="en-IN" sz="1400" dirty="0"/>
+          </a:p>
+          <a:p>
+            <a:r>
+              <a:rPr lang="en-IN" sz="1400" dirty="0"/>
               <a:t>After prefill, KV Cache contains:</a:t>
             </a:r>
           </a:p>
@@ -7644,7 +10349,7 @@
               </a:spcBef>
             </a:pPr>
             <a:r>
-              <a:rPr lang="en-IN" sz="1400"/>
+              <a:rPr lang="en-IN" sz="1400" dirty="0"/>
               <a:t>  Token 1 "today"   → K1, V1</a:t>
             </a:r>
           </a:p>
@@ -7655,7 +10360,7 @@
               </a:spcBef>
             </a:pPr>
             <a:r>
-              <a:rPr lang="en-IN" sz="1400"/>
+              <a:rPr lang="en-IN" sz="1400" dirty="0"/>
               <a:t>  Token 2 "we"      → K2, V2</a:t>
             </a:r>
           </a:p>
@@ -7666,7 +10371,7 @@
               </a:spcBef>
             </a:pPr>
             <a:r>
-              <a:rPr lang="en-IN" sz="1400"/>
+              <a:rPr lang="en-IN" sz="1400" dirty="0"/>
               <a:t>  Token 3 "are"     → K3, V3</a:t>
             </a:r>
           </a:p>
@@ -7677,7 +10382,7 @@
               </a:spcBef>
             </a:pPr>
             <a:r>
-              <a:rPr lang="en-IN" sz="1400"/>
+              <a:rPr lang="en-IN" sz="1400" dirty="0"/>
               <a:t>  Token 4 "going"   → K4, V4</a:t>
             </a:r>
           </a:p>
@@ -7688,7 +10393,7 @@
               </a:spcBef>
             </a:pPr>
             <a:r>
-              <a:rPr lang="en-IN" sz="1400"/>
+              <a:rPr lang="en-IN" sz="1400" dirty="0"/>
               <a:t>  Token 5 "to"      → K5, V5</a:t>
             </a:r>
           </a:p>
@@ -7699,14 +10404,14 @@
               </a:spcBef>
             </a:pPr>
             <a:r>
-              <a:rPr lang="en-IN" sz="1400"/>
+              <a:rPr lang="en-IN" sz="1400" dirty="0"/>
               <a:t>  Token 6 "learn"   → K6, V6</a:t>
             </a:r>
           </a:p>
           <a:p>
             <a:r>
-              <a:rPr lang="en-IN" sz="1400"/>
-              <a:t>During decode, when the model generates token 7 (e.g., "machine"), it only computes K7, V7 and attends over the cached K1–K6.</a:t>
+              <a:rPr lang="en-IN" sz="1400" dirty="0"/>
+              <a:t>During decode, when the model generates token 7 (e.g., ”model"), it only computes K7, V7 and attends over the cached K1–K6.</a:t>
             </a:r>
           </a:p>
           <a:p>

</xml_diff>

<commit_message>
added more concepts to draw.io files (#19)
</commit_message>
<xml_diff>
--- a/deep_on_inference.pptx
+++ b/deep_on_inference.pptx
@@ -5,7 +5,7 @@
     <p:sldMasterId id="2147483648" r:id="rId1"/>
   </p:sldMasterIdLst>
   <p:notesMasterIdLst>
-    <p:notesMasterId r:id="rId11"/>
+    <p:notesMasterId r:id="rId15"/>
   </p:notesMasterIdLst>
   <p:sldIdLst>
     <p:sldId id="256" r:id="rId2"/>
@@ -17,6 +17,10 @@
     <p:sldId id="261" r:id="rId8"/>
     <p:sldId id="262" r:id="rId9"/>
     <p:sldId id="263" r:id="rId10"/>
+    <p:sldId id="265" r:id="rId11"/>
+    <p:sldId id="266" r:id="rId12"/>
+    <p:sldId id="267" r:id="rId13"/>
+    <p:sldId id="268" r:id="rId14"/>
   </p:sldIdLst>
   <p:sldSz cx="12192000" cy="6858000"/>
   <p:notesSz cx="6858000" cy="9144000"/>
@@ -552,6 +556,222 @@
 </p:notes>
 </file>
 
+<file path=ppt/notesSlides/notesSlide10.xml><?xml version="1.0" encoding="utf-8"?>
+<p:notes xmlns:a="http://schemas.openxmlformats.org/drawingml/2006/main" xmlns:r="http://schemas.openxmlformats.org/officeDocument/2006/relationships" xmlns:p="http://schemas.openxmlformats.org/presentationml/2006/main">
+  <p:cSld>
+    <p:spTree>
+      <p:nvGrpSpPr>
+        <p:cNvPr id="1" name="">
+          <a:extLst>
+            <a:ext uri="{FF2B5EF4-FFF2-40B4-BE49-F238E27FC236}">
+              <a16:creationId xmlns:a16="http://schemas.microsoft.com/office/drawing/2014/main" id="{EA1E683F-D896-230F-9884-00E8CB4690F1}"/>
+            </a:ext>
+          </a:extLst>
+        </p:cNvPr>
+        <p:cNvGrpSpPr/>
+        <p:nvPr/>
+      </p:nvGrpSpPr>
+      <p:grpSpPr>
+        <a:xfrm>
+          <a:off x="0" y="0"/>
+          <a:ext cx="0" cy="0"/>
+          <a:chOff x="0" y="0"/>
+          <a:chExt cx="0" cy="0"/>
+        </a:xfrm>
+      </p:grpSpPr>
+      <p:sp>
+        <p:nvSpPr>
+          <p:cNvPr id="2" name="Slide Image Placeholder 1">
+            <a:extLst>
+              <a:ext uri="{FF2B5EF4-FFF2-40B4-BE49-F238E27FC236}">
+                <a16:creationId xmlns:a16="http://schemas.microsoft.com/office/drawing/2014/main" id="{02691DFD-A6FF-4539-0599-A427283C2539}"/>
+              </a:ext>
+            </a:extLst>
+          </p:cNvPr>
+          <p:cNvSpPr>
+            <a:spLocks noGrp="1" noRot="1" noChangeAspect="1"/>
+          </p:cNvSpPr>
+          <p:nvPr>
+            <p:ph type="sldImg"/>
+          </p:nvPr>
+        </p:nvSpPr>
+        <p:spPr/>
+      </p:sp>
+      <p:sp>
+        <p:nvSpPr>
+          <p:cNvPr id="3" name="Notes Placeholder 2">
+            <a:extLst>
+              <a:ext uri="{FF2B5EF4-FFF2-40B4-BE49-F238E27FC236}">
+                <a16:creationId xmlns:a16="http://schemas.microsoft.com/office/drawing/2014/main" id="{A64E8A66-F401-F05D-8011-89C5467F9158}"/>
+              </a:ext>
+            </a:extLst>
+          </p:cNvPr>
+          <p:cNvSpPr>
+            <a:spLocks noGrp="1"/>
+          </p:cNvSpPr>
+          <p:nvPr>
+            <p:ph type="body" idx="1"/>
+          </p:nvPr>
+        </p:nvSpPr>
+        <p:spPr/>
+        <p:txBody>
+          <a:bodyPr/>
+          <a:lstStyle/>
+          <a:p>
+            <a:endParaRPr lang="en-US" dirty="0"/>
+          </a:p>
+        </p:txBody>
+      </p:sp>
+      <p:sp>
+        <p:nvSpPr>
+          <p:cNvPr id="4" name="Slide Number Placeholder 3">
+            <a:extLst>
+              <a:ext uri="{FF2B5EF4-FFF2-40B4-BE49-F238E27FC236}">
+                <a16:creationId xmlns:a16="http://schemas.microsoft.com/office/drawing/2014/main" id="{C39A53DB-91F3-19EF-6FAC-8197DA48D23E}"/>
+              </a:ext>
+            </a:extLst>
+          </p:cNvPr>
+          <p:cNvSpPr>
+            <a:spLocks noGrp="1"/>
+          </p:cNvSpPr>
+          <p:nvPr>
+            <p:ph type="sldNum" sz="quarter" idx="5"/>
+          </p:nvPr>
+        </p:nvSpPr>
+        <p:spPr/>
+        <p:txBody>
+          <a:bodyPr/>
+          <a:lstStyle/>
+          <a:p>
+            <a:fld id="{EC94FF2E-E923-D04D-A47F-B6EB8146CC33}" type="slidenum">
+              <a:rPr lang="en-US" smtClean="0"/>
+              <a:t>12</a:t>
+            </a:fld>
+            <a:endParaRPr lang="en-US"/>
+          </a:p>
+        </p:txBody>
+      </p:sp>
+    </p:spTree>
+    <p:extLst>
+      <p:ext uri="{BB962C8B-B14F-4D97-AF65-F5344CB8AC3E}">
+        <p14:creationId xmlns:p14="http://schemas.microsoft.com/office/powerpoint/2010/main" val="3663337534"/>
+      </p:ext>
+    </p:extLst>
+  </p:cSld>
+  <p:clrMapOvr>
+    <a:masterClrMapping/>
+  </p:clrMapOvr>
+</p:notes>
+</file>
+
+<file path=ppt/notesSlides/notesSlide11.xml><?xml version="1.0" encoding="utf-8"?>
+<p:notes xmlns:a="http://schemas.openxmlformats.org/drawingml/2006/main" xmlns:r="http://schemas.openxmlformats.org/officeDocument/2006/relationships" xmlns:p="http://schemas.openxmlformats.org/presentationml/2006/main">
+  <p:cSld>
+    <p:spTree>
+      <p:nvGrpSpPr>
+        <p:cNvPr id="1" name="">
+          <a:extLst>
+            <a:ext uri="{FF2B5EF4-FFF2-40B4-BE49-F238E27FC236}">
+              <a16:creationId xmlns:a16="http://schemas.microsoft.com/office/drawing/2014/main" id="{94378374-19AD-A049-21A9-B7A72EE5CBAC}"/>
+            </a:ext>
+          </a:extLst>
+        </p:cNvPr>
+        <p:cNvGrpSpPr/>
+        <p:nvPr/>
+      </p:nvGrpSpPr>
+      <p:grpSpPr>
+        <a:xfrm>
+          <a:off x="0" y="0"/>
+          <a:ext cx="0" cy="0"/>
+          <a:chOff x="0" y="0"/>
+          <a:chExt cx="0" cy="0"/>
+        </a:xfrm>
+      </p:grpSpPr>
+      <p:sp>
+        <p:nvSpPr>
+          <p:cNvPr id="2" name="Slide Image Placeholder 1">
+            <a:extLst>
+              <a:ext uri="{FF2B5EF4-FFF2-40B4-BE49-F238E27FC236}">
+                <a16:creationId xmlns:a16="http://schemas.microsoft.com/office/drawing/2014/main" id="{BBD4E75D-5E92-B783-8AA8-67AC8EFD2CE9}"/>
+              </a:ext>
+            </a:extLst>
+          </p:cNvPr>
+          <p:cNvSpPr>
+            <a:spLocks noGrp="1" noRot="1" noChangeAspect="1"/>
+          </p:cNvSpPr>
+          <p:nvPr>
+            <p:ph type="sldImg"/>
+          </p:nvPr>
+        </p:nvSpPr>
+        <p:spPr/>
+      </p:sp>
+      <p:sp>
+        <p:nvSpPr>
+          <p:cNvPr id="3" name="Notes Placeholder 2">
+            <a:extLst>
+              <a:ext uri="{FF2B5EF4-FFF2-40B4-BE49-F238E27FC236}">
+                <a16:creationId xmlns:a16="http://schemas.microsoft.com/office/drawing/2014/main" id="{038D340C-9066-6336-09B5-194E37B70491}"/>
+              </a:ext>
+            </a:extLst>
+          </p:cNvPr>
+          <p:cNvSpPr>
+            <a:spLocks noGrp="1"/>
+          </p:cNvSpPr>
+          <p:nvPr>
+            <p:ph type="body" idx="1"/>
+          </p:nvPr>
+        </p:nvSpPr>
+        <p:spPr/>
+        <p:txBody>
+          <a:bodyPr/>
+          <a:lstStyle/>
+          <a:p>
+            <a:endParaRPr lang="en-US" dirty="0"/>
+          </a:p>
+        </p:txBody>
+      </p:sp>
+      <p:sp>
+        <p:nvSpPr>
+          <p:cNvPr id="4" name="Slide Number Placeholder 3">
+            <a:extLst>
+              <a:ext uri="{FF2B5EF4-FFF2-40B4-BE49-F238E27FC236}">
+                <a16:creationId xmlns:a16="http://schemas.microsoft.com/office/drawing/2014/main" id="{DD66F22E-B861-4BBF-6A46-11F924806C0D}"/>
+              </a:ext>
+            </a:extLst>
+          </p:cNvPr>
+          <p:cNvSpPr>
+            <a:spLocks noGrp="1"/>
+          </p:cNvSpPr>
+          <p:nvPr>
+            <p:ph type="sldNum" sz="quarter" idx="5"/>
+          </p:nvPr>
+        </p:nvSpPr>
+        <p:spPr/>
+        <p:txBody>
+          <a:bodyPr/>
+          <a:lstStyle/>
+          <a:p>
+            <a:fld id="{EC94FF2E-E923-D04D-A47F-B6EB8146CC33}" type="slidenum">
+              <a:rPr lang="en-US" smtClean="0"/>
+              <a:t>13</a:t>
+            </a:fld>
+            <a:endParaRPr lang="en-US"/>
+          </a:p>
+        </p:txBody>
+      </p:sp>
+    </p:spTree>
+    <p:extLst>
+      <p:ext uri="{BB962C8B-B14F-4D97-AF65-F5344CB8AC3E}">
+        <p14:creationId xmlns:p14="http://schemas.microsoft.com/office/powerpoint/2010/main" val="3075487479"/>
+      </p:ext>
+    </p:extLst>
+  </p:cSld>
+  <p:clrMapOvr>
+    <a:masterClrMapping/>
+  </p:clrMapOvr>
+</p:notes>
+</file>
+
 <file path=ppt/notesSlides/notesSlide2.xml><?xml version="1.0" encoding="utf-8"?>
 <p:notes xmlns:a="http://schemas.openxmlformats.org/drawingml/2006/main" xmlns:r="http://schemas.openxmlformats.org/officeDocument/2006/relationships" xmlns:p="http://schemas.openxmlformats.org/presentationml/2006/main">
   <p:cSld>
@@ -1630,6 +1850,222 @@
     <p:extLst>
       <p:ext uri="{BB962C8B-B14F-4D97-AF65-F5344CB8AC3E}">
         <p14:creationId xmlns:p14="http://schemas.microsoft.com/office/powerpoint/2010/main" val="4110271203"/>
+      </p:ext>
+    </p:extLst>
+  </p:cSld>
+  <p:clrMapOvr>
+    <a:masterClrMapping/>
+  </p:clrMapOvr>
+</p:notes>
+</file>
+
+<file path=ppt/notesSlides/notesSlide8.xml><?xml version="1.0" encoding="utf-8"?>
+<p:notes xmlns:a="http://schemas.openxmlformats.org/drawingml/2006/main" xmlns:r="http://schemas.openxmlformats.org/officeDocument/2006/relationships" xmlns:p="http://schemas.openxmlformats.org/presentationml/2006/main">
+  <p:cSld>
+    <p:spTree>
+      <p:nvGrpSpPr>
+        <p:cNvPr id="1" name="">
+          <a:extLst>
+            <a:ext uri="{FF2B5EF4-FFF2-40B4-BE49-F238E27FC236}">
+              <a16:creationId xmlns:a16="http://schemas.microsoft.com/office/drawing/2014/main" id="{DEA5F2A7-FA39-A2EE-64A2-8994C3613350}"/>
+            </a:ext>
+          </a:extLst>
+        </p:cNvPr>
+        <p:cNvGrpSpPr/>
+        <p:nvPr/>
+      </p:nvGrpSpPr>
+      <p:grpSpPr>
+        <a:xfrm>
+          <a:off x="0" y="0"/>
+          <a:ext cx="0" cy="0"/>
+          <a:chOff x="0" y="0"/>
+          <a:chExt cx="0" cy="0"/>
+        </a:xfrm>
+      </p:grpSpPr>
+      <p:sp>
+        <p:nvSpPr>
+          <p:cNvPr id="2" name="Slide Image Placeholder 1">
+            <a:extLst>
+              <a:ext uri="{FF2B5EF4-FFF2-40B4-BE49-F238E27FC236}">
+                <a16:creationId xmlns:a16="http://schemas.microsoft.com/office/drawing/2014/main" id="{1FECA1FF-607D-2FBE-9DB1-B639BBC116F3}"/>
+              </a:ext>
+            </a:extLst>
+          </p:cNvPr>
+          <p:cNvSpPr>
+            <a:spLocks noGrp="1" noRot="1" noChangeAspect="1"/>
+          </p:cNvSpPr>
+          <p:nvPr>
+            <p:ph type="sldImg"/>
+          </p:nvPr>
+        </p:nvSpPr>
+        <p:spPr/>
+      </p:sp>
+      <p:sp>
+        <p:nvSpPr>
+          <p:cNvPr id="3" name="Notes Placeholder 2">
+            <a:extLst>
+              <a:ext uri="{FF2B5EF4-FFF2-40B4-BE49-F238E27FC236}">
+                <a16:creationId xmlns:a16="http://schemas.microsoft.com/office/drawing/2014/main" id="{40EB21AA-CBA2-4F99-56AB-8373444051E8}"/>
+              </a:ext>
+            </a:extLst>
+          </p:cNvPr>
+          <p:cNvSpPr>
+            <a:spLocks noGrp="1"/>
+          </p:cNvSpPr>
+          <p:nvPr>
+            <p:ph type="body" idx="1"/>
+          </p:nvPr>
+        </p:nvSpPr>
+        <p:spPr/>
+        <p:txBody>
+          <a:bodyPr/>
+          <a:lstStyle/>
+          <a:p>
+            <a:endParaRPr lang="en-US" dirty="0"/>
+          </a:p>
+        </p:txBody>
+      </p:sp>
+      <p:sp>
+        <p:nvSpPr>
+          <p:cNvPr id="4" name="Slide Number Placeholder 3">
+            <a:extLst>
+              <a:ext uri="{FF2B5EF4-FFF2-40B4-BE49-F238E27FC236}">
+                <a16:creationId xmlns:a16="http://schemas.microsoft.com/office/drawing/2014/main" id="{2429BBD5-8594-F3DA-24A9-2B458BF599A5}"/>
+              </a:ext>
+            </a:extLst>
+          </p:cNvPr>
+          <p:cNvSpPr>
+            <a:spLocks noGrp="1"/>
+          </p:cNvSpPr>
+          <p:nvPr>
+            <p:ph type="sldNum" sz="quarter" idx="5"/>
+          </p:nvPr>
+        </p:nvSpPr>
+        <p:spPr/>
+        <p:txBody>
+          <a:bodyPr/>
+          <a:lstStyle/>
+          <a:p>
+            <a:fld id="{EC94FF2E-E923-D04D-A47F-B6EB8146CC33}" type="slidenum">
+              <a:rPr lang="en-US" smtClean="0"/>
+              <a:t>10</a:t>
+            </a:fld>
+            <a:endParaRPr lang="en-US"/>
+          </a:p>
+        </p:txBody>
+      </p:sp>
+    </p:spTree>
+    <p:extLst>
+      <p:ext uri="{BB962C8B-B14F-4D97-AF65-F5344CB8AC3E}">
+        <p14:creationId xmlns:p14="http://schemas.microsoft.com/office/powerpoint/2010/main" val="4141130966"/>
+      </p:ext>
+    </p:extLst>
+  </p:cSld>
+  <p:clrMapOvr>
+    <a:masterClrMapping/>
+  </p:clrMapOvr>
+</p:notes>
+</file>
+
+<file path=ppt/notesSlides/notesSlide9.xml><?xml version="1.0" encoding="utf-8"?>
+<p:notes xmlns:a="http://schemas.openxmlformats.org/drawingml/2006/main" xmlns:r="http://schemas.openxmlformats.org/officeDocument/2006/relationships" xmlns:p="http://schemas.openxmlformats.org/presentationml/2006/main">
+  <p:cSld>
+    <p:spTree>
+      <p:nvGrpSpPr>
+        <p:cNvPr id="1" name="">
+          <a:extLst>
+            <a:ext uri="{FF2B5EF4-FFF2-40B4-BE49-F238E27FC236}">
+              <a16:creationId xmlns:a16="http://schemas.microsoft.com/office/drawing/2014/main" id="{A07997E1-B605-D680-FBC3-72925C124349}"/>
+            </a:ext>
+          </a:extLst>
+        </p:cNvPr>
+        <p:cNvGrpSpPr/>
+        <p:nvPr/>
+      </p:nvGrpSpPr>
+      <p:grpSpPr>
+        <a:xfrm>
+          <a:off x="0" y="0"/>
+          <a:ext cx="0" cy="0"/>
+          <a:chOff x="0" y="0"/>
+          <a:chExt cx="0" cy="0"/>
+        </a:xfrm>
+      </p:grpSpPr>
+      <p:sp>
+        <p:nvSpPr>
+          <p:cNvPr id="2" name="Slide Image Placeholder 1">
+            <a:extLst>
+              <a:ext uri="{FF2B5EF4-FFF2-40B4-BE49-F238E27FC236}">
+                <a16:creationId xmlns:a16="http://schemas.microsoft.com/office/drawing/2014/main" id="{E09EB0C2-344D-220D-F639-EB8F99BCAAB3}"/>
+              </a:ext>
+            </a:extLst>
+          </p:cNvPr>
+          <p:cNvSpPr>
+            <a:spLocks noGrp="1" noRot="1" noChangeAspect="1"/>
+          </p:cNvSpPr>
+          <p:nvPr>
+            <p:ph type="sldImg"/>
+          </p:nvPr>
+        </p:nvSpPr>
+        <p:spPr/>
+      </p:sp>
+      <p:sp>
+        <p:nvSpPr>
+          <p:cNvPr id="3" name="Notes Placeholder 2">
+            <a:extLst>
+              <a:ext uri="{FF2B5EF4-FFF2-40B4-BE49-F238E27FC236}">
+                <a16:creationId xmlns:a16="http://schemas.microsoft.com/office/drawing/2014/main" id="{93C8D4FB-0A99-96FB-BE3A-F410971E6EE1}"/>
+              </a:ext>
+            </a:extLst>
+          </p:cNvPr>
+          <p:cNvSpPr>
+            <a:spLocks noGrp="1"/>
+          </p:cNvSpPr>
+          <p:nvPr>
+            <p:ph type="body" idx="1"/>
+          </p:nvPr>
+        </p:nvSpPr>
+        <p:spPr/>
+        <p:txBody>
+          <a:bodyPr/>
+          <a:lstStyle/>
+          <a:p>
+            <a:endParaRPr lang="en-US" dirty="0"/>
+          </a:p>
+        </p:txBody>
+      </p:sp>
+      <p:sp>
+        <p:nvSpPr>
+          <p:cNvPr id="4" name="Slide Number Placeholder 3">
+            <a:extLst>
+              <a:ext uri="{FF2B5EF4-FFF2-40B4-BE49-F238E27FC236}">
+                <a16:creationId xmlns:a16="http://schemas.microsoft.com/office/drawing/2014/main" id="{0C2222DE-6DDB-F2F0-C624-9ED28706A6D0}"/>
+              </a:ext>
+            </a:extLst>
+          </p:cNvPr>
+          <p:cNvSpPr>
+            <a:spLocks noGrp="1"/>
+          </p:cNvSpPr>
+          <p:nvPr>
+            <p:ph type="sldNum" sz="quarter" idx="5"/>
+          </p:nvPr>
+        </p:nvSpPr>
+        <p:spPr/>
+        <p:txBody>
+          <a:bodyPr/>
+          <a:lstStyle/>
+          <a:p>
+            <a:fld id="{EC94FF2E-E923-D04D-A47F-B6EB8146CC33}" type="slidenum">
+              <a:rPr lang="en-US" smtClean="0"/>
+              <a:t>11</a:t>
+            </a:fld>
+            <a:endParaRPr lang="en-US"/>
+          </a:p>
+        </p:txBody>
+      </p:sp>
+    </p:spTree>
+    <p:extLst>
+      <p:ext uri="{BB962C8B-B14F-4D97-AF65-F5344CB8AC3E}">
+        <p14:creationId xmlns:p14="http://schemas.microsoft.com/office/powerpoint/2010/main" val="1930417939"/>
       </p:ext>
     </p:extLst>
   </p:cSld>
@@ -4943,6 +5379,2275 @@
 </p:sld>
 </file>
 
+<file path=ppt/slides/slide10.xml><?xml version="1.0" encoding="utf-8"?>
+<p:sld xmlns:a="http://schemas.openxmlformats.org/drawingml/2006/main" xmlns:r="http://schemas.openxmlformats.org/officeDocument/2006/relationships" xmlns:p="http://schemas.openxmlformats.org/presentationml/2006/main">
+  <p:cSld>
+    <p:bg>
+      <p:bgPr>
+        <a:solidFill>
+          <a:schemeClr val="bg1"/>
+        </a:solidFill>
+        <a:effectLst/>
+      </p:bgPr>
+    </p:bg>
+    <p:spTree>
+      <p:nvGrpSpPr>
+        <p:cNvPr id="1" name="">
+          <a:extLst>
+            <a:ext uri="{FF2B5EF4-FFF2-40B4-BE49-F238E27FC236}">
+              <a16:creationId xmlns:a16="http://schemas.microsoft.com/office/drawing/2014/main" id="{346F6256-E725-F4F9-952F-9B7FF8928D5B}"/>
+            </a:ext>
+          </a:extLst>
+        </p:cNvPr>
+        <p:cNvGrpSpPr/>
+        <p:nvPr/>
+      </p:nvGrpSpPr>
+      <p:grpSpPr>
+        <a:xfrm>
+          <a:off x="0" y="0"/>
+          <a:ext cx="0" cy="0"/>
+          <a:chOff x="0" y="0"/>
+          <a:chExt cx="0" cy="0"/>
+        </a:xfrm>
+      </p:grpSpPr>
+      <p:sp useBgFill="1">
+        <p:nvSpPr>
+          <p:cNvPr id="66" name="Rectangle 65">
+            <a:extLst>
+              <a:ext uri="{FF2B5EF4-FFF2-40B4-BE49-F238E27FC236}">
+                <a16:creationId xmlns:a16="http://schemas.microsoft.com/office/drawing/2014/main" id="{BCED4D40-4B67-4331-AC48-79B82B4A47D8}"/>
+              </a:ext>
+              <a:ext uri="{C183D7F6-B498-43B3-948B-1728B52AA6E4}">
+                <adec:decorative xmlns:adec="http://schemas.microsoft.com/office/drawing/2017/decorative" val="1"/>
+              </a:ext>
+            </a:extLst>
+          </p:cNvPr>
+          <p:cNvSpPr>
+            <a:spLocks noGrp="1" noRot="1" noChangeAspect="1" noMove="1" noResize="1" noEditPoints="1" noAdjustHandles="1" noChangeArrowheads="1" noChangeShapeType="1" noTextEdit="1"/>
+          </p:cNvSpPr>
+          <p:nvPr>
+            <p:extLst>
+              <p:ext uri="{386F3935-93C4-4BCD-93E2-E3B085C9AB24}">
+                <p16:designElem xmlns:p16="http://schemas.microsoft.com/office/powerpoint/2015/main" val="1"/>
+              </p:ext>
+            </p:extLst>
+          </p:nvPr>
+        </p:nvSpPr>
+        <p:spPr>
+          <a:xfrm>
+            <a:off x="0" y="0"/>
+            <a:ext cx="12192000" cy="6858000"/>
+          </a:xfrm>
+          <a:prstGeom prst="rect">
+            <a:avLst/>
+          </a:prstGeom>
+          <a:ln>
+            <a:noFill/>
+          </a:ln>
+        </p:spPr>
+        <p:style>
+          <a:lnRef idx="2">
+            <a:schemeClr val="accent1">
+              <a:shade val="50000"/>
+            </a:schemeClr>
+          </a:lnRef>
+          <a:fillRef idx="1">
+            <a:schemeClr val="accent1"/>
+          </a:fillRef>
+          <a:effectRef idx="0">
+            <a:schemeClr val="accent1"/>
+          </a:effectRef>
+          <a:fontRef idx="minor">
+            <a:schemeClr val="lt1"/>
+          </a:fontRef>
+        </p:style>
+        <p:txBody>
+          <a:bodyPr rtlCol="0" anchor="ctr"/>
+          <a:lstStyle/>
+          <a:p>
+            <a:pPr algn="ctr"/>
+            <a:endParaRPr lang="en-US"/>
+          </a:p>
+        </p:txBody>
+      </p:sp>
+      <p:sp>
+        <p:nvSpPr>
+          <p:cNvPr id="2" name="Title 1">
+            <a:extLst>
+              <a:ext uri="{FF2B5EF4-FFF2-40B4-BE49-F238E27FC236}">
+                <a16:creationId xmlns:a16="http://schemas.microsoft.com/office/drawing/2014/main" id="{66EF003C-A9FC-1466-8EA0-AB95F29DF3FC}"/>
+              </a:ext>
+            </a:extLst>
+          </p:cNvPr>
+          <p:cNvSpPr>
+            <a:spLocks noGrp="1"/>
+          </p:cNvSpPr>
+          <p:nvPr>
+            <p:ph type="title"/>
+          </p:nvPr>
+        </p:nvSpPr>
+        <p:spPr>
+          <a:xfrm>
+            <a:off x="638881" y="417576"/>
+            <a:ext cx="10909640" cy="1249394"/>
+          </a:xfrm>
+        </p:spPr>
+        <p:txBody>
+          <a:bodyPr vert="horz" lIns="91440" tIns="45720" rIns="91440" bIns="45720" rtlCol="0" anchor="ctr">
+            <a:normAutofit/>
+          </a:bodyPr>
+          <a:lstStyle/>
+          <a:p>
+            <a:pPr algn="ctr"/>
+            <a:r>
+              <a:rPr lang="en-US" sz="4100" b="1" kern="1200">
+                <a:solidFill>
+                  <a:schemeClr val="tx1"/>
+                </a:solidFill>
+                <a:latin typeface="+mj-lt"/>
+                <a:ea typeface="+mj-ea"/>
+                <a:cs typeface="+mj-cs"/>
+              </a:rPr>
+              <a:t>PagedAttention: Prompts, Tokenization &amp; Block Allocation</a:t>
+            </a:r>
+          </a:p>
+        </p:txBody>
+      </p:sp>
+      <p:sp>
+        <p:nvSpPr>
+          <p:cNvPr id="68" name="sketch line">
+            <a:extLst>
+              <a:ext uri="{FF2B5EF4-FFF2-40B4-BE49-F238E27FC236}">
+                <a16:creationId xmlns:a16="http://schemas.microsoft.com/office/drawing/2014/main" id="{670CEDEF-4F34-412E-84EE-329C1E936AF5}"/>
+              </a:ext>
+              <a:ext uri="{C183D7F6-B498-43B3-948B-1728B52AA6E4}">
+                <adec:decorative xmlns:adec="http://schemas.microsoft.com/office/drawing/2017/decorative" val="1"/>
+              </a:ext>
+            </a:extLst>
+          </p:cNvPr>
+          <p:cNvSpPr>
+            <a:spLocks noGrp="1" noRot="1" noChangeAspect="1" noMove="1" noResize="1" noEditPoints="1" noAdjustHandles="1" noChangeArrowheads="1" noChangeShapeType="1" noTextEdit="1"/>
+          </p:cNvSpPr>
+          <p:nvPr>
+            <p:extLst>
+              <p:ext uri="{386F3935-93C4-4BCD-93E2-E3B085C9AB24}">
+                <p16:designElem xmlns:p16="http://schemas.microsoft.com/office/powerpoint/2015/main" val="1"/>
+              </p:ext>
+            </p:extLst>
+          </p:nvPr>
+        </p:nvSpPr>
+        <p:spPr>
+          <a:xfrm>
+            <a:off x="3807702" y="1733454"/>
+            <a:ext cx="4572000" cy="18288"/>
+          </a:xfrm>
+          <a:custGeom>
+            <a:avLst/>
+            <a:gdLst>
+              <a:gd name="csX0" fmla="*/ 0 w 4572000"/>
+              <a:gd name="csY0" fmla="*/ 0 h 18288"/>
+              <a:gd name="csX1" fmla="*/ 515983 w 4572000"/>
+              <a:gd name="csY1" fmla="*/ 0 h 18288"/>
+              <a:gd name="csX2" fmla="*/ 1031966 w 4572000"/>
+              <a:gd name="csY2" fmla="*/ 0 h 18288"/>
+              <a:gd name="csX3" fmla="*/ 1639389 w 4572000"/>
+              <a:gd name="csY3" fmla="*/ 0 h 18288"/>
+              <a:gd name="csX4" fmla="*/ 2383971 w 4572000"/>
+              <a:gd name="csY4" fmla="*/ 0 h 18288"/>
+              <a:gd name="csX5" fmla="*/ 2945674 w 4572000"/>
+              <a:gd name="csY5" fmla="*/ 0 h 18288"/>
+              <a:gd name="csX6" fmla="*/ 3507377 w 4572000"/>
+              <a:gd name="csY6" fmla="*/ 0 h 18288"/>
+              <a:gd name="csX7" fmla="*/ 4572000 w 4572000"/>
+              <a:gd name="csY7" fmla="*/ 0 h 18288"/>
+              <a:gd name="csX8" fmla="*/ 4572000 w 4572000"/>
+              <a:gd name="csY8" fmla="*/ 18288 h 18288"/>
+              <a:gd name="csX9" fmla="*/ 3873137 w 4572000"/>
+              <a:gd name="csY9" fmla="*/ 18288 h 18288"/>
+              <a:gd name="csX10" fmla="*/ 3311434 w 4572000"/>
+              <a:gd name="csY10" fmla="*/ 18288 h 18288"/>
+              <a:gd name="csX11" fmla="*/ 2749731 w 4572000"/>
+              <a:gd name="csY11" fmla="*/ 18288 h 18288"/>
+              <a:gd name="csX12" fmla="*/ 2050869 w 4572000"/>
+              <a:gd name="csY12" fmla="*/ 18288 h 18288"/>
+              <a:gd name="csX13" fmla="*/ 1306286 w 4572000"/>
+              <a:gd name="csY13" fmla="*/ 18288 h 18288"/>
+              <a:gd name="csX14" fmla="*/ 790303 w 4572000"/>
+              <a:gd name="csY14" fmla="*/ 18288 h 18288"/>
+              <a:gd name="csX15" fmla="*/ 0 w 4572000"/>
+              <a:gd name="csY15" fmla="*/ 18288 h 18288"/>
+              <a:gd name="csX16" fmla="*/ 0 w 4572000"/>
+              <a:gd name="csY16" fmla="*/ 0 h 18288"/>
+            </a:gdLst>
+            <a:ahLst/>
+            <a:cxnLst>
+              <a:cxn ang="0">
+                <a:pos x="csX0" y="csY0"/>
+              </a:cxn>
+              <a:cxn ang="0">
+                <a:pos x="csX1" y="csY1"/>
+              </a:cxn>
+              <a:cxn ang="0">
+                <a:pos x="csX2" y="csY2"/>
+              </a:cxn>
+              <a:cxn ang="0">
+                <a:pos x="csX3" y="csY3"/>
+              </a:cxn>
+              <a:cxn ang="0">
+                <a:pos x="csX4" y="csY4"/>
+              </a:cxn>
+              <a:cxn ang="0">
+                <a:pos x="csX5" y="csY5"/>
+              </a:cxn>
+              <a:cxn ang="0">
+                <a:pos x="csX6" y="csY6"/>
+              </a:cxn>
+              <a:cxn ang="0">
+                <a:pos x="csX7" y="csY7"/>
+              </a:cxn>
+              <a:cxn ang="0">
+                <a:pos x="csX8" y="csY8"/>
+              </a:cxn>
+              <a:cxn ang="0">
+                <a:pos x="csX9" y="csY9"/>
+              </a:cxn>
+              <a:cxn ang="0">
+                <a:pos x="csX10" y="csY10"/>
+              </a:cxn>
+              <a:cxn ang="0">
+                <a:pos x="csX11" y="csY11"/>
+              </a:cxn>
+              <a:cxn ang="0">
+                <a:pos x="csX12" y="csY12"/>
+              </a:cxn>
+              <a:cxn ang="0">
+                <a:pos x="csX13" y="csY13"/>
+              </a:cxn>
+              <a:cxn ang="0">
+                <a:pos x="csX14" y="csY14"/>
+              </a:cxn>
+              <a:cxn ang="0">
+                <a:pos x="csX15" y="csY15"/>
+              </a:cxn>
+              <a:cxn ang="0">
+                <a:pos x="csX16" y="csY16"/>
+              </a:cxn>
+            </a:cxnLst>
+            <a:rect l="l" t="t" r="r" b="b"/>
+            <a:pathLst>
+              <a:path w="4572000" h="18288" fill="none" extrusionOk="0">
+                <a:moveTo>
+                  <a:pt x="0" y="0"/>
+                </a:moveTo>
+                <a:cubicBezTo>
+                  <a:pt x="105156" y="-20963"/>
+                  <a:pt x="340432" y="822"/>
+                  <a:pt x="515983" y="0"/>
+                </a:cubicBezTo>
+                <a:cubicBezTo>
+                  <a:pt x="691534" y="-822"/>
+                  <a:pt x="850679" y="16479"/>
+                  <a:pt x="1031966" y="0"/>
+                </a:cubicBezTo>
+                <a:cubicBezTo>
+                  <a:pt x="1213253" y="-16479"/>
+                  <a:pt x="1443646" y="-18730"/>
+                  <a:pt x="1639389" y="0"/>
+                </a:cubicBezTo>
+                <a:cubicBezTo>
+                  <a:pt x="1835132" y="18730"/>
+                  <a:pt x="2159975" y="18531"/>
+                  <a:pt x="2383971" y="0"/>
+                </a:cubicBezTo>
+                <a:cubicBezTo>
+                  <a:pt x="2607967" y="-18531"/>
+                  <a:pt x="2719096" y="-12030"/>
+                  <a:pt x="2945674" y="0"/>
+                </a:cubicBezTo>
+                <a:cubicBezTo>
+                  <a:pt x="3172252" y="12030"/>
+                  <a:pt x="3269167" y="27666"/>
+                  <a:pt x="3507377" y="0"/>
+                </a:cubicBezTo>
+                <a:cubicBezTo>
+                  <a:pt x="3745587" y="-27666"/>
+                  <a:pt x="4116741" y="18705"/>
+                  <a:pt x="4572000" y="0"/>
+                </a:cubicBezTo>
+                <a:cubicBezTo>
+                  <a:pt x="4572895" y="8974"/>
+                  <a:pt x="4571454" y="9359"/>
+                  <a:pt x="4572000" y="18288"/>
+                </a:cubicBezTo>
+                <a:cubicBezTo>
+                  <a:pt x="4374698" y="3942"/>
+                  <a:pt x="4098874" y="-11042"/>
+                  <a:pt x="3873137" y="18288"/>
+                </a:cubicBezTo>
+                <a:cubicBezTo>
+                  <a:pt x="3647400" y="47618"/>
+                  <a:pt x="3517055" y="5421"/>
+                  <a:pt x="3311434" y="18288"/>
+                </a:cubicBezTo>
+                <a:cubicBezTo>
+                  <a:pt x="3105813" y="31155"/>
+                  <a:pt x="3025168" y="17856"/>
+                  <a:pt x="2749731" y="18288"/>
+                </a:cubicBezTo>
+                <a:cubicBezTo>
+                  <a:pt x="2474294" y="18720"/>
+                  <a:pt x="2291766" y="-14168"/>
+                  <a:pt x="2050869" y="18288"/>
+                </a:cubicBezTo>
+                <a:cubicBezTo>
+                  <a:pt x="1809972" y="50744"/>
+                  <a:pt x="1540276" y="46798"/>
+                  <a:pt x="1306286" y="18288"/>
+                </a:cubicBezTo>
+                <a:cubicBezTo>
+                  <a:pt x="1072296" y="-10222"/>
+                  <a:pt x="972445" y="19645"/>
+                  <a:pt x="790303" y="18288"/>
+                </a:cubicBezTo>
+                <a:cubicBezTo>
+                  <a:pt x="608161" y="16931"/>
+                  <a:pt x="200981" y="8241"/>
+                  <a:pt x="0" y="18288"/>
+                </a:cubicBezTo>
+                <a:cubicBezTo>
+                  <a:pt x="-229" y="14222"/>
+                  <a:pt x="509" y="5816"/>
+                  <a:pt x="0" y="0"/>
+                </a:cubicBezTo>
+                <a:close/>
+              </a:path>
+              <a:path w="4572000" h="18288" stroke="0" extrusionOk="0">
+                <a:moveTo>
+                  <a:pt x="0" y="0"/>
+                </a:moveTo>
+                <a:cubicBezTo>
+                  <a:pt x="143285" y="-9565"/>
+                  <a:pt x="327959" y="-11498"/>
+                  <a:pt x="561703" y="0"/>
+                </a:cubicBezTo>
+                <a:cubicBezTo>
+                  <a:pt x="795447" y="11498"/>
+                  <a:pt x="838260" y="18255"/>
+                  <a:pt x="1077686" y="0"/>
+                </a:cubicBezTo>
+                <a:cubicBezTo>
+                  <a:pt x="1317112" y="-18255"/>
+                  <a:pt x="1437472" y="23514"/>
+                  <a:pt x="1639389" y="0"/>
+                </a:cubicBezTo>
+                <a:cubicBezTo>
+                  <a:pt x="1841306" y="-23514"/>
+                  <a:pt x="2037142" y="-12551"/>
+                  <a:pt x="2292531" y="0"/>
+                </a:cubicBezTo>
+                <a:cubicBezTo>
+                  <a:pt x="2547920" y="12551"/>
+                  <a:pt x="2810436" y="-20352"/>
+                  <a:pt x="2991394" y="0"/>
+                </a:cubicBezTo>
+                <a:cubicBezTo>
+                  <a:pt x="3172352" y="20352"/>
+                  <a:pt x="3530025" y="-13347"/>
+                  <a:pt x="3735977" y="0"/>
+                </a:cubicBezTo>
+                <a:cubicBezTo>
+                  <a:pt x="3941929" y="13347"/>
+                  <a:pt x="4161497" y="34086"/>
+                  <a:pt x="4572000" y="0"/>
+                </a:cubicBezTo>
+                <a:cubicBezTo>
+                  <a:pt x="4571545" y="6162"/>
+                  <a:pt x="4571903" y="11775"/>
+                  <a:pt x="4572000" y="18288"/>
+                </a:cubicBezTo>
+                <a:cubicBezTo>
+                  <a:pt x="4228040" y="36490"/>
+                  <a:pt x="4199736" y="42557"/>
+                  <a:pt x="3873137" y="18288"/>
+                </a:cubicBezTo>
+                <a:cubicBezTo>
+                  <a:pt x="3546538" y="-5981"/>
+                  <a:pt x="3472124" y="16809"/>
+                  <a:pt x="3128554" y="18288"/>
+                </a:cubicBezTo>
+                <a:cubicBezTo>
+                  <a:pt x="2784984" y="19767"/>
+                  <a:pt x="2735896" y="-17781"/>
+                  <a:pt x="2383971" y="18288"/>
+                </a:cubicBezTo>
+                <a:cubicBezTo>
+                  <a:pt x="2032046" y="54357"/>
+                  <a:pt x="2019324" y="2920"/>
+                  <a:pt x="1867989" y="18288"/>
+                </a:cubicBezTo>
+                <a:cubicBezTo>
+                  <a:pt x="1716654" y="33656"/>
+                  <a:pt x="1418675" y="32575"/>
+                  <a:pt x="1169126" y="18288"/>
+                </a:cubicBezTo>
+                <a:cubicBezTo>
+                  <a:pt x="919577" y="4001"/>
+                  <a:pt x="798537" y="16165"/>
+                  <a:pt x="561703" y="18288"/>
+                </a:cubicBezTo>
+                <a:cubicBezTo>
+                  <a:pt x="324869" y="20411"/>
+                  <a:pt x="221395" y="-912"/>
+                  <a:pt x="0" y="18288"/>
+                </a:cubicBezTo>
+                <a:cubicBezTo>
+                  <a:pt x="766" y="10800"/>
+                  <a:pt x="-457" y="8180"/>
+                  <a:pt x="0" y="0"/>
+                </a:cubicBezTo>
+                <a:close/>
+              </a:path>
+            </a:pathLst>
+          </a:custGeom>
+          <a:solidFill>
+            <a:schemeClr val="accent2"/>
+          </a:solidFill>
+          <a:ln w="41275" cap="rnd">
+            <a:solidFill>
+              <a:schemeClr val="accent2"/>
+            </a:solidFill>
+            <a:round/>
+            <a:extLst>
+              <a:ext uri="{C807C97D-BFC1-408E-A445-0C87EB9F89A2}">
+                <ask:lineSketchStyleProps xmlns:ask="http://schemas.microsoft.com/office/drawing/2018/sketchyshapes" sd="2727557108">
+                  <a:prstGeom prst="rect">
+                    <a:avLst/>
+                  </a:prstGeom>
+                  <ask:type>
+                    <ask:lineSketchFreehand/>
+                  </ask:type>
+                </ask:lineSketchStyleProps>
+              </a:ext>
+            </a:extLst>
+          </a:ln>
+        </p:spPr>
+        <p:style>
+          <a:lnRef idx="2">
+            <a:schemeClr val="accent1">
+              <a:shade val="50000"/>
+            </a:schemeClr>
+          </a:lnRef>
+          <a:fillRef idx="1">
+            <a:schemeClr val="accent1"/>
+          </a:fillRef>
+          <a:effectRef idx="0">
+            <a:schemeClr val="accent1"/>
+          </a:effectRef>
+          <a:fontRef idx="minor">
+            <a:schemeClr val="lt1"/>
+          </a:fontRef>
+        </p:style>
+        <p:txBody>
+          <a:bodyPr rtlCol="0" anchor="ctr"/>
+          <a:lstStyle/>
+          <a:p>
+            <a:pPr algn="ctr"/>
+            <a:endParaRPr lang="en-US"/>
+          </a:p>
+        </p:txBody>
+      </p:sp>
+      <p:pic>
+        <p:nvPicPr>
+          <p:cNvPr id="3" name="Picture 2">
+            <a:extLst>
+              <a:ext uri="{FF2B5EF4-FFF2-40B4-BE49-F238E27FC236}">
+                <a16:creationId xmlns:a16="http://schemas.microsoft.com/office/drawing/2014/main" id="{828CB561-43E4-E505-D83C-D40356F5D250}"/>
+              </a:ext>
+            </a:extLst>
+          </p:cNvPr>
+          <p:cNvPicPr>
+            <a:picLocks noChangeAspect="1"/>
+          </p:cNvPicPr>
+          <p:nvPr/>
+        </p:nvPicPr>
+        <p:blipFill>
+          <a:blip r:embed="rId3"/>
+          <a:stretch>
+            <a:fillRect/>
+          </a:stretch>
+        </p:blipFill>
+        <p:spPr>
+          <a:xfrm>
+            <a:off x="320040" y="2983039"/>
+            <a:ext cx="11548872" cy="2887219"/>
+          </a:xfrm>
+          <a:prstGeom prst="rect">
+            <a:avLst/>
+          </a:prstGeom>
+        </p:spPr>
+      </p:pic>
+    </p:spTree>
+    <p:extLst>
+      <p:ext uri="{BB962C8B-B14F-4D97-AF65-F5344CB8AC3E}">
+        <p14:creationId xmlns:p14="http://schemas.microsoft.com/office/powerpoint/2010/main" val="1426268313"/>
+      </p:ext>
+    </p:extLst>
+  </p:cSld>
+  <p:clrMapOvr>
+    <a:masterClrMapping/>
+  </p:clrMapOvr>
+</p:sld>
+</file>
+
+<file path=ppt/slides/slide11.xml><?xml version="1.0" encoding="utf-8"?>
+<p:sld xmlns:a="http://schemas.openxmlformats.org/drawingml/2006/main" xmlns:r="http://schemas.openxmlformats.org/officeDocument/2006/relationships" xmlns:p="http://schemas.openxmlformats.org/presentationml/2006/main">
+  <p:cSld>
+    <p:bg>
+      <p:bgPr>
+        <a:solidFill>
+          <a:schemeClr val="bg1"/>
+        </a:solidFill>
+        <a:effectLst/>
+      </p:bgPr>
+    </p:bg>
+    <p:spTree>
+      <p:nvGrpSpPr>
+        <p:cNvPr id="1" name="">
+          <a:extLst>
+            <a:ext uri="{FF2B5EF4-FFF2-40B4-BE49-F238E27FC236}">
+              <a16:creationId xmlns:a16="http://schemas.microsoft.com/office/drawing/2014/main" id="{E8B6EE3E-3B36-F86B-463A-2565C9C1831E}"/>
+            </a:ext>
+          </a:extLst>
+        </p:cNvPr>
+        <p:cNvGrpSpPr/>
+        <p:nvPr/>
+      </p:nvGrpSpPr>
+      <p:grpSpPr>
+        <a:xfrm>
+          <a:off x="0" y="0"/>
+          <a:ext cx="0" cy="0"/>
+          <a:chOff x="0" y="0"/>
+          <a:chExt cx="0" cy="0"/>
+        </a:xfrm>
+      </p:grpSpPr>
+      <p:sp useBgFill="1">
+        <p:nvSpPr>
+          <p:cNvPr id="73" name="Rectangle 72">
+            <a:extLst>
+              <a:ext uri="{FF2B5EF4-FFF2-40B4-BE49-F238E27FC236}">
+                <a16:creationId xmlns:a16="http://schemas.microsoft.com/office/drawing/2014/main" id="{2B97F24A-32CE-4C1C-A50D-3016B394DCFB}"/>
+              </a:ext>
+              <a:ext uri="{C183D7F6-B498-43B3-948B-1728B52AA6E4}">
+                <adec:decorative xmlns:adec="http://schemas.microsoft.com/office/drawing/2017/decorative" val="1"/>
+              </a:ext>
+            </a:extLst>
+          </p:cNvPr>
+          <p:cNvSpPr>
+            <a:spLocks noGrp="1" noRot="1" noChangeAspect="1" noMove="1" noResize="1" noEditPoints="1" noAdjustHandles="1" noChangeArrowheads="1" noChangeShapeType="1" noTextEdit="1"/>
+          </p:cNvSpPr>
+          <p:nvPr>
+            <p:extLst>
+              <p:ext uri="{386F3935-93C4-4BCD-93E2-E3B085C9AB24}">
+                <p16:designElem xmlns:p16="http://schemas.microsoft.com/office/powerpoint/2015/main" val="1"/>
+              </p:ext>
+            </p:extLst>
+          </p:nvPr>
+        </p:nvSpPr>
+        <p:spPr>
+          <a:xfrm>
+            <a:off x="0" y="0"/>
+            <a:ext cx="12192000" cy="6858000"/>
+          </a:xfrm>
+          <a:prstGeom prst="rect">
+            <a:avLst/>
+          </a:prstGeom>
+          <a:ln>
+            <a:noFill/>
+          </a:ln>
+        </p:spPr>
+        <p:style>
+          <a:lnRef idx="2">
+            <a:schemeClr val="accent1">
+              <a:shade val="50000"/>
+            </a:schemeClr>
+          </a:lnRef>
+          <a:fillRef idx="1">
+            <a:schemeClr val="accent1"/>
+          </a:fillRef>
+          <a:effectRef idx="0">
+            <a:schemeClr val="accent1"/>
+          </a:effectRef>
+          <a:fontRef idx="minor">
+            <a:schemeClr val="lt1"/>
+          </a:fontRef>
+        </p:style>
+        <p:txBody>
+          <a:bodyPr rtlCol="0" anchor="ctr"/>
+          <a:lstStyle/>
+          <a:p>
+            <a:pPr algn="ctr"/>
+            <a:endParaRPr lang="en-US"/>
+          </a:p>
+        </p:txBody>
+      </p:sp>
+      <p:sp>
+        <p:nvSpPr>
+          <p:cNvPr id="2" name="Title 1">
+            <a:extLst>
+              <a:ext uri="{FF2B5EF4-FFF2-40B4-BE49-F238E27FC236}">
+                <a16:creationId xmlns:a16="http://schemas.microsoft.com/office/drawing/2014/main" id="{5570279A-0567-9DEA-6111-4A4A32A394E2}"/>
+              </a:ext>
+            </a:extLst>
+          </p:cNvPr>
+          <p:cNvSpPr>
+            <a:spLocks noGrp="1"/>
+          </p:cNvSpPr>
+          <p:nvPr>
+            <p:ph type="title"/>
+          </p:nvPr>
+        </p:nvSpPr>
+        <p:spPr>
+          <a:xfrm>
+            <a:off x="630936" y="639520"/>
+            <a:ext cx="3429000" cy="1719072"/>
+          </a:xfrm>
+        </p:spPr>
+        <p:txBody>
+          <a:bodyPr vert="horz" lIns="91440" tIns="45720" rIns="91440" bIns="45720" rtlCol="0" anchor="b">
+            <a:normAutofit/>
+          </a:bodyPr>
+          <a:lstStyle/>
+          <a:p>
+            <a:r>
+              <a:rPr lang="en-US" sz="5000" b="1" kern="1200">
+                <a:solidFill>
+                  <a:schemeClr val="tx1"/>
+                </a:solidFill>
+                <a:latin typeface="+mj-lt"/>
+                <a:ea typeface="+mj-ea"/>
+                <a:cs typeface="+mj-cs"/>
+              </a:rPr>
+              <a:t>Continuous Batching</a:t>
+            </a:r>
+          </a:p>
+        </p:txBody>
+      </p:sp>
+      <p:sp>
+        <p:nvSpPr>
+          <p:cNvPr id="75" name="sketch line">
+            <a:extLst>
+              <a:ext uri="{FF2B5EF4-FFF2-40B4-BE49-F238E27FC236}">
+                <a16:creationId xmlns:a16="http://schemas.microsoft.com/office/drawing/2014/main" id="{CD8B4F24-440B-49E9-B85D-733523DC064B}"/>
+              </a:ext>
+              <a:ext uri="{C183D7F6-B498-43B3-948B-1728B52AA6E4}">
+                <adec:decorative xmlns:adec="http://schemas.microsoft.com/office/drawing/2017/decorative" val="1"/>
+              </a:ext>
+            </a:extLst>
+          </p:cNvPr>
+          <p:cNvSpPr>
+            <a:spLocks noGrp="1" noRot="1" noChangeAspect="1" noMove="1" noResize="1" noEditPoints="1" noAdjustHandles="1" noChangeArrowheads="1" noChangeShapeType="1" noTextEdit="1"/>
+          </p:cNvSpPr>
+          <p:nvPr>
+            <p:extLst>
+              <p:ext uri="{386F3935-93C4-4BCD-93E2-E3B085C9AB24}">
+                <p16:designElem xmlns:p16="http://schemas.microsoft.com/office/powerpoint/2015/main" val="1"/>
+              </p:ext>
+            </p:extLst>
+          </p:nvPr>
+        </p:nvSpPr>
+        <p:spPr>
+          <a:xfrm>
+            <a:off x="643278" y="2573756"/>
+            <a:ext cx="3255095" cy="18288"/>
+          </a:xfrm>
+          <a:custGeom>
+            <a:avLst/>
+            <a:gdLst>
+              <a:gd name="csX0" fmla="*/ 0 w 3255095"/>
+              <a:gd name="csY0" fmla="*/ 0 h 18288"/>
+              <a:gd name="csX1" fmla="*/ 618468 w 3255095"/>
+              <a:gd name="csY1" fmla="*/ 0 h 18288"/>
+              <a:gd name="csX2" fmla="*/ 1269487 w 3255095"/>
+              <a:gd name="csY2" fmla="*/ 0 h 18288"/>
+              <a:gd name="csX3" fmla="*/ 1953057 w 3255095"/>
+              <a:gd name="csY3" fmla="*/ 0 h 18288"/>
+              <a:gd name="csX4" fmla="*/ 2636627 w 3255095"/>
+              <a:gd name="csY4" fmla="*/ 0 h 18288"/>
+              <a:gd name="csX5" fmla="*/ 3255095 w 3255095"/>
+              <a:gd name="csY5" fmla="*/ 0 h 18288"/>
+              <a:gd name="csX6" fmla="*/ 3255095 w 3255095"/>
+              <a:gd name="csY6" fmla="*/ 18288 h 18288"/>
+              <a:gd name="csX7" fmla="*/ 2538974 w 3255095"/>
+              <a:gd name="csY7" fmla="*/ 18288 h 18288"/>
+              <a:gd name="csX8" fmla="*/ 1822853 w 3255095"/>
+              <a:gd name="csY8" fmla="*/ 18288 h 18288"/>
+              <a:gd name="csX9" fmla="*/ 1171834 w 3255095"/>
+              <a:gd name="csY9" fmla="*/ 18288 h 18288"/>
+              <a:gd name="csX10" fmla="*/ 0 w 3255095"/>
+              <a:gd name="csY10" fmla="*/ 18288 h 18288"/>
+              <a:gd name="csX11" fmla="*/ 0 w 3255095"/>
+              <a:gd name="csY11" fmla="*/ 0 h 18288"/>
+            </a:gdLst>
+            <a:ahLst/>
+            <a:cxnLst>
+              <a:cxn ang="0">
+                <a:pos x="csX0" y="csY0"/>
+              </a:cxn>
+              <a:cxn ang="0">
+                <a:pos x="csX1" y="csY1"/>
+              </a:cxn>
+              <a:cxn ang="0">
+                <a:pos x="csX2" y="csY2"/>
+              </a:cxn>
+              <a:cxn ang="0">
+                <a:pos x="csX3" y="csY3"/>
+              </a:cxn>
+              <a:cxn ang="0">
+                <a:pos x="csX4" y="csY4"/>
+              </a:cxn>
+              <a:cxn ang="0">
+                <a:pos x="csX5" y="csY5"/>
+              </a:cxn>
+              <a:cxn ang="0">
+                <a:pos x="csX6" y="csY6"/>
+              </a:cxn>
+              <a:cxn ang="0">
+                <a:pos x="csX7" y="csY7"/>
+              </a:cxn>
+              <a:cxn ang="0">
+                <a:pos x="csX8" y="csY8"/>
+              </a:cxn>
+              <a:cxn ang="0">
+                <a:pos x="csX9" y="csY9"/>
+              </a:cxn>
+              <a:cxn ang="0">
+                <a:pos x="csX10" y="csY10"/>
+              </a:cxn>
+              <a:cxn ang="0">
+                <a:pos x="csX11" y="csY11"/>
+              </a:cxn>
+            </a:cxnLst>
+            <a:rect l="l" t="t" r="r" b="b"/>
+            <a:pathLst>
+              <a:path w="3255095" h="18288" fill="none" extrusionOk="0">
+                <a:moveTo>
+                  <a:pt x="0" y="0"/>
+                </a:moveTo>
+                <a:cubicBezTo>
+                  <a:pt x="240201" y="-22123"/>
+                  <a:pt x="462021" y="-19623"/>
+                  <a:pt x="618468" y="0"/>
+                </a:cubicBezTo>
+                <a:cubicBezTo>
+                  <a:pt x="774915" y="19623"/>
+                  <a:pt x="974734" y="2035"/>
+                  <a:pt x="1269487" y="0"/>
+                </a:cubicBezTo>
+                <a:cubicBezTo>
+                  <a:pt x="1564240" y="-2035"/>
+                  <a:pt x="1733579" y="10639"/>
+                  <a:pt x="1953057" y="0"/>
+                </a:cubicBezTo>
+                <a:cubicBezTo>
+                  <a:pt x="2172535" y="-10639"/>
+                  <a:pt x="2453962" y="14018"/>
+                  <a:pt x="2636627" y="0"/>
+                </a:cubicBezTo>
+                <a:cubicBezTo>
+                  <a:pt x="2819292" y="-14018"/>
+                  <a:pt x="3121375" y="5399"/>
+                  <a:pt x="3255095" y="0"/>
+                </a:cubicBezTo>
+                <a:cubicBezTo>
+                  <a:pt x="3254386" y="8157"/>
+                  <a:pt x="3254682" y="12125"/>
+                  <a:pt x="3255095" y="18288"/>
+                </a:cubicBezTo>
+                <a:cubicBezTo>
+                  <a:pt x="3088545" y="23203"/>
+                  <a:pt x="2687475" y="7419"/>
+                  <a:pt x="2538974" y="18288"/>
+                </a:cubicBezTo>
+                <a:cubicBezTo>
+                  <a:pt x="2390473" y="29157"/>
+                  <a:pt x="2137381" y="-8959"/>
+                  <a:pt x="1822853" y="18288"/>
+                </a:cubicBezTo>
+                <a:cubicBezTo>
+                  <a:pt x="1508325" y="45535"/>
+                  <a:pt x="1466437" y="20385"/>
+                  <a:pt x="1171834" y="18288"/>
+                </a:cubicBezTo>
+                <a:cubicBezTo>
+                  <a:pt x="877231" y="16191"/>
+                  <a:pt x="561097" y="37643"/>
+                  <a:pt x="0" y="18288"/>
+                </a:cubicBezTo>
+                <a:cubicBezTo>
+                  <a:pt x="-46" y="12483"/>
+                  <a:pt x="-203" y="6491"/>
+                  <a:pt x="0" y="0"/>
+                </a:cubicBezTo>
+                <a:close/>
+              </a:path>
+              <a:path w="3255095" h="18288" stroke="0" extrusionOk="0">
+                <a:moveTo>
+                  <a:pt x="0" y="0"/>
+                </a:moveTo>
+                <a:cubicBezTo>
+                  <a:pt x="291965" y="19429"/>
+                  <a:pt x="363155" y="8568"/>
+                  <a:pt x="618468" y="0"/>
+                </a:cubicBezTo>
+                <a:cubicBezTo>
+                  <a:pt x="873781" y="-8568"/>
+                  <a:pt x="904459" y="-19505"/>
+                  <a:pt x="1171834" y="0"/>
+                </a:cubicBezTo>
+                <a:cubicBezTo>
+                  <a:pt x="1439209" y="19505"/>
+                  <a:pt x="1744369" y="9790"/>
+                  <a:pt x="1887955" y="0"/>
+                </a:cubicBezTo>
+                <a:cubicBezTo>
+                  <a:pt x="2031541" y="-9790"/>
+                  <a:pt x="2346378" y="21240"/>
+                  <a:pt x="2506423" y="0"/>
+                </a:cubicBezTo>
+                <a:cubicBezTo>
+                  <a:pt x="2666468" y="-21240"/>
+                  <a:pt x="2990257" y="30414"/>
+                  <a:pt x="3255095" y="0"/>
+                </a:cubicBezTo>
+                <a:cubicBezTo>
+                  <a:pt x="3254831" y="4493"/>
+                  <a:pt x="3255479" y="9472"/>
+                  <a:pt x="3255095" y="18288"/>
+                </a:cubicBezTo>
+                <a:cubicBezTo>
+                  <a:pt x="3120743" y="16690"/>
+                  <a:pt x="2759628" y="42462"/>
+                  <a:pt x="2604076" y="18288"/>
+                </a:cubicBezTo>
+                <a:cubicBezTo>
+                  <a:pt x="2448524" y="-5886"/>
+                  <a:pt x="2184336" y="19599"/>
+                  <a:pt x="1887955" y="18288"/>
+                </a:cubicBezTo>
+                <a:cubicBezTo>
+                  <a:pt x="1591574" y="16977"/>
+                  <a:pt x="1548845" y="6870"/>
+                  <a:pt x="1334589" y="18288"/>
+                </a:cubicBezTo>
+                <a:cubicBezTo>
+                  <a:pt x="1120333" y="29706"/>
+                  <a:pt x="996014" y="9662"/>
+                  <a:pt x="683570" y="18288"/>
+                </a:cubicBezTo>
+                <a:cubicBezTo>
+                  <a:pt x="371126" y="26914"/>
+                  <a:pt x="198687" y="16167"/>
+                  <a:pt x="0" y="18288"/>
+                </a:cubicBezTo>
+                <a:cubicBezTo>
+                  <a:pt x="843" y="9577"/>
+                  <a:pt x="371" y="6900"/>
+                  <a:pt x="0" y="0"/>
+                </a:cubicBezTo>
+                <a:close/>
+              </a:path>
+            </a:pathLst>
+          </a:custGeom>
+          <a:solidFill>
+            <a:schemeClr val="accent2"/>
+          </a:solidFill>
+          <a:ln w="38100" cap="rnd">
+            <a:solidFill>
+              <a:schemeClr val="accent2"/>
+            </a:solidFill>
+            <a:round/>
+            <a:extLst>
+              <a:ext uri="{C807C97D-BFC1-408E-A445-0C87EB9F89A2}">
+                <ask:lineSketchStyleProps xmlns:ask="http://schemas.microsoft.com/office/drawing/2018/sketchyshapes" sd="1219033472">
+                  <a:prstGeom prst="rect">
+                    <a:avLst/>
+                  </a:prstGeom>
+                  <ask:type>
+                    <ask:lineSketchFreehand/>
+                  </ask:type>
+                </ask:lineSketchStyleProps>
+              </a:ext>
+            </a:extLst>
+          </a:ln>
+        </p:spPr>
+        <p:style>
+          <a:lnRef idx="2">
+            <a:schemeClr val="accent1">
+              <a:shade val="50000"/>
+            </a:schemeClr>
+          </a:lnRef>
+          <a:fillRef idx="1">
+            <a:schemeClr val="accent1"/>
+          </a:fillRef>
+          <a:effectRef idx="0">
+            <a:schemeClr val="accent1"/>
+          </a:effectRef>
+          <a:fontRef idx="minor">
+            <a:schemeClr val="lt1"/>
+          </a:fontRef>
+        </p:style>
+        <p:txBody>
+          <a:bodyPr rtlCol="0" anchor="ctr"/>
+          <a:lstStyle/>
+          <a:p>
+            <a:pPr algn="ctr"/>
+            <a:endParaRPr lang="en-US"/>
+          </a:p>
+        </p:txBody>
+      </p:sp>
+      <p:sp>
+        <p:nvSpPr>
+          <p:cNvPr id="5" name="TextBox 4">
+            <a:extLst>
+              <a:ext uri="{FF2B5EF4-FFF2-40B4-BE49-F238E27FC236}">
+                <a16:creationId xmlns:a16="http://schemas.microsoft.com/office/drawing/2014/main" id="{974F3E77-AB24-140C-0382-5B7829BB80D1}"/>
+              </a:ext>
+            </a:extLst>
+          </p:cNvPr>
+          <p:cNvSpPr txBox="1"/>
+          <p:nvPr/>
+        </p:nvSpPr>
+        <p:spPr>
+          <a:xfrm>
+            <a:off x="630936" y="2807208"/>
+            <a:ext cx="3429000" cy="3410712"/>
+          </a:xfrm>
+          <a:prstGeom prst="rect">
+            <a:avLst/>
+          </a:prstGeom>
+        </p:spPr>
+        <p:txBody>
+          <a:bodyPr vert="horz" lIns="91440" tIns="45720" rIns="91440" bIns="45720" rtlCol="0" anchor="t">
+            <a:normAutofit/>
+          </a:bodyPr>
+          <a:lstStyle/>
+          <a:p>
+            <a:pPr>
+              <a:lnSpc>
+                <a:spcPct val="90000"/>
+              </a:lnSpc>
+              <a:spcAft>
+                <a:spcPts val="938"/>
+              </a:spcAft>
+            </a:pPr>
+            <a:r>
+              <a:rPr lang="en-US" sz="1500" b="0" i="0" dirty="0">
+                <a:effectLst/>
+              </a:rPr>
+              <a:t>If Paged Attention improves memory efficiency, </a:t>
+            </a:r>
+            <a:r>
+              <a:rPr lang="en-US" sz="1500" b="1" i="0" dirty="0">
+                <a:effectLst/>
+              </a:rPr>
+              <a:t>Continuous Batching</a:t>
+            </a:r>
+            <a:r>
+              <a:rPr lang="en-US" sz="1500" b="0" i="0" dirty="0">
+                <a:effectLst/>
+              </a:rPr>
+              <a:t> maximizes GPU computation efficiency.</a:t>
+            </a:r>
+          </a:p>
+          <a:p>
+            <a:pPr indent="-228600">
+              <a:lnSpc>
+                <a:spcPct val="90000"/>
+              </a:lnSpc>
+              <a:spcAft>
+                <a:spcPts val="938"/>
+              </a:spcAft>
+              <a:buFont typeface="Arial" panose="020B0604020202020204" pitchFamily="34" charset="0"/>
+              <a:buChar char="•"/>
+            </a:pPr>
+            <a:r>
+              <a:rPr lang="en-US" sz="1500" b="0" i="0" dirty="0">
+                <a:effectLst/>
+              </a:rPr>
+              <a:t>Traditional batch inference:</a:t>
+            </a:r>
+          </a:p>
+          <a:p>
+            <a:pPr indent="-228600">
+              <a:lnSpc>
+                <a:spcPct val="90000"/>
+              </a:lnSpc>
+              <a:spcAft>
+                <a:spcPts val="938"/>
+              </a:spcAft>
+              <a:buFont typeface="Arial" panose="020B0604020202020204" pitchFamily="34" charset="0"/>
+              <a:buChar char="•"/>
+            </a:pPr>
+            <a:r>
+              <a:rPr lang="en-US" sz="1500" b="0" i="0" dirty="0">
+                <a:effectLst/>
+              </a:rPr>
+              <a:t>Collect requests → form a batch → process the entire batch → then move to the next batch But LLM requests differ in completion time (due to different output lengths). Thus, while a slow request continues, faster requests </a:t>
+            </a:r>
+            <a:r>
+              <a:rPr lang="en-US" sz="1500" b="1" i="0" dirty="0">
+                <a:effectLst/>
+              </a:rPr>
+              <a:t>remain stuck waiting</a:t>
+            </a:r>
+            <a:r>
+              <a:rPr lang="en-US" sz="1500" b="0" i="0" dirty="0">
+                <a:effectLst/>
+              </a:rPr>
+              <a:t>, wasting GPU compute capacity.</a:t>
+            </a:r>
+          </a:p>
+        </p:txBody>
+      </p:sp>
+      <p:pic>
+        <p:nvPicPr>
+          <p:cNvPr id="6" name="Picture 5">
+            <a:extLst>
+              <a:ext uri="{FF2B5EF4-FFF2-40B4-BE49-F238E27FC236}">
+                <a16:creationId xmlns:a16="http://schemas.microsoft.com/office/drawing/2014/main" id="{03002B1A-8649-3968-9123-7D1FED715BA4}"/>
+              </a:ext>
+            </a:extLst>
+          </p:cNvPr>
+          <p:cNvPicPr>
+            <a:picLocks noChangeAspect="1"/>
+          </p:cNvPicPr>
+          <p:nvPr/>
+        </p:nvPicPr>
+        <p:blipFill>
+          <a:blip r:embed="rId3"/>
+          <a:stretch>
+            <a:fillRect/>
+          </a:stretch>
+        </p:blipFill>
+        <p:spPr>
+          <a:xfrm>
+            <a:off x="4654296" y="1944700"/>
+            <a:ext cx="6903720" cy="2968600"/>
+          </a:xfrm>
+          <a:prstGeom prst="rect">
+            <a:avLst/>
+          </a:prstGeom>
+        </p:spPr>
+      </p:pic>
+    </p:spTree>
+    <p:extLst>
+      <p:ext uri="{BB962C8B-B14F-4D97-AF65-F5344CB8AC3E}">
+        <p14:creationId xmlns:p14="http://schemas.microsoft.com/office/powerpoint/2010/main" val="3911955687"/>
+      </p:ext>
+    </p:extLst>
+  </p:cSld>
+  <p:clrMapOvr>
+    <a:masterClrMapping/>
+  </p:clrMapOvr>
+</p:sld>
+</file>
+
+<file path=ppt/slides/slide12.xml><?xml version="1.0" encoding="utf-8"?>
+<p:sld xmlns:a="http://schemas.openxmlformats.org/drawingml/2006/main" xmlns:r="http://schemas.openxmlformats.org/officeDocument/2006/relationships" xmlns:p="http://schemas.openxmlformats.org/presentationml/2006/main">
+  <p:cSld>
+    <p:bg>
+      <p:bgPr>
+        <a:solidFill>
+          <a:schemeClr val="bg1"/>
+        </a:solidFill>
+        <a:effectLst/>
+      </p:bgPr>
+    </p:bg>
+    <p:spTree>
+      <p:nvGrpSpPr>
+        <p:cNvPr id="1" name="">
+          <a:extLst>
+            <a:ext uri="{FF2B5EF4-FFF2-40B4-BE49-F238E27FC236}">
+              <a16:creationId xmlns:a16="http://schemas.microsoft.com/office/drawing/2014/main" id="{B51BA401-DB5F-9955-0BB0-A83AE286F97E}"/>
+            </a:ext>
+          </a:extLst>
+        </p:cNvPr>
+        <p:cNvGrpSpPr/>
+        <p:nvPr/>
+      </p:nvGrpSpPr>
+      <p:grpSpPr>
+        <a:xfrm>
+          <a:off x="0" y="0"/>
+          <a:ext cx="0" cy="0"/>
+          <a:chOff x="0" y="0"/>
+          <a:chExt cx="0" cy="0"/>
+        </a:xfrm>
+      </p:grpSpPr>
+      <p:sp useBgFill="1">
+        <p:nvSpPr>
+          <p:cNvPr id="91" name="Rectangle 90">
+            <a:extLst>
+              <a:ext uri="{FF2B5EF4-FFF2-40B4-BE49-F238E27FC236}">
+                <a16:creationId xmlns:a16="http://schemas.microsoft.com/office/drawing/2014/main" id="{2B97F24A-32CE-4C1C-A50D-3016B394DCFB}"/>
+              </a:ext>
+              <a:ext uri="{C183D7F6-B498-43B3-948B-1728B52AA6E4}">
+                <adec:decorative xmlns:adec="http://schemas.microsoft.com/office/drawing/2017/decorative" val="1"/>
+              </a:ext>
+            </a:extLst>
+          </p:cNvPr>
+          <p:cNvSpPr>
+            <a:spLocks noGrp="1" noRot="1" noChangeAspect="1" noMove="1" noResize="1" noEditPoints="1" noAdjustHandles="1" noChangeArrowheads="1" noChangeShapeType="1" noTextEdit="1"/>
+          </p:cNvSpPr>
+          <p:nvPr>
+            <p:extLst>
+              <p:ext uri="{386F3935-93C4-4BCD-93E2-E3B085C9AB24}">
+                <p16:designElem xmlns:p16="http://schemas.microsoft.com/office/powerpoint/2015/main" val="1"/>
+              </p:ext>
+            </p:extLst>
+          </p:nvPr>
+        </p:nvSpPr>
+        <p:spPr>
+          <a:xfrm>
+            <a:off x="0" y="0"/>
+            <a:ext cx="12192000" cy="6858000"/>
+          </a:xfrm>
+          <a:prstGeom prst="rect">
+            <a:avLst/>
+          </a:prstGeom>
+          <a:ln>
+            <a:noFill/>
+          </a:ln>
+        </p:spPr>
+        <p:style>
+          <a:lnRef idx="2">
+            <a:schemeClr val="accent1">
+              <a:shade val="50000"/>
+            </a:schemeClr>
+          </a:lnRef>
+          <a:fillRef idx="1">
+            <a:schemeClr val="accent1"/>
+          </a:fillRef>
+          <a:effectRef idx="0">
+            <a:schemeClr val="accent1"/>
+          </a:effectRef>
+          <a:fontRef idx="minor">
+            <a:schemeClr val="lt1"/>
+          </a:fontRef>
+        </p:style>
+        <p:txBody>
+          <a:bodyPr rtlCol="0" anchor="ctr"/>
+          <a:lstStyle/>
+          <a:p>
+            <a:pPr algn="ctr"/>
+            <a:endParaRPr lang="en-US"/>
+          </a:p>
+        </p:txBody>
+      </p:sp>
+      <p:sp>
+        <p:nvSpPr>
+          <p:cNvPr id="2" name="Title 1">
+            <a:extLst>
+              <a:ext uri="{FF2B5EF4-FFF2-40B4-BE49-F238E27FC236}">
+                <a16:creationId xmlns:a16="http://schemas.microsoft.com/office/drawing/2014/main" id="{A1CA99BA-DC6D-6483-485B-185D3D2C88B9}"/>
+              </a:ext>
+            </a:extLst>
+          </p:cNvPr>
+          <p:cNvSpPr>
+            <a:spLocks noGrp="1"/>
+          </p:cNvSpPr>
+          <p:nvPr>
+            <p:ph type="title"/>
+          </p:nvPr>
+        </p:nvSpPr>
+        <p:spPr>
+          <a:xfrm>
+            <a:off x="630936" y="639520"/>
+            <a:ext cx="3429000" cy="1719072"/>
+          </a:xfrm>
+        </p:spPr>
+        <p:txBody>
+          <a:bodyPr vert="horz" lIns="91440" tIns="45720" rIns="91440" bIns="45720" rtlCol="0" anchor="b">
+            <a:normAutofit/>
+          </a:bodyPr>
+          <a:lstStyle/>
+          <a:p>
+            <a:r>
+              <a:rPr lang="en-US" sz="5000" b="1" kern="1200">
+                <a:solidFill>
+                  <a:schemeClr val="tx1"/>
+                </a:solidFill>
+                <a:latin typeface="+mj-lt"/>
+                <a:ea typeface="+mj-ea"/>
+                <a:cs typeface="+mj-cs"/>
+              </a:rPr>
+              <a:t>Continuous Batching</a:t>
+            </a:r>
+          </a:p>
+        </p:txBody>
+      </p:sp>
+      <p:sp>
+        <p:nvSpPr>
+          <p:cNvPr id="92" name="sketch line">
+            <a:extLst>
+              <a:ext uri="{FF2B5EF4-FFF2-40B4-BE49-F238E27FC236}">
+                <a16:creationId xmlns:a16="http://schemas.microsoft.com/office/drawing/2014/main" id="{CD8B4F24-440B-49E9-B85D-733523DC064B}"/>
+              </a:ext>
+              <a:ext uri="{C183D7F6-B498-43B3-948B-1728B52AA6E4}">
+                <adec:decorative xmlns:adec="http://schemas.microsoft.com/office/drawing/2017/decorative" val="1"/>
+              </a:ext>
+            </a:extLst>
+          </p:cNvPr>
+          <p:cNvSpPr>
+            <a:spLocks noGrp="1" noRot="1" noChangeAspect="1" noMove="1" noResize="1" noEditPoints="1" noAdjustHandles="1" noChangeArrowheads="1" noChangeShapeType="1" noTextEdit="1"/>
+          </p:cNvSpPr>
+          <p:nvPr>
+            <p:extLst>
+              <p:ext uri="{386F3935-93C4-4BCD-93E2-E3B085C9AB24}">
+                <p16:designElem xmlns:p16="http://schemas.microsoft.com/office/powerpoint/2015/main" val="1"/>
+              </p:ext>
+            </p:extLst>
+          </p:nvPr>
+        </p:nvSpPr>
+        <p:spPr>
+          <a:xfrm>
+            <a:off x="643278" y="2573756"/>
+            <a:ext cx="3255095" cy="18288"/>
+          </a:xfrm>
+          <a:custGeom>
+            <a:avLst/>
+            <a:gdLst>
+              <a:gd name="csX0" fmla="*/ 0 w 3255095"/>
+              <a:gd name="csY0" fmla="*/ 0 h 18288"/>
+              <a:gd name="csX1" fmla="*/ 618468 w 3255095"/>
+              <a:gd name="csY1" fmla="*/ 0 h 18288"/>
+              <a:gd name="csX2" fmla="*/ 1269487 w 3255095"/>
+              <a:gd name="csY2" fmla="*/ 0 h 18288"/>
+              <a:gd name="csX3" fmla="*/ 1953057 w 3255095"/>
+              <a:gd name="csY3" fmla="*/ 0 h 18288"/>
+              <a:gd name="csX4" fmla="*/ 2636627 w 3255095"/>
+              <a:gd name="csY4" fmla="*/ 0 h 18288"/>
+              <a:gd name="csX5" fmla="*/ 3255095 w 3255095"/>
+              <a:gd name="csY5" fmla="*/ 0 h 18288"/>
+              <a:gd name="csX6" fmla="*/ 3255095 w 3255095"/>
+              <a:gd name="csY6" fmla="*/ 18288 h 18288"/>
+              <a:gd name="csX7" fmla="*/ 2538974 w 3255095"/>
+              <a:gd name="csY7" fmla="*/ 18288 h 18288"/>
+              <a:gd name="csX8" fmla="*/ 1822853 w 3255095"/>
+              <a:gd name="csY8" fmla="*/ 18288 h 18288"/>
+              <a:gd name="csX9" fmla="*/ 1171834 w 3255095"/>
+              <a:gd name="csY9" fmla="*/ 18288 h 18288"/>
+              <a:gd name="csX10" fmla="*/ 0 w 3255095"/>
+              <a:gd name="csY10" fmla="*/ 18288 h 18288"/>
+              <a:gd name="csX11" fmla="*/ 0 w 3255095"/>
+              <a:gd name="csY11" fmla="*/ 0 h 18288"/>
+            </a:gdLst>
+            <a:ahLst/>
+            <a:cxnLst>
+              <a:cxn ang="0">
+                <a:pos x="csX0" y="csY0"/>
+              </a:cxn>
+              <a:cxn ang="0">
+                <a:pos x="csX1" y="csY1"/>
+              </a:cxn>
+              <a:cxn ang="0">
+                <a:pos x="csX2" y="csY2"/>
+              </a:cxn>
+              <a:cxn ang="0">
+                <a:pos x="csX3" y="csY3"/>
+              </a:cxn>
+              <a:cxn ang="0">
+                <a:pos x="csX4" y="csY4"/>
+              </a:cxn>
+              <a:cxn ang="0">
+                <a:pos x="csX5" y="csY5"/>
+              </a:cxn>
+              <a:cxn ang="0">
+                <a:pos x="csX6" y="csY6"/>
+              </a:cxn>
+              <a:cxn ang="0">
+                <a:pos x="csX7" y="csY7"/>
+              </a:cxn>
+              <a:cxn ang="0">
+                <a:pos x="csX8" y="csY8"/>
+              </a:cxn>
+              <a:cxn ang="0">
+                <a:pos x="csX9" y="csY9"/>
+              </a:cxn>
+              <a:cxn ang="0">
+                <a:pos x="csX10" y="csY10"/>
+              </a:cxn>
+              <a:cxn ang="0">
+                <a:pos x="csX11" y="csY11"/>
+              </a:cxn>
+            </a:cxnLst>
+            <a:rect l="l" t="t" r="r" b="b"/>
+            <a:pathLst>
+              <a:path w="3255095" h="18288" fill="none" extrusionOk="0">
+                <a:moveTo>
+                  <a:pt x="0" y="0"/>
+                </a:moveTo>
+                <a:cubicBezTo>
+                  <a:pt x="240201" y="-22123"/>
+                  <a:pt x="462021" y="-19623"/>
+                  <a:pt x="618468" y="0"/>
+                </a:cubicBezTo>
+                <a:cubicBezTo>
+                  <a:pt x="774915" y="19623"/>
+                  <a:pt x="974734" y="2035"/>
+                  <a:pt x="1269487" y="0"/>
+                </a:cubicBezTo>
+                <a:cubicBezTo>
+                  <a:pt x="1564240" y="-2035"/>
+                  <a:pt x="1733579" y="10639"/>
+                  <a:pt x="1953057" y="0"/>
+                </a:cubicBezTo>
+                <a:cubicBezTo>
+                  <a:pt x="2172535" y="-10639"/>
+                  <a:pt x="2453962" y="14018"/>
+                  <a:pt x="2636627" y="0"/>
+                </a:cubicBezTo>
+                <a:cubicBezTo>
+                  <a:pt x="2819292" y="-14018"/>
+                  <a:pt x="3121375" y="5399"/>
+                  <a:pt x="3255095" y="0"/>
+                </a:cubicBezTo>
+                <a:cubicBezTo>
+                  <a:pt x="3254386" y="8157"/>
+                  <a:pt x="3254682" y="12125"/>
+                  <a:pt x="3255095" y="18288"/>
+                </a:cubicBezTo>
+                <a:cubicBezTo>
+                  <a:pt x="3088545" y="23203"/>
+                  <a:pt x="2687475" y="7419"/>
+                  <a:pt x="2538974" y="18288"/>
+                </a:cubicBezTo>
+                <a:cubicBezTo>
+                  <a:pt x="2390473" y="29157"/>
+                  <a:pt x="2137381" y="-8959"/>
+                  <a:pt x="1822853" y="18288"/>
+                </a:cubicBezTo>
+                <a:cubicBezTo>
+                  <a:pt x="1508325" y="45535"/>
+                  <a:pt x="1466437" y="20385"/>
+                  <a:pt x="1171834" y="18288"/>
+                </a:cubicBezTo>
+                <a:cubicBezTo>
+                  <a:pt x="877231" y="16191"/>
+                  <a:pt x="561097" y="37643"/>
+                  <a:pt x="0" y="18288"/>
+                </a:cubicBezTo>
+                <a:cubicBezTo>
+                  <a:pt x="-46" y="12483"/>
+                  <a:pt x="-203" y="6491"/>
+                  <a:pt x="0" y="0"/>
+                </a:cubicBezTo>
+                <a:close/>
+              </a:path>
+              <a:path w="3255095" h="18288" stroke="0" extrusionOk="0">
+                <a:moveTo>
+                  <a:pt x="0" y="0"/>
+                </a:moveTo>
+                <a:cubicBezTo>
+                  <a:pt x="291965" y="19429"/>
+                  <a:pt x="363155" y="8568"/>
+                  <a:pt x="618468" y="0"/>
+                </a:cubicBezTo>
+                <a:cubicBezTo>
+                  <a:pt x="873781" y="-8568"/>
+                  <a:pt x="904459" y="-19505"/>
+                  <a:pt x="1171834" y="0"/>
+                </a:cubicBezTo>
+                <a:cubicBezTo>
+                  <a:pt x="1439209" y="19505"/>
+                  <a:pt x="1744369" y="9790"/>
+                  <a:pt x="1887955" y="0"/>
+                </a:cubicBezTo>
+                <a:cubicBezTo>
+                  <a:pt x="2031541" y="-9790"/>
+                  <a:pt x="2346378" y="21240"/>
+                  <a:pt x="2506423" y="0"/>
+                </a:cubicBezTo>
+                <a:cubicBezTo>
+                  <a:pt x="2666468" y="-21240"/>
+                  <a:pt x="2990257" y="30414"/>
+                  <a:pt x="3255095" y="0"/>
+                </a:cubicBezTo>
+                <a:cubicBezTo>
+                  <a:pt x="3254831" y="4493"/>
+                  <a:pt x="3255479" y="9472"/>
+                  <a:pt x="3255095" y="18288"/>
+                </a:cubicBezTo>
+                <a:cubicBezTo>
+                  <a:pt x="3120743" y="16690"/>
+                  <a:pt x="2759628" y="42462"/>
+                  <a:pt x="2604076" y="18288"/>
+                </a:cubicBezTo>
+                <a:cubicBezTo>
+                  <a:pt x="2448524" y="-5886"/>
+                  <a:pt x="2184336" y="19599"/>
+                  <a:pt x="1887955" y="18288"/>
+                </a:cubicBezTo>
+                <a:cubicBezTo>
+                  <a:pt x="1591574" y="16977"/>
+                  <a:pt x="1548845" y="6870"/>
+                  <a:pt x="1334589" y="18288"/>
+                </a:cubicBezTo>
+                <a:cubicBezTo>
+                  <a:pt x="1120333" y="29706"/>
+                  <a:pt x="996014" y="9662"/>
+                  <a:pt x="683570" y="18288"/>
+                </a:cubicBezTo>
+                <a:cubicBezTo>
+                  <a:pt x="371126" y="26914"/>
+                  <a:pt x="198687" y="16167"/>
+                  <a:pt x="0" y="18288"/>
+                </a:cubicBezTo>
+                <a:cubicBezTo>
+                  <a:pt x="843" y="9577"/>
+                  <a:pt x="371" y="6900"/>
+                  <a:pt x="0" y="0"/>
+                </a:cubicBezTo>
+                <a:close/>
+              </a:path>
+            </a:pathLst>
+          </a:custGeom>
+          <a:solidFill>
+            <a:schemeClr val="accent2"/>
+          </a:solidFill>
+          <a:ln w="38100" cap="rnd">
+            <a:solidFill>
+              <a:schemeClr val="accent2"/>
+            </a:solidFill>
+            <a:round/>
+            <a:extLst>
+              <a:ext uri="{C807C97D-BFC1-408E-A445-0C87EB9F89A2}">
+                <ask:lineSketchStyleProps xmlns:ask="http://schemas.microsoft.com/office/drawing/2018/sketchyshapes" sd="1219033472">
+                  <a:prstGeom prst="rect">
+                    <a:avLst/>
+                  </a:prstGeom>
+                  <ask:type>
+                    <ask:lineSketchFreehand/>
+                  </ask:type>
+                </ask:lineSketchStyleProps>
+              </a:ext>
+            </a:extLst>
+          </a:ln>
+        </p:spPr>
+        <p:style>
+          <a:lnRef idx="2">
+            <a:schemeClr val="accent1">
+              <a:shade val="50000"/>
+            </a:schemeClr>
+          </a:lnRef>
+          <a:fillRef idx="1">
+            <a:schemeClr val="accent1"/>
+          </a:fillRef>
+          <a:effectRef idx="0">
+            <a:schemeClr val="accent1"/>
+          </a:effectRef>
+          <a:fontRef idx="minor">
+            <a:schemeClr val="lt1"/>
+          </a:fontRef>
+        </p:style>
+        <p:txBody>
+          <a:bodyPr rtlCol="0" anchor="ctr"/>
+          <a:lstStyle/>
+          <a:p>
+            <a:pPr algn="ctr"/>
+            <a:endParaRPr lang="en-US"/>
+          </a:p>
+        </p:txBody>
+      </p:sp>
+      <p:sp>
+        <p:nvSpPr>
+          <p:cNvPr id="5" name="TextBox 4">
+            <a:extLst>
+              <a:ext uri="{FF2B5EF4-FFF2-40B4-BE49-F238E27FC236}">
+                <a16:creationId xmlns:a16="http://schemas.microsoft.com/office/drawing/2014/main" id="{3E969908-12E1-30A8-6339-406D2D3F55FB}"/>
+              </a:ext>
+            </a:extLst>
+          </p:cNvPr>
+          <p:cNvSpPr txBox="1"/>
+          <p:nvPr/>
+        </p:nvSpPr>
+        <p:spPr>
+          <a:xfrm>
+            <a:off x="630936" y="2807208"/>
+            <a:ext cx="4931664" cy="3411272"/>
+          </a:xfrm>
+          <a:prstGeom prst="rect">
+            <a:avLst/>
+          </a:prstGeom>
+        </p:spPr>
+        <p:txBody>
+          <a:bodyPr vert="horz" lIns="91440" tIns="45720" rIns="91440" bIns="45720" rtlCol="0" anchor="t">
+            <a:noAutofit/>
+          </a:bodyPr>
+          <a:lstStyle/>
+          <a:p>
+            <a:pPr indent="-228600">
+              <a:lnSpc>
+                <a:spcPct val="90000"/>
+              </a:lnSpc>
+              <a:spcAft>
+                <a:spcPts val="600"/>
+              </a:spcAft>
+              <a:buFont typeface="Arial" panose="020B0604020202020204" pitchFamily="34" charset="0"/>
+              <a:buChar char="•"/>
+            </a:pPr>
+            <a:r>
+              <a:rPr lang="en-US" sz="1200" dirty="0"/>
+              <a:t>Continuous Batching breaks the process into </a:t>
+            </a:r>
+            <a:r>
+              <a:rPr lang="en-US" sz="1200" b="1" dirty="0"/>
+              <a:t>token-generation iterations</a:t>
+            </a:r>
+            <a:r>
+              <a:rPr lang="en-US" sz="1200" dirty="0"/>
+              <a:t>. After each iteration:</a:t>
+            </a:r>
+          </a:p>
+          <a:p>
+            <a:pPr indent="-228600">
+              <a:lnSpc>
+                <a:spcPct val="90000"/>
+              </a:lnSpc>
+              <a:spcAft>
+                <a:spcPts val="600"/>
+              </a:spcAft>
+              <a:buFont typeface="Arial" panose="020B0604020202020204" pitchFamily="34" charset="0"/>
+              <a:buChar char="•"/>
+            </a:pPr>
+            <a:r>
+              <a:rPr lang="en-US" sz="1200" dirty="0"/>
+              <a:t>Finished requests exit the batch immediately</a:t>
+            </a:r>
+          </a:p>
+          <a:p>
+            <a:pPr indent="-228600">
+              <a:lnSpc>
+                <a:spcPct val="90000"/>
+              </a:lnSpc>
+              <a:spcAft>
+                <a:spcPts val="600"/>
+              </a:spcAft>
+              <a:buFont typeface="Arial" panose="020B0604020202020204" pitchFamily="34" charset="0"/>
+              <a:buChar char="•"/>
+            </a:pPr>
+            <a:r>
+              <a:rPr lang="en-US" sz="1200" dirty="0"/>
+              <a:t>Newly arrived requests join the batch instantly</a:t>
+            </a:r>
+          </a:p>
+          <a:p>
+            <a:pPr indent="-228600">
+              <a:lnSpc>
+                <a:spcPct val="90000"/>
+              </a:lnSpc>
+              <a:spcAft>
+                <a:spcPts val="600"/>
+              </a:spcAft>
+              <a:buFont typeface="Arial" panose="020B0604020202020204" pitchFamily="34" charset="0"/>
+              <a:buChar char="•"/>
+            </a:pPr>
+            <a:r>
+              <a:rPr lang="en-US" sz="1200" dirty="0"/>
+              <a:t>This makes the batch a </a:t>
+            </a:r>
+            <a:r>
+              <a:rPr lang="en-US" sz="1200" b="1" dirty="0"/>
+              <a:t>continuously updating structure</a:t>
+            </a:r>
+            <a:r>
+              <a:rPr lang="en-US" sz="1200" dirty="0"/>
+              <a:t> rather than a fixed one.</a:t>
+            </a:r>
+          </a:p>
+          <a:p>
+            <a:pPr indent="-228600">
+              <a:lnSpc>
+                <a:spcPct val="90000"/>
+              </a:lnSpc>
+              <a:spcAft>
+                <a:spcPts val="600"/>
+              </a:spcAft>
+              <a:buFont typeface="Arial" panose="020B0604020202020204" pitchFamily="34" charset="0"/>
+              <a:buChar char="•"/>
+            </a:pPr>
+            <a:endParaRPr lang="en-US" sz="1200" dirty="0"/>
+          </a:p>
+          <a:p>
+            <a:pPr indent="-228600">
+              <a:lnSpc>
+                <a:spcPct val="90000"/>
+              </a:lnSpc>
+              <a:spcAft>
+                <a:spcPts val="600"/>
+              </a:spcAft>
+              <a:buFont typeface="Arial" panose="020B0604020202020204" pitchFamily="34" charset="0"/>
+              <a:buChar char="•"/>
+            </a:pPr>
+            <a:r>
+              <a:rPr lang="en-US" sz="1200" dirty="0"/>
+              <a:t>This reduces GPU idle time and allows </a:t>
+            </a:r>
+            <a:r>
+              <a:rPr lang="en-US" sz="1200" b="1" dirty="0"/>
+              <a:t>far more requests</a:t>
+            </a:r>
+            <a:r>
+              <a:rPr lang="en-US" sz="1200" dirty="0"/>
+              <a:t> to be processed within the same timeframe. In particular, for environments with many short requests mixed with long ones, user-perceived latency improves dramatically.</a:t>
+            </a:r>
+          </a:p>
+          <a:p>
+            <a:pPr indent="-228600">
+              <a:lnSpc>
+                <a:spcPct val="90000"/>
+              </a:lnSpc>
+              <a:spcAft>
+                <a:spcPts val="600"/>
+              </a:spcAft>
+              <a:buFont typeface="Arial" panose="020B0604020202020204" pitchFamily="34" charset="0"/>
+              <a:buChar char="•"/>
+            </a:pPr>
+            <a:r>
+              <a:rPr lang="en-US" sz="1200" dirty="0"/>
+              <a:t>With:</a:t>
+            </a:r>
+          </a:p>
+          <a:p>
+            <a:pPr indent="-228600">
+              <a:lnSpc>
+                <a:spcPct val="90000"/>
+              </a:lnSpc>
+              <a:spcAft>
+                <a:spcPts val="600"/>
+              </a:spcAft>
+              <a:buFont typeface="Arial" panose="020B0604020202020204" pitchFamily="34" charset="0"/>
+              <a:buChar char="•"/>
+            </a:pPr>
+            <a:endParaRPr lang="en-US" sz="1200" dirty="0"/>
+          </a:p>
+          <a:p>
+            <a:pPr indent="-228600">
+              <a:lnSpc>
+                <a:spcPct val="90000"/>
+              </a:lnSpc>
+              <a:spcAft>
+                <a:spcPts val="600"/>
+              </a:spcAft>
+              <a:buFont typeface="Arial" panose="020B0604020202020204" pitchFamily="34" charset="0"/>
+              <a:buChar char="•"/>
+            </a:pPr>
+            <a:r>
+              <a:rPr lang="en-US" sz="1200" b="1" dirty="0"/>
+              <a:t>Paged Attention → efficient memory use</a:t>
+            </a:r>
+            <a:r>
+              <a:rPr lang="en-US" sz="1200" dirty="0"/>
+              <a:t>, and</a:t>
+            </a:r>
+          </a:p>
+          <a:p>
+            <a:pPr indent="-228600">
+              <a:lnSpc>
+                <a:spcPct val="90000"/>
+              </a:lnSpc>
+              <a:spcAft>
+                <a:spcPts val="600"/>
+              </a:spcAft>
+              <a:buFont typeface="Arial" panose="020B0604020202020204" pitchFamily="34" charset="0"/>
+              <a:buChar char="•"/>
+            </a:pPr>
+            <a:r>
+              <a:rPr lang="en-US" sz="1200" b="1" dirty="0"/>
+              <a:t>Continuous Batching → maximal compute utilization</a:t>
+            </a:r>
+            <a:r>
+              <a:rPr lang="en-US" sz="1200" dirty="0"/>
+              <a:t>,</a:t>
+            </a:r>
+          </a:p>
+          <a:p>
+            <a:pPr indent="-228600">
+              <a:lnSpc>
+                <a:spcPct val="90000"/>
+              </a:lnSpc>
+              <a:spcAft>
+                <a:spcPts val="600"/>
+              </a:spcAft>
+              <a:buFont typeface="Arial" panose="020B0604020202020204" pitchFamily="34" charset="0"/>
+              <a:buChar char="•"/>
+            </a:pPr>
+            <a:endParaRPr lang="en-US" sz="1200" dirty="0"/>
+          </a:p>
+        </p:txBody>
+      </p:sp>
+      <p:pic>
+        <p:nvPicPr>
+          <p:cNvPr id="3" name="Picture 2">
+            <a:extLst>
+              <a:ext uri="{FF2B5EF4-FFF2-40B4-BE49-F238E27FC236}">
+                <a16:creationId xmlns:a16="http://schemas.microsoft.com/office/drawing/2014/main" id="{D835F546-05D8-A20B-0A29-61705D45A394}"/>
+              </a:ext>
+            </a:extLst>
+          </p:cNvPr>
+          <p:cNvPicPr>
+            <a:picLocks noChangeAspect="1"/>
+          </p:cNvPicPr>
+          <p:nvPr/>
+        </p:nvPicPr>
+        <p:blipFill>
+          <a:blip r:embed="rId3"/>
+          <a:stretch>
+            <a:fillRect/>
+          </a:stretch>
+        </p:blipFill>
+        <p:spPr>
+          <a:xfrm>
+            <a:off x="5816600" y="1953330"/>
+            <a:ext cx="5741416" cy="2454456"/>
+          </a:xfrm>
+          <a:prstGeom prst="rect">
+            <a:avLst/>
+          </a:prstGeom>
+        </p:spPr>
+      </p:pic>
+    </p:spTree>
+    <p:extLst>
+      <p:ext uri="{BB962C8B-B14F-4D97-AF65-F5344CB8AC3E}">
+        <p14:creationId xmlns:p14="http://schemas.microsoft.com/office/powerpoint/2010/main" val="2421950582"/>
+      </p:ext>
+    </p:extLst>
+  </p:cSld>
+  <p:clrMapOvr>
+    <a:masterClrMapping/>
+  </p:clrMapOvr>
+</p:sld>
+</file>
+
+<file path=ppt/slides/slide13.xml><?xml version="1.0" encoding="utf-8"?>
+<p:sld xmlns:a="http://schemas.openxmlformats.org/drawingml/2006/main" xmlns:r="http://schemas.openxmlformats.org/officeDocument/2006/relationships" xmlns:p="http://schemas.openxmlformats.org/presentationml/2006/main">
+  <p:cSld>
+    <p:bg>
+      <p:bgPr>
+        <a:solidFill>
+          <a:schemeClr val="bg1"/>
+        </a:solidFill>
+        <a:effectLst/>
+      </p:bgPr>
+    </p:bg>
+    <p:spTree>
+      <p:nvGrpSpPr>
+        <p:cNvPr id="1" name="">
+          <a:extLst>
+            <a:ext uri="{FF2B5EF4-FFF2-40B4-BE49-F238E27FC236}">
+              <a16:creationId xmlns:a16="http://schemas.microsoft.com/office/drawing/2014/main" id="{D8140342-81B1-8651-BE9F-4BEAAACB35A8}"/>
+            </a:ext>
+          </a:extLst>
+        </p:cNvPr>
+        <p:cNvGrpSpPr/>
+        <p:nvPr/>
+      </p:nvGrpSpPr>
+      <p:grpSpPr>
+        <a:xfrm>
+          <a:off x="0" y="0"/>
+          <a:ext cx="0" cy="0"/>
+          <a:chOff x="0" y="0"/>
+          <a:chExt cx="0" cy="0"/>
+        </a:xfrm>
+      </p:grpSpPr>
+      <p:sp useBgFill="1">
+        <p:nvSpPr>
+          <p:cNvPr id="101" name="Rectangle 100">
+            <a:extLst>
+              <a:ext uri="{FF2B5EF4-FFF2-40B4-BE49-F238E27FC236}">
+                <a16:creationId xmlns:a16="http://schemas.microsoft.com/office/drawing/2014/main" id="{BCED4D40-4B67-4331-AC48-79B82B4A47D8}"/>
+              </a:ext>
+              <a:ext uri="{C183D7F6-B498-43B3-948B-1728B52AA6E4}">
+                <adec:decorative xmlns:adec="http://schemas.microsoft.com/office/drawing/2017/decorative" val="1"/>
+              </a:ext>
+            </a:extLst>
+          </p:cNvPr>
+          <p:cNvSpPr>
+            <a:spLocks noGrp="1" noRot="1" noChangeAspect="1" noMove="1" noResize="1" noEditPoints="1" noAdjustHandles="1" noChangeArrowheads="1" noChangeShapeType="1" noTextEdit="1"/>
+          </p:cNvSpPr>
+          <p:nvPr>
+            <p:extLst>
+              <p:ext uri="{386F3935-93C4-4BCD-93E2-E3B085C9AB24}">
+                <p16:designElem xmlns:p16="http://schemas.microsoft.com/office/powerpoint/2015/main" val="1"/>
+              </p:ext>
+            </p:extLst>
+          </p:nvPr>
+        </p:nvSpPr>
+        <p:spPr>
+          <a:xfrm>
+            <a:off x="0" y="0"/>
+            <a:ext cx="12192000" cy="6858000"/>
+          </a:xfrm>
+          <a:prstGeom prst="rect">
+            <a:avLst/>
+          </a:prstGeom>
+          <a:ln>
+            <a:noFill/>
+          </a:ln>
+        </p:spPr>
+        <p:style>
+          <a:lnRef idx="2">
+            <a:schemeClr val="accent1">
+              <a:shade val="50000"/>
+            </a:schemeClr>
+          </a:lnRef>
+          <a:fillRef idx="1">
+            <a:schemeClr val="accent1"/>
+          </a:fillRef>
+          <a:effectRef idx="0">
+            <a:schemeClr val="accent1"/>
+          </a:effectRef>
+          <a:fontRef idx="minor">
+            <a:schemeClr val="lt1"/>
+          </a:fontRef>
+        </p:style>
+        <p:txBody>
+          <a:bodyPr rtlCol="0" anchor="ctr"/>
+          <a:lstStyle/>
+          <a:p>
+            <a:pPr algn="ctr"/>
+            <a:endParaRPr lang="en-US"/>
+          </a:p>
+        </p:txBody>
+      </p:sp>
+      <p:sp>
+        <p:nvSpPr>
+          <p:cNvPr id="2" name="Title 1">
+            <a:extLst>
+              <a:ext uri="{FF2B5EF4-FFF2-40B4-BE49-F238E27FC236}">
+                <a16:creationId xmlns:a16="http://schemas.microsoft.com/office/drawing/2014/main" id="{DE1CBF9E-9FC5-134B-9AAE-546D0131AF9F}"/>
+              </a:ext>
+            </a:extLst>
+          </p:cNvPr>
+          <p:cNvSpPr>
+            <a:spLocks noGrp="1"/>
+          </p:cNvSpPr>
+          <p:nvPr>
+            <p:ph type="title"/>
+          </p:nvPr>
+        </p:nvSpPr>
+        <p:spPr>
+          <a:xfrm>
+            <a:off x="638881" y="417576"/>
+            <a:ext cx="10909640" cy="1249394"/>
+          </a:xfrm>
+        </p:spPr>
+        <p:txBody>
+          <a:bodyPr vert="horz" lIns="91440" tIns="45720" rIns="91440" bIns="45720" rtlCol="0" anchor="ctr">
+            <a:normAutofit/>
+          </a:bodyPr>
+          <a:lstStyle/>
+          <a:p>
+            <a:pPr algn="ctr"/>
+            <a:r>
+              <a:rPr lang="en-US" sz="6600" b="1" kern="1200">
+                <a:solidFill>
+                  <a:schemeClr val="tx1"/>
+                </a:solidFill>
+                <a:latin typeface="+mj-lt"/>
+                <a:ea typeface="+mj-ea"/>
+                <a:cs typeface="+mj-cs"/>
+              </a:rPr>
+              <a:t>Continuous Batching</a:t>
+            </a:r>
+          </a:p>
+        </p:txBody>
+      </p:sp>
+      <p:sp>
+        <p:nvSpPr>
+          <p:cNvPr id="102" name="sketch line">
+            <a:extLst>
+              <a:ext uri="{FF2B5EF4-FFF2-40B4-BE49-F238E27FC236}">
+                <a16:creationId xmlns:a16="http://schemas.microsoft.com/office/drawing/2014/main" id="{670CEDEF-4F34-412E-84EE-329C1E936AF5}"/>
+              </a:ext>
+              <a:ext uri="{C183D7F6-B498-43B3-948B-1728B52AA6E4}">
+                <adec:decorative xmlns:adec="http://schemas.microsoft.com/office/drawing/2017/decorative" val="1"/>
+              </a:ext>
+            </a:extLst>
+          </p:cNvPr>
+          <p:cNvSpPr>
+            <a:spLocks noGrp="1" noRot="1" noChangeAspect="1" noMove="1" noResize="1" noEditPoints="1" noAdjustHandles="1" noChangeArrowheads="1" noChangeShapeType="1" noTextEdit="1"/>
+          </p:cNvSpPr>
+          <p:nvPr>
+            <p:extLst>
+              <p:ext uri="{386F3935-93C4-4BCD-93E2-E3B085C9AB24}">
+                <p16:designElem xmlns:p16="http://schemas.microsoft.com/office/powerpoint/2015/main" val="1"/>
+              </p:ext>
+            </p:extLst>
+          </p:nvPr>
+        </p:nvSpPr>
+        <p:spPr>
+          <a:xfrm>
+            <a:off x="3807702" y="1733454"/>
+            <a:ext cx="4572000" cy="18288"/>
+          </a:xfrm>
+          <a:custGeom>
+            <a:avLst/>
+            <a:gdLst>
+              <a:gd name="csX0" fmla="*/ 0 w 4572000"/>
+              <a:gd name="csY0" fmla="*/ 0 h 18288"/>
+              <a:gd name="csX1" fmla="*/ 515983 w 4572000"/>
+              <a:gd name="csY1" fmla="*/ 0 h 18288"/>
+              <a:gd name="csX2" fmla="*/ 1031966 w 4572000"/>
+              <a:gd name="csY2" fmla="*/ 0 h 18288"/>
+              <a:gd name="csX3" fmla="*/ 1639389 w 4572000"/>
+              <a:gd name="csY3" fmla="*/ 0 h 18288"/>
+              <a:gd name="csX4" fmla="*/ 2383971 w 4572000"/>
+              <a:gd name="csY4" fmla="*/ 0 h 18288"/>
+              <a:gd name="csX5" fmla="*/ 2945674 w 4572000"/>
+              <a:gd name="csY5" fmla="*/ 0 h 18288"/>
+              <a:gd name="csX6" fmla="*/ 3507377 w 4572000"/>
+              <a:gd name="csY6" fmla="*/ 0 h 18288"/>
+              <a:gd name="csX7" fmla="*/ 4572000 w 4572000"/>
+              <a:gd name="csY7" fmla="*/ 0 h 18288"/>
+              <a:gd name="csX8" fmla="*/ 4572000 w 4572000"/>
+              <a:gd name="csY8" fmla="*/ 18288 h 18288"/>
+              <a:gd name="csX9" fmla="*/ 3873137 w 4572000"/>
+              <a:gd name="csY9" fmla="*/ 18288 h 18288"/>
+              <a:gd name="csX10" fmla="*/ 3311434 w 4572000"/>
+              <a:gd name="csY10" fmla="*/ 18288 h 18288"/>
+              <a:gd name="csX11" fmla="*/ 2749731 w 4572000"/>
+              <a:gd name="csY11" fmla="*/ 18288 h 18288"/>
+              <a:gd name="csX12" fmla="*/ 2050869 w 4572000"/>
+              <a:gd name="csY12" fmla="*/ 18288 h 18288"/>
+              <a:gd name="csX13" fmla="*/ 1306286 w 4572000"/>
+              <a:gd name="csY13" fmla="*/ 18288 h 18288"/>
+              <a:gd name="csX14" fmla="*/ 790303 w 4572000"/>
+              <a:gd name="csY14" fmla="*/ 18288 h 18288"/>
+              <a:gd name="csX15" fmla="*/ 0 w 4572000"/>
+              <a:gd name="csY15" fmla="*/ 18288 h 18288"/>
+              <a:gd name="csX16" fmla="*/ 0 w 4572000"/>
+              <a:gd name="csY16" fmla="*/ 0 h 18288"/>
+            </a:gdLst>
+            <a:ahLst/>
+            <a:cxnLst>
+              <a:cxn ang="0">
+                <a:pos x="csX0" y="csY0"/>
+              </a:cxn>
+              <a:cxn ang="0">
+                <a:pos x="csX1" y="csY1"/>
+              </a:cxn>
+              <a:cxn ang="0">
+                <a:pos x="csX2" y="csY2"/>
+              </a:cxn>
+              <a:cxn ang="0">
+                <a:pos x="csX3" y="csY3"/>
+              </a:cxn>
+              <a:cxn ang="0">
+                <a:pos x="csX4" y="csY4"/>
+              </a:cxn>
+              <a:cxn ang="0">
+                <a:pos x="csX5" y="csY5"/>
+              </a:cxn>
+              <a:cxn ang="0">
+                <a:pos x="csX6" y="csY6"/>
+              </a:cxn>
+              <a:cxn ang="0">
+                <a:pos x="csX7" y="csY7"/>
+              </a:cxn>
+              <a:cxn ang="0">
+                <a:pos x="csX8" y="csY8"/>
+              </a:cxn>
+              <a:cxn ang="0">
+                <a:pos x="csX9" y="csY9"/>
+              </a:cxn>
+              <a:cxn ang="0">
+                <a:pos x="csX10" y="csY10"/>
+              </a:cxn>
+              <a:cxn ang="0">
+                <a:pos x="csX11" y="csY11"/>
+              </a:cxn>
+              <a:cxn ang="0">
+                <a:pos x="csX12" y="csY12"/>
+              </a:cxn>
+              <a:cxn ang="0">
+                <a:pos x="csX13" y="csY13"/>
+              </a:cxn>
+              <a:cxn ang="0">
+                <a:pos x="csX14" y="csY14"/>
+              </a:cxn>
+              <a:cxn ang="0">
+                <a:pos x="csX15" y="csY15"/>
+              </a:cxn>
+              <a:cxn ang="0">
+                <a:pos x="csX16" y="csY16"/>
+              </a:cxn>
+            </a:cxnLst>
+            <a:rect l="l" t="t" r="r" b="b"/>
+            <a:pathLst>
+              <a:path w="4572000" h="18288" fill="none" extrusionOk="0">
+                <a:moveTo>
+                  <a:pt x="0" y="0"/>
+                </a:moveTo>
+                <a:cubicBezTo>
+                  <a:pt x="105156" y="-20963"/>
+                  <a:pt x="340432" y="822"/>
+                  <a:pt x="515983" y="0"/>
+                </a:cubicBezTo>
+                <a:cubicBezTo>
+                  <a:pt x="691534" y="-822"/>
+                  <a:pt x="850679" y="16479"/>
+                  <a:pt x="1031966" y="0"/>
+                </a:cubicBezTo>
+                <a:cubicBezTo>
+                  <a:pt x="1213253" y="-16479"/>
+                  <a:pt x="1443646" y="-18730"/>
+                  <a:pt x="1639389" y="0"/>
+                </a:cubicBezTo>
+                <a:cubicBezTo>
+                  <a:pt x="1835132" y="18730"/>
+                  <a:pt x="2159975" y="18531"/>
+                  <a:pt x="2383971" y="0"/>
+                </a:cubicBezTo>
+                <a:cubicBezTo>
+                  <a:pt x="2607967" y="-18531"/>
+                  <a:pt x="2719096" y="-12030"/>
+                  <a:pt x="2945674" y="0"/>
+                </a:cubicBezTo>
+                <a:cubicBezTo>
+                  <a:pt x="3172252" y="12030"/>
+                  <a:pt x="3269167" y="27666"/>
+                  <a:pt x="3507377" y="0"/>
+                </a:cubicBezTo>
+                <a:cubicBezTo>
+                  <a:pt x="3745587" y="-27666"/>
+                  <a:pt x="4116741" y="18705"/>
+                  <a:pt x="4572000" y="0"/>
+                </a:cubicBezTo>
+                <a:cubicBezTo>
+                  <a:pt x="4572895" y="8974"/>
+                  <a:pt x="4571454" y="9359"/>
+                  <a:pt x="4572000" y="18288"/>
+                </a:cubicBezTo>
+                <a:cubicBezTo>
+                  <a:pt x="4374698" y="3942"/>
+                  <a:pt x="4098874" y="-11042"/>
+                  <a:pt x="3873137" y="18288"/>
+                </a:cubicBezTo>
+                <a:cubicBezTo>
+                  <a:pt x="3647400" y="47618"/>
+                  <a:pt x="3517055" y="5421"/>
+                  <a:pt x="3311434" y="18288"/>
+                </a:cubicBezTo>
+                <a:cubicBezTo>
+                  <a:pt x="3105813" y="31155"/>
+                  <a:pt x="3025168" y="17856"/>
+                  <a:pt x="2749731" y="18288"/>
+                </a:cubicBezTo>
+                <a:cubicBezTo>
+                  <a:pt x="2474294" y="18720"/>
+                  <a:pt x="2291766" y="-14168"/>
+                  <a:pt x="2050869" y="18288"/>
+                </a:cubicBezTo>
+                <a:cubicBezTo>
+                  <a:pt x="1809972" y="50744"/>
+                  <a:pt x="1540276" y="46798"/>
+                  <a:pt x="1306286" y="18288"/>
+                </a:cubicBezTo>
+                <a:cubicBezTo>
+                  <a:pt x="1072296" y="-10222"/>
+                  <a:pt x="972445" y="19645"/>
+                  <a:pt x="790303" y="18288"/>
+                </a:cubicBezTo>
+                <a:cubicBezTo>
+                  <a:pt x="608161" y="16931"/>
+                  <a:pt x="200981" y="8241"/>
+                  <a:pt x="0" y="18288"/>
+                </a:cubicBezTo>
+                <a:cubicBezTo>
+                  <a:pt x="-229" y="14222"/>
+                  <a:pt x="509" y="5816"/>
+                  <a:pt x="0" y="0"/>
+                </a:cubicBezTo>
+                <a:close/>
+              </a:path>
+              <a:path w="4572000" h="18288" stroke="0" extrusionOk="0">
+                <a:moveTo>
+                  <a:pt x="0" y="0"/>
+                </a:moveTo>
+                <a:cubicBezTo>
+                  <a:pt x="143285" y="-9565"/>
+                  <a:pt x="327959" y="-11498"/>
+                  <a:pt x="561703" y="0"/>
+                </a:cubicBezTo>
+                <a:cubicBezTo>
+                  <a:pt x="795447" y="11498"/>
+                  <a:pt x="838260" y="18255"/>
+                  <a:pt x="1077686" y="0"/>
+                </a:cubicBezTo>
+                <a:cubicBezTo>
+                  <a:pt x="1317112" y="-18255"/>
+                  <a:pt x="1437472" y="23514"/>
+                  <a:pt x="1639389" y="0"/>
+                </a:cubicBezTo>
+                <a:cubicBezTo>
+                  <a:pt x="1841306" y="-23514"/>
+                  <a:pt x="2037142" y="-12551"/>
+                  <a:pt x="2292531" y="0"/>
+                </a:cubicBezTo>
+                <a:cubicBezTo>
+                  <a:pt x="2547920" y="12551"/>
+                  <a:pt x="2810436" y="-20352"/>
+                  <a:pt x="2991394" y="0"/>
+                </a:cubicBezTo>
+                <a:cubicBezTo>
+                  <a:pt x="3172352" y="20352"/>
+                  <a:pt x="3530025" y="-13347"/>
+                  <a:pt x="3735977" y="0"/>
+                </a:cubicBezTo>
+                <a:cubicBezTo>
+                  <a:pt x="3941929" y="13347"/>
+                  <a:pt x="4161497" y="34086"/>
+                  <a:pt x="4572000" y="0"/>
+                </a:cubicBezTo>
+                <a:cubicBezTo>
+                  <a:pt x="4571545" y="6162"/>
+                  <a:pt x="4571903" y="11775"/>
+                  <a:pt x="4572000" y="18288"/>
+                </a:cubicBezTo>
+                <a:cubicBezTo>
+                  <a:pt x="4228040" y="36490"/>
+                  <a:pt x="4199736" y="42557"/>
+                  <a:pt x="3873137" y="18288"/>
+                </a:cubicBezTo>
+                <a:cubicBezTo>
+                  <a:pt x="3546538" y="-5981"/>
+                  <a:pt x="3472124" y="16809"/>
+                  <a:pt x="3128554" y="18288"/>
+                </a:cubicBezTo>
+                <a:cubicBezTo>
+                  <a:pt x="2784984" y="19767"/>
+                  <a:pt x="2735896" y="-17781"/>
+                  <a:pt x="2383971" y="18288"/>
+                </a:cubicBezTo>
+                <a:cubicBezTo>
+                  <a:pt x="2032046" y="54357"/>
+                  <a:pt x="2019324" y="2920"/>
+                  <a:pt x="1867989" y="18288"/>
+                </a:cubicBezTo>
+                <a:cubicBezTo>
+                  <a:pt x="1716654" y="33656"/>
+                  <a:pt x="1418675" y="32575"/>
+                  <a:pt x="1169126" y="18288"/>
+                </a:cubicBezTo>
+                <a:cubicBezTo>
+                  <a:pt x="919577" y="4001"/>
+                  <a:pt x="798537" y="16165"/>
+                  <a:pt x="561703" y="18288"/>
+                </a:cubicBezTo>
+                <a:cubicBezTo>
+                  <a:pt x="324869" y="20411"/>
+                  <a:pt x="221395" y="-912"/>
+                  <a:pt x="0" y="18288"/>
+                </a:cubicBezTo>
+                <a:cubicBezTo>
+                  <a:pt x="766" y="10800"/>
+                  <a:pt x="-457" y="8180"/>
+                  <a:pt x="0" y="0"/>
+                </a:cubicBezTo>
+                <a:close/>
+              </a:path>
+            </a:pathLst>
+          </a:custGeom>
+          <a:solidFill>
+            <a:schemeClr val="accent2"/>
+          </a:solidFill>
+          <a:ln w="41275" cap="rnd">
+            <a:solidFill>
+              <a:schemeClr val="accent2"/>
+            </a:solidFill>
+            <a:round/>
+            <a:extLst>
+              <a:ext uri="{C807C97D-BFC1-408E-A445-0C87EB9F89A2}">
+                <ask:lineSketchStyleProps xmlns:ask="http://schemas.microsoft.com/office/drawing/2018/sketchyshapes" sd="2727557108">
+                  <a:prstGeom prst="rect">
+                    <a:avLst/>
+                  </a:prstGeom>
+                  <ask:type>
+                    <ask:lineSketchFreehand/>
+                  </ask:type>
+                </ask:lineSketchStyleProps>
+              </a:ext>
+            </a:extLst>
+          </a:ln>
+        </p:spPr>
+        <p:style>
+          <a:lnRef idx="2">
+            <a:schemeClr val="accent1">
+              <a:shade val="50000"/>
+            </a:schemeClr>
+          </a:lnRef>
+          <a:fillRef idx="1">
+            <a:schemeClr val="accent1"/>
+          </a:fillRef>
+          <a:effectRef idx="0">
+            <a:schemeClr val="accent1"/>
+          </a:effectRef>
+          <a:fontRef idx="minor">
+            <a:schemeClr val="lt1"/>
+          </a:fontRef>
+        </p:style>
+        <p:txBody>
+          <a:bodyPr rtlCol="0" anchor="ctr"/>
+          <a:lstStyle/>
+          <a:p>
+            <a:pPr algn="ctr"/>
+            <a:endParaRPr lang="en-US"/>
+          </a:p>
+        </p:txBody>
+      </p:sp>
+      <p:pic>
+        <p:nvPicPr>
+          <p:cNvPr id="4" name="Picture 3">
+            <a:extLst>
+              <a:ext uri="{FF2B5EF4-FFF2-40B4-BE49-F238E27FC236}">
+                <a16:creationId xmlns:a16="http://schemas.microsoft.com/office/drawing/2014/main" id="{E2ACFC46-604D-AE15-3BD3-44429860C148}"/>
+              </a:ext>
+            </a:extLst>
+          </p:cNvPr>
+          <p:cNvPicPr>
+            <a:picLocks noChangeAspect="1"/>
+          </p:cNvPicPr>
+          <p:nvPr/>
+        </p:nvPicPr>
+        <p:blipFill>
+          <a:blip r:embed="rId3"/>
+          <a:stretch>
+            <a:fillRect/>
+          </a:stretch>
+        </p:blipFill>
+        <p:spPr>
+          <a:xfrm>
+            <a:off x="385406" y="1818226"/>
+            <a:ext cx="11421187" cy="4482814"/>
+          </a:xfrm>
+          <a:prstGeom prst="rect">
+            <a:avLst/>
+          </a:prstGeom>
+        </p:spPr>
+      </p:pic>
+    </p:spTree>
+    <p:extLst>
+      <p:ext uri="{BB962C8B-B14F-4D97-AF65-F5344CB8AC3E}">
+        <p14:creationId xmlns:p14="http://schemas.microsoft.com/office/powerpoint/2010/main" val="611591770"/>
+      </p:ext>
+    </p:extLst>
+  </p:cSld>
+  <p:clrMapOvr>
+    <a:masterClrMapping/>
+  </p:clrMapOvr>
+</p:sld>
+</file>
+
 <file path=ppt/slides/slide2.xml><?xml version="1.0" encoding="utf-8"?>
 <p:sld xmlns:a="http://schemas.openxmlformats.org/drawingml/2006/main" xmlns:r="http://schemas.openxmlformats.org/officeDocument/2006/relationships" xmlns:p="http://schemas.openxmlformats.org/presentationml/2006/main">
   <p:cSld>
@@ -7572,7 +10277,7 @@
           <a:lstStyle/>
           <a:p>
             <a:r>
-              <a:rPr lang="en-IN" sz="1400"/>
+              <a:rPr lang="en-IN" sz="1400" dirty="0"/>
               <a:t>For each token in a sequence, at each Transformer layer, the model computes:</a:t>
             </a:r>
           </a:p>
@@ -7583,11 +10288,11 @@
               </a:spcBef>
             </a:pPr>
             <a:r>
-              <a:rPr lang="en-IN" sz="1400" b="1"/>
+              <a:rPr lang="en-IN" sz="1400" b="1" dirty="0"/>
               <a:t>K</a:t>
             </a:r>
             <a:r>
-              <a:rPr lang="en-IN" sz="1400"/>
+              <a:rPr lang="en-IN" sz="1400" dirty="0"/>
               <a:t> (Key vector) — what this token "offers"</a:t>
             </a:r>
           </a:p>
@@ -7598,11 +10303,11 @@
               </a:spcBef>
             </a:pPr>
             <a:r>
-              <a:rPr lang="en-IN" sz="1400" b="1"/>
+              <a:rPr lang="en-IN" sz="1400" b="1" dirty="0"/>
               <a:t>V</a:t>
             </a:r>
             <a:r>
-              <a:rPr lang="en-IN" sz="1400"/>
+              <a:rPr lang="en-IN" sz="1400" dirty="0"/>
               <a:t> (Value vector) — what information this token holds</a:t>
             </a:r>
           </a:p>
@@ -7613,7 +10318,7 @@
               </a:spcBef>
             </a:pPr>
             <a:r>
-              <a:rPr lang="en-IN" sz="1400"/>
+              <a:rPr lang="en-IN" sz="1400" dirty="0"/>
               <a:t>These are stored in GPU memory so they don't need to be recomputed.</a:t>
             </a:r>
           </a:p>
@@ -7624,16 +10329,16 @@
               </a:spcBef>
             </a:pPr>
             <a:r>
-              <a:rPr lang="en-IN" sz="1400"/>
+              <a:rPr lang="en-IN" sz="1400" dirty="0"/>
               <a:t>Sentence: "today we are going to learn"</a:t>
             </a:r>
           </a:p>
           <a:p>
-            <a:endParaRPr lang="en-IN" sz="1400"/>
-          </a:p>
-          <a:p>
-            <a:r>
-              <a:rPr lang="en-IN" sz="1400"/>
+            <a:endParaRPr lang="en-IN" sz="1400" dirty="0"/>
+          </a:p>
+          <a:p>
+            <a:r>
+              <a:rPr lang="en-IN" sz="1400" dirty="0"/>
               <a:t>After prefill, KV Cache contains:</a:t>
             </a:r>
           </a:p>
@@ -7644,7 +10349,7 @@
               </a:spcBef>
             </a:pPr>
             <a:r>
-              <a:rPr lang="en-IN" sz="1400"/>
+              <a:rPr lang="en-IN" sz="1400" dirty="0"/>
               <a:t>  Token 1 "today"   → K1, V1</a:t>
             </a:r>
           </a:p>
@@ -7655,7 +10360,7 @@
               </a:spcBef>
             </a:pPr>
             <a:r>
-              <a:rPr lang="en-IN" sz="1400"/>
+              <a:rPr lang="en-IN" sz="1400" dirty="0"/>
               <a:t>  Token 2 "we"      → K2, V2</a:t>
             </a:r>
           </a:p>
@@ -7666,7 +10371,7 @@
               </a:spcBef>
             </a:pPr>
             <a:r>
-              <a:rPr lang="en-IN" sz="1400"/>
+              <a:rPr lang="en-IN" sz="1400" dirty="0"/>
               <a:t>  Token 3 "are"     → K3, V3</a:t>
             </a:r>
           </a:p>
@@ -7677,7 +10382,7 @@
               </a:spcBef>
             </a:pPr>
             <a:r>
-              <a:rPr lang="en-IN" sz="1400"/>
+              <a:rPr lang="en-IN" sz="1400" dirty="0"/>
               <a:t>  Token 4 "going"   → K4, V4</a:t>
             </a:r>
           </a:p>
@@ -7688,7 +10393,7 @@
               </a:spcBef>
             </a:pPr>
             <a:r>
-              <a:rPr lang="en-IN" sz="1400"/>
+              <a:rPr lang="en-IN" sz="1400" dirty="0"/>
               <a:t>  Token 5 "to"      → K5, V5</a:t>
             </a:r>
           </a:p>
@@ -7699,14 +10404,14 @@
               </a:spcBef>
             </a:pPr>
             <a:r>
-              <a:rPr lang="en-IN" sz="1400"/>
+              <a:rPr lang="en-IN" sz="1400" dirty="0"/>
               <a:t>  Token 6 "learn"   → K6, V6</a:t>
             </a:r>
           </a:p>
           <a:p>
             <a:r>
-              <a:rPr lang="en-IN" sz="1400"/>
-              <a:t>During decode, when the model generates token 7 (e.g., "machine"), it only computes K7, V7 and attends over the cached K1–K6.</a:t>
+              <a:rPr lang="en-IN" sz="1400" dirty="0"/>
+              <a:t>During decode, when the model generates token 7 (e.g., ”model"), it only computes K7, V7 and attends over the cached K1–K6.</a:t>
             </a:r>
           </a:p>
           <a:p>

</xml_diff>